<commit_message>
all-slides-with-answers.pdf all-slides.pdf exceptions.pdf exceptions.pptx
</commit_message>
<xml_diff>
--- a/ipsa/slides/exceptions.pptx
+++ b/ipsa/slides/exceptions.pptx
@@ -147,7 +147,7 @@
 <file path=ppt/revisionInfo.xml><?xml version="1.0" encoding="utf-8"?>
 <p1510:revInfo xmlns:a="http://schemas.openxmlformats.org/drawingml/2006/main" xmlns:r="http://schemas.openxmlformats.org/officeDocument/2006/relationships" xmlns:p1510="http://schemas.microsoft.com/office/powerpoint/2015/10/main">
   <p1510:revLst>
-    <p1510:client id="{9F458CB3-E497-4EBE-93FC-6326415FF9FB}" v="5" dt="2025-03-12T07:34:22.221"/>
+    <p1510:client id="{E38F93A8-4FA1-49BC-B109-DD14B9BCDAB8}" v="3" dt="2026-03-09T05:33:46.945"/>
   </p1510:revLst>
 </p1510:revInfo>
 </file>
@@ -155,439 +155,66 @@
 <file path=ppt/changesInfos/changesInfo1.xml><?xml version="1.0" encoding="utf-8"?>
 <pc:chgInfo xmlns:a="http://schemas.openxmlformats.org/drawingml/2006/main" xmlns:r="http://schemas.openxmlformats.org/officeDocument/2006/relationships" xmlns:ac="http://schemas.microsoft.com/office/drawing/2013/main/command" xmlns:pc="http://schemas.microsoft.com/office/powerpoint/2013/main/command">
   <pc:docChgLst>
-    <pc:chgData name="Gerth Stølting Brodal" userId="04ef4784-6591-4f86-a140-f5c3b108582a" providerId="ADAL" clId="{9F458CB3-E497-4EBE-93FC-6326415FF9FB}"/>
+    <pc:chgData name="Gerth Stølting Brodal" userId="04ef4784-6591-4f86-a140-f5c3b108582a" providerId="ADAL" clId="{73BAC7D6-516A-44B5-B4B0-C7B08CA8B392}"/>
     <pc:docChg chg="undo custSel modSld">
-      <pc:chgData name="Gerth Stølting Brodal" userId="04ef4784-6591-4f86-a140-f5c3b108582a" providerId="ADAL" clId="{9F458CB3-E497-4EBE-93FC-6326415FF9FB}" dt="2025-03-12T07:34:46.944" v="146" actId="20577"/>
-      <pc:docMkLst>
-        <pc:docMk/>
-      </pc:docMkLst>
-      <pc:sldChg chg="modSp mod modNotesTx">
-        <pc:chgData name="Gerth Stølting Brodal" userId="04ef4784-6591-4f86-a140-f5c3b108582a" providerId="ADAL" clId="{9F458CB3-E497-4EBE-93FC-6326415FF9FB}" dt="2025-03-10T06:59:00.692" v="85" actId="20577"/>
-        <pc:sldMkLst>
-          <pc:docMk/>
-          <pc:sldMk cId="1654434957" sldId="704"/>
-        </pc:sldMkLst>
-        <pc:graphicFrameChg chg="mod modGraphic">
-          <ac:chgData name="Gerth Stølting Brodal" userId="04ef4784-6591-4f86-a140-f5c3b108582a" providerId="ADAL" clId="{9F458CB3-E497-4EBE-93FC-6326415FF9FB}" dt="2025-03-10T06:57:54.728" v="17" actId="20577"/>
-          <ac:graphicFrameMkLst>
-            <pc:docMk/>
-            <pc:sldMk cId="1654434957" sldId="704"/>
-            <ac:graphicFrameMk id="4" creationId="{00000000-0000-0000-0000-000000000000}"/>
-          </ac:graphicFrameMkLst>
-        </pc:graphicFrameChg>
-      </pc:sldChg>
-      <pc:sldChg chg="modSp mod">
-        <pc:chgData name="Gerth Stølting Brodal" userId="04ef4784-6591-4f86-a140-f5c3b108582a" providerId="ADAL" clId="{9F458CB3-E497-4EBE-93FC-6326415FF9FB}" dt="2025-03-12T07:34:46.944" v="146" actId="20577"/>
-        <pc:sldMkLst>
-          <pc:docMk/>
-          <pc:sldMk cId="928740216" sldId="729"/>
-        </pc:sldMkLst>
-        <pc:graphicFrameChg chg="mod modGraphic">
-          <ac:chgData name="Gerth Stølting Brodal" userId="04ef4784-6591-4f86-a140-f5c3b108582a" providerId="ADAL" clId="{9F458CB3-E497-4EBE-93FC-6326415FF9FB}" dt="2025-03-12T07:34:46.944" v="146" actId="20577"/>
-          <ac:graphicFrameMkLst>
-            <pc:docMk/>
-            <pc:sldMk cId="928740216" sldId="729"/>
-            <ac:graphicFrameMk id="4" creationId="{00000000-0000-0000-0000-000000000000}"/>
-          </ac:graphicFrameMkLst>
-        </pc:graphicFrameChg>
-      </pc:sldChg>
-    </pc:docChg>
-  </pc:docChgLst>
-  <pc:docChgLst>
-    <pc:chgData name="Gerth Stølting Brodal" userId="04ef4784-6591-4f86-a140-f5c3b108582a" providerId="ADAL" clId="{0375A3B1-3E85-4265-A3F4-D5A88847E856}"/>
-    <pc:docChg chg="undo custSel addSld delSld modSld">
-      <pc:chgData name="Gerth Stølting Brodal" userId="04ef4784-6591-4f86-a140-f5c3b108582a" providerId="ADAL" clId="{0375A3B1-3E85-4265-A3F4-D5A88847E856}" dt="2024-03-10T20:09:27.833" v="325" actId="20577"/>
+      <pc:chgData name="Gerth Stølting Brodal" userId="04ef4784-6591-4f86-a140-f5c3b108582a" providerId="ADAL" clId="{73BAC7D6-516A-44B5-B4B0-C7B08CA8B392}" dt="2026-03-09T06:25:56.526" v="307" actId="20577"/>
       <pc:docMkLst>
         <pc:docMk/>
       </pc:docMkLst>
       <pc:sldChg chg="modSp mod">
-        <pc:chgData name="Gerth Stølting Brodal" userId="04ef4784-6591-4f86-a140-f5c3b108582a" providerId="ADAL" clId="{0375A3B1-3E85-4265-A3F4-D5A88847E856}" dt="2024-03-10T19:30:51.971" v="35" actId="20577"/>
+        <pc:chgData name="Gerth Stølting Brodal" userId="04ef4784-6591-4f86-a140-f5c3b108582a" providerId="ADAL" clId="{73BAC7D6-516A-44B5-B4B0-C7B08CA8B392}" dt="2026-03-09T05:33:46.993" v="22" actId="27636"/>
         <pc:sldMkLst>
           <pc:docMk/>
           <pc:sldMk cId="1038163257" sldId="475"/>
         </pc:sldMkLst>
-      </pc:sldChg>
-      <pc:sldChg chg="modSp mod">
-        <pc:chgData name="Gerth Stølting Brodal" userId="04ef4784-6591-4f86-a140-f5c3b108582a" providerId="ADAL" clId="{0375A3B1-3E85-4265-A3F4-D5A88847E856}" dt="2024-03-10T19:43:50.086" v="38" actId="114"/>
-        <pc:sldMkLst>
-          <pc:docMk/>
-          <pc:sldMk cId="4179205861" sldId="512"/>
-        </pc:sldMkLst>
+        <pc:spChg chg="mod">
+          <ac:chgData name="Gerth Stølting Brodal" userId="04ef4784-6591-4f86-a140-f5c3b108582a" providerId="ADAL" clId="{73BAC7D6-516A-44B5-B4B0-C7B08CA8B392}" dt="2026-03-09T05:33:46.993" v="22" actId="27636"/>
+          <ac:spMkLst>
+            <pc:docMk/>
+            <pc:sldMk cId="1038163257" sldId="475"/>
+            <ac:spMk id="3" creationId="{00000000-0000-0000-0000-000000000000}"/>
+          </ac:spMkLst>
+        </pc:spChg>
       </pc:sldChg>
       <pc:sldChg chg="modNotesTx">
-        <pc:chgData name="Gerth Stølting Brodal" userId="04ef4784-6591-4f86-a140-f5c3b108582a" providerId="ADAL" clId="{0375A3B1-3E85-4265-A3F4-D5A88847E856}" dt="2024-03-10T20:09:27.833" v="325" actId="20577"/>
-        <pc:sldMkLst>
-          <pc:docMk/>
-          <pc:sldMk cId="1330004482" sldId="708"/>
-        </pc:sldMkLst>
-      </pc:sldChg>
-      <pc:sldChg chg="modNotesTx">
-        <pc:chgData name="Gerth Stølting Brodal" userId="04ef4784-6591-4f86-a140-f5c3b108582a" providerId="ADAL" clId="{0375A3B1-3E85-4265-A3F4-D5A88847E856}" dt="2024-03-10T20:01:51.254" v="252" actId="113"/>
-        <pc:sldMkLst>
-          <pc:docMk/>
-          <pc:sldMk cId="366870384" sldId="712"/>
-        </pc:sldMkLst>
-      </pc:sldChg>
-      <pc:sldChg chg="modSp mod">
-        <pc:chgData name="Gerth Stølting Brodal" userId="04ef4784-6591-4f86-a140-f5c3b108582a" providerId="ADAL" clId="{0375A3B1-3E85-4265-A3F4-D5A88847E856}" dt="2024-03-10T19:44:01.842" v="40" actId="114"/>
-        <pc:sldMkLst>
-          <pc:docMk/>
-          <pc:sldMk cId="926288180" sldId="716"/>
-        </pc:sldMkLst>
-      </pc:sldChg>
-      <pc:sldChg chg="modSp mod">
-        <pc:chgData name="Gerth Stølting Brodal" userId="04ef4784-6591-4f86-a140-f5c3b108582a" providerId="ADAL" clId="{0375A3B1-3E85-4265-A3F4-D5A88847E856}" dt="2024-03-10T19:50:19.213" v="108" actId="27636"/>
-        <pc:sldMkLst>
-          <pc:docMk/>
-          <pc:sldMk cId="3997418003" sldId="718"/>
-        </pc:sldMkLst>
-      </pc:sldChg>
-      <pc:sldChg chg="modSp mod">
-        <pc:chgData name="Gerth Stølting Brodal" userId="04ef4784-6591-4f86-a140-f5c3b108582a" providerId="ADAL" clId="{0375A3B1-3E85-4265-A3F4-D5A88847E856}" dt="2024-03-10T20:03:09.351" v="258"/>
-        <pc:sldMkLst>
-          <pc:docMk/>
-          <pc:sldMk cId="3379938229" sldId="720"/>
-        </pc:sldMkLst>
-      </pc:sldChg>
-      <pc:sldChg chg="add">
-        <pc:chgData name="Gerth Stølting Brodal" userId="04ef4784-6591-4f86-a140-f5c3b108582a" providerId="ADAL" clId="{0375A3B1-3E85-4265-A3F4-D5A88847E856}" dt="2024-03-10T19:32:20.737" v="37"/>
-        <pc:sldMkLst>
-          <pc:docMk/>
-          <pc:sldMk cId="2645871161" sldId="728"/>
-        </pc:sldMkLst>
-      </pc:sldChg>
-      <pc:sldChg chg="del">
-        <pc:chgData name="Gerth Stølting Brodal" userId="04ef4784-6591-4f86-a140-f5c3b108582a" providerId="ADAL" clId="{0375A3B1-3E85-4265-A3F4-D5A88847E856}" dt="2024-03-10T19:32:13.847" v="36" actId="2696"/>
-        <pc:sldMkLst>
-          <pc:docMk/>
-          <pc:sldMk cId="2802748937" sldId="728"/>
-        </pc:sldMkLst>
-      </pc:sldChg>
-      <pc:sldChg chg="add">
-        <pc:chgData name="Gerth Stølting Brodal" userId="04ef4784-6591-4f86-a140-f5c3b108582a" providerId="ADAL" clId="{0375A3B1-3E85-4265-A3F4-D5A88847E856}" dt="2024-03-10T19:32:20.737" v="37"/>
-        <pc:sldMkLst>
-          <pc:docMk/>
-          <pc:sldMk cId="928740216" sldId="729"/>
-        </pc:sldMkLst>
-      </pc:sldChg>
-      <pc:sldChg chg="del">
-        <pc:chgData name="Gerth Stølting Brodal" userId="04ef4784-6591-4f86-a140-f5c3b108582a" providerId="ADAL" clId="{0375A3B1-3E85-4265-A3F4-D5A88847E856}" dt="2024-03-10T19:32:13.847" v="36" actId="2696"/>
-        <pc:sldMkLst>
-          <pc:docMk/>
-          <pc:sldMk cId="1881171177" sldId="729"/>
-        </pc:sldMkLst>
-      </pc:sldChg>
-      <pc:sldChg chg="del">
-        <pc:chgData name="Gerth Stølting Brodal" userId="04ef4784-6591-4f86-a140-f5c3b108582a" providerId="ADAL" clId="{0375A3B1-3E85-4265-A3F4-D5A88847E856}" dt="2024-03-10T19:32:13.847" v="36" actId="2696"/>
-        <pc:sldMkLst>
-          <pc:docMk/>
-          <pc:sldMk cId="4113973945" sldId="730"/>
-        </pc:sldMkLst>
-      </pc:sldChg>
-      <pc:sldChg chg="add">
-        <pc:chgData name="Gerth Stølting Brodal" userId="04ef4784-6591-4f86-a140-f5c3b108582a" providerId="ADAL" clId="{0375A3B1-3E85-4265-A3F4-D5A88847E856}" dt="2024-03-10T19:32:20.737" v="37"/>
-        <pc:sldMkLst>
-          <pc:docMk/>
-          <pc:sldMk cId="4197840191" sldId="730"/>
-        </pc:sldMkLst>
-      </pc:sldChg>
-    </pc:docChg>
-  </pc:docChgLst>
-  <pc:docChgLst>
-    <pc:chgData name="Gerth Stølting Brodal" userId="04ef4784-6591-4f86-a140-f5c3b108582a" providerId="ADAL" clId="{D404FE24-4761-49EE-88D6-CDB48199D24C}"/>
-    <pc:docChg chg="undo redo custSel addSld delSld modSld">
-      <pc:chgData name="Gerth Stølting Brodal" userId="04ef4784-6591-4f86-a140-f5c3b108582a" providerId="ADAL" clId="{D404FE24-4761-49EE-88D6-CDB48199D24C}" dt="2023-03-13T10:16:49.555" v="1671" actId="207"/>
-      <pc:docMkLst>
-        <pc:docMk/>
-      </pc:docMkLst>
-      <pc:sldChg chg="modSp mod">
-        <pc:chgData name="Gerth Stølting Brodal" userId="04ef4784-6591-4f86-a140-f5c3b108582a" providerId="ADAL" clId="{D404FE24-4761-49EE-88D6-CDB48199D24C}" dt="2023-03-12T19:37:18.915" v="306" actId="20577"/>
-        <pc:sldMkLst>
-          <pc:docMk/>
-          <pc:sldMk cId="4179205861" sldId="512"/>
-        </pc:sldMkLst>
-      </pc:sldChg>
-      <pc:sldChg chg="modSp mod modNotesTx">
-        <pc:chgData name="Gerth Stølting Brodal" userId="04ef4784-6591-4f86-a140-f5c3b108582a" providerId="ADAL" clId="{D404FE24-4761-49EE-88D6-CDB48199D24C}" dt="2023-03-12T19:26:49.058" v="255" actId="20577"/>
-        <pc:sldMkLst>
-          <pc:docMk/>
-          <pc:sldMk cId="1160923753" sldId="702"/>
-        </pc:sldMkLst>
-      </pc:sldChg>
-      <pc:sldChg chg="modSp mod modNotesTx">
-        <pc:chgData name="Gerth Stølting Brodal" userId="04ef4784-6591-4f86-a140-f5c3b108582a" providerId="ADAL" clId="{D404FE24-4761-49EE-88D6-CDB48199D24C}" dt="2023-03-12T19:30:54.668" v="304" actId="20577"/>
+        <pc:chgData name="Gerth Stølting Brodal" userId="04ef4784-6591-4f86-a140-f5c3b108582a" providerId="ADAL" clId="{73BAC7D6-516A-44B5-B4B0-C7B08CA8B392}" dt="2026-03-09T05:24:28.008" v="0" actId="20577"/>
         <pc:sldMkLst>
           <pc:docMk/>
           <pc:sldMk cId="1654434957" sldId="704"/>
         </pc:sldMkLst>
       </pc:sldChg>
-      <pc:sldChg chg="modSp mod">
-        <pc:chgData name="Gerth Stølting Brodal" userId="04ef4784-6591-4f86-a140-f5c3b108582a" providerId="ADAL" clId="{D404FE24-4761-49EE-88D6-CDB48199D24C}" dt="2023-03-10T22:35:46.730" v="15" actId="20577"/>
-        <pc:sldMkLst>
-          <pc:docMk/>
-          <pc:sldMk cId="2005488815" sldId="705"/>
-        </pc:sldMkLst>
-      </pc:sldChg>
-      <pc:sldChg chg="modSp mod">
-        <pc:chgData name="Gerth Stølting Brodal" userId="04ef4784-6591-4f86-a140-f5c3b108582a" providerId="ADAL" clId="{D404FE24-4761-49EE-88D6-CDB48199D24C}" dt="2023-03-10T22:35:57.196" v="19" actId="20577"/>
-        <pc:sldMkLst>
-          <pc:docMk/>
-          <pc:sldMk cId="2852041830" sldId="706"/>
-        </pc:sldMkLst>
-      </pc:sldChg>
-      <pc:sldChg chg="modSp mod">
-        <pc:chgData name="Gerth Stølting Brodal" userId="04ef4784-6591-4f86-a140-f5c3b108582a" providerId="ADAL" clId="{D404FE24-4761-49EE-88D6-CDB48199D24C}" dt="2023-03-10T23:31:38.787" v="170" actId="20577"/>
-        <pc:sldMkLst>
-          <pc:docMk/>
-          <pc:sldMk cId="753419617" sldId="707"/>
-        </pc:sldMkLst>
-      </pc:sldChg>
-      <pc:sldChg chg="modSp mod">
-        <pc:chgData name="Gerth Stølting Brodal" userId="04ef4784-6591-4f86-a140-f5c3b108582a" providerId="ADAL" clId="{D404FE24-4761-49EE-88D6-CDB48199D24C}" dt="2023-03-12T21:29:55.297" v="1645" actId="113"/>
-        <pc:sldMkLst>
-          <pc:docMk/>
-          <pc:sldMk cId="1330004482" sldId="708"/>
-        </pc:sldMkLst>
-      </pc:sldChg>
-      <pc:sldChg chg="modSp mod">
-        <pc:chgData name="Gerth Stølting Brodal" userId="04ef4784-6591-4f86-a140-f5c3b108582a" providerId="ADAL" clId="{D404FE24-4761-49EE-88D6-CDB48199D24C}" dt="2023-03-12T21:21:45.658" v="1611" actId="14100"/>
-        <pc:sldMkLst>
-          <pc:docMk/>
-          <pc:sldMk cId="1202853326" sldId="709"/>
-        </pc:sldMkLst>
-      </pc:sldChg>
-      <pc:sldChg chg="modSp mod">
-        <pc:chgData name="Gerth Stølting Brodal" userId="04ef4784-6591-4f86-a140-f5c3b108582a" providerId="ADAL" clId="{D404FE24-4761-49EE-88D6-CDB48199D24C}" dt="2023-03-12T20:42:21.741" v="1241" actId="20577"/>
-        <pc:sldMkLst>
-          <pc:docMk/>
-          <pc:sldMk cId="1043759414" sldId="710"/>
-        </pc:sldMkLst>
-      </pc:sldChg>
-      <pc:sldChg chg="addSp modSp mod modNotesTx">
-        <pc:chgData name="Gerth Stølting Brodal" userId="04ef4784-6591-4f86-a140-f5c3b108582a" providerId="ADAL" clId="{D404FE24-4761-49EE-88D6-CDB48199D24C}" dt="2023-03-12T21:29:50.671" v="1644" actId="113"/>
-        <pc:sldMkLst>
-          <pc:docMk/>
-          <pc:sldMk cId="2905942797" sldId="711"/>
-        </pc:sldMkLst>
-      </pc:sldChg>
-      <pc:sldChg chg="modSp mod">
-        <pc:chgData name="Gerth Stølting Brodal" userId="04ef4784-6591-4f86-a140-f5c3b108582a" providerId="ADAL" clId="{D404FE24-4761-49EE-88D6-CDB48199D24C}" dt="2023-03-12T20:16:13.095" v="918" actId="20577"/>
-        <pc:sldMkLst>
-          <pc:docMk/>
-          <pc:sldMk cId="366870384" sldId="712"/>
-        </pc:sldMkLst>
-      </pc:sldChg>
-      <pc:sldChg chg="modNotesTx">
-        <pc:chgData name="Gerth Stølting Brodal" userId="04ef4784-6591-4f86-a140-f5c3b108582a" providerId="ADAL" clId="{D404FE24-4761-49EE-88D6-CDB48199D24C}" dt="2023-03-12T19:59:24.670" v="651" actId="113"/>
-        <pc:sldMkLst>
-          <pc:docMk/>
-          <pc:sldMk cId="2166775173" sldId="714"/>
-        </pc:sldMkLst>
-      </pc:sldChg>
       <pc:sldChg chg="modSp mod modNotesTx">
-        <pc:chgData name="Gerth Stølting Brodal" userId="04ef4784-6591-4f86-a140-f5c3b108582a" providerId="ADAL" clId="{D404FE24-4761-49EE-88D6-CDB48199D24C}" dt="2023-03-12T19:45:05.394" v="551" actId="20577"/>
-        <pc:sldMkLst>
-          <pc:docMk/>
-          <pc:sldMk cId="2015921638" sldId="715"/>
-        </pc:sldMkLst>
-      </pc:sldChg>
-      <pc:sldChg chg="modSp mod">
-        <pc:chgData name="Gerth Stølting Brodal" userId="04ef4784-6591-4f86-a140-f5c3b108582a" providerId="ADAL" clId="{D404FE24-4761-49EE-88D6-CDB48199D24C}" dt="2023-03-12T19:37:34.556" v="311" actId="20577"/>
+        <pc:chgData name="Gerth Stølting Brodal" userId="04ef4784-6591-4f86-a140-f5c3b108582a" providerId="ADAL" clId="{73BAC7D6-516A-44B5-B4B0-C7B08CA8B392}" dt="2026-03-09T05:52:17.894" v="71" actId="313"/>
         <pc:sldMkLst>
           <pc:docMk/>
           <pc:sldMk cId="926288180" sldId="716"/>
         </pc:sldMkLst>
+        <pc:spChg chg="ord">
+          <ac:chgData name="Gerth Stølting Brodal" userId="04ef4784-6591-4f86-a140-f5c3b108582a" providerId="ADAL" clId="{73BAC7D6-516A-44B5-B4B0-C7B08CA8B392}" dt="2026-03-09T05:51:13.007" v="23" actId="167"/>
+          <ac:spMkLst>
+            <pc:docMk/>
+            <pc:sldMk cId="926288180" sldId="716"/>
+            <ac:spMk id="7" creationId="{00000000-0000-0000-0000-000000000000}"/>
+          </ac:spMkLst>
+        </pc:spChg>
       </pc:sldChg>
-      <pc:sldChg chg="modSp mod">
-        <pc:chgData name="Gerth Stølting Brodal" userId="04ef4784-6591-4f86-a140-f5c3b108582a" providerId="ADAL" clId="{D404FE24-4761-49EE-88D6-CDB48199D24C}" dt="2023-03-12T22:12:54.872" v="1662" actId="6549"/>
+      <pc:sldChg chg="modSp mod modNotesTx">
+        <pc:chgData name="Gerth Stølting Brodal" userId="04ef4784-6591-4f86-a140-f5c3b108582a" providerId="ADAL" clId="{73BAC7D6-516A-44B5-B4B0-C7B08CA8B392}" dt="2026-03-09T06:20:40.585" v="217" actId="20577"/>
         <pc:sldMkLst>
           <pc:docMk/>
-          <pc:sldMk cId="2205391547" sldId="717"/>
+          <pc:sldMk cId="3037496381" sldId="721"/>
         </pc:sldMkLst>
+        <pc:spChg chg="mod">
+          <ac:chgData name="Gerth Stølting Brodal" userId="04ef4784-6591-4f86-a140-f5c3b108582a" providerId="ADAL" clId="{73BAC7D6-516A-44B5-B4B0-C7B08CA8B392}" dt="2026-03-09T06:17:49.938" v="73" actId="20577"/>
+          <ac:spMkLst>
+            <pc:docMk/>
+            <pc:sldMk cId="3037496381" sldId="721"/>
+            <ac:spMk id="3" creationId="{00000000-0000-0000-0000-000000000000}"/>
+          </ac:spMkLst>
+        </pc:spChg>
       </pc:sldChg>
       <pc:sldChg chg="modNotesTx">
-        <pc:chgData name="Gerth Stølting Brodal" userId="04ef4784-6591-4f86-a140-f5c3b108582a" providerId="ADAL" clId="{D404FE24-4761-49EE-88D6-CDB48199D24C}" dt="2023-03-12T20:02:04.267" v="704" actId="20577"/>
-        <pc:sldMkLst>
-          <pc:docMk/>
-          <pc:sldMk cId="3997418003" sldId="718"/>
-        </pc:sldMkLst>
-      </pc:sldChg>
-      <pc:sldChg chg="modSp mod modNotesTx">
-        <pc:chgData name="Gerth Stølting Brodal" userId="04ef4784-6591-4f86-a140-f5c3b108582a" providerId="ADAL" clId="{D404FE24-4761-49EE-88D6-CDB48199D24C}" dt="2023-03-12T20:40:42.885" v="1217" actId="113"/>
-        <pc:sldMkLst>
-          <pc:docMk/>
-          <pc:sldMk cId="3379938229" sldId="720"/>
-        </pc:sldMkLst>
-      </pc:sldChg>
-      <pc:sldChg chg="modSp mod">
-        <pc:chgData name="Gerth Stølting Brodal" userId="04ef4784-6591-4f86-a140-f5c3b108582a" providerId="ADAL" clId="{D404FE24-4761-49EE-88D6-CDB48199D24C}" dt="2023-03-10T22:36:19.416" v="33" actId="20577"/>
-        <pc:sldMkLst>
-          <pc:docMk/>
-          <pc:sldMk cId="1515186800" sldId="722"/>
-        </pc:sldMkLst>
-      </pc:sldChg>
-      <pc:sldChg chg="modSp mod">
-        <pc:chgData name="Gerth Stølting Brodal" userId="04ef4784-6591-4f86-a140-f5c3b108582a" providerId="ADAL" clId="{D404FE24-4761-49EE-88D6-CDB48199D24C}" dt="2023-03-10T23:29:47.864" v="161" actId="20577"/>
-        <pc:sldMkLst>
-          <pc:docMk/>
-          <pc:sldMk cId="4063920540" sldId="723"/>
-        </pc:sldMkLst>
-      </pc:sldChg>
-      <pc:sldChg chg="modSp mod">
-        <pc:chgData name="Gerth Stølting Brodal" userId="04ef4784-6591-4f86-a140-f5c3b108582a" providerId="ADAL" clId="{D404FE24-4761-49EE-88D6-CDB48199D24C}" dt="2023-03-10T23:12:17.890" v="148" actId="14100"/>
-        <pc:sldMkLst>
-          <pc:docMk/>
-          <pc:sldMk cId="1799338885" sldId="726"/>
-        </pc:sldMkLst>
-      </pc:sldChg>
-      <pc:sldChg chg="modSp mod modNotesTx">
-        <pc:chgData name="Gerth Stølting Brodal" userId="04ef4784-6591-4f86-a140-f5c3b108582a" providerId="ADAL" clId="{D404FE24-4761-49EE-88D6-CDB48199D24C}" dt="2023-03-13T10:16:49.555" v="1671" actId="207"/>
-        <pc:sldMkLst>
-          <pc:docMk/>
-          <pc:sldMk cId="3983956302" sldId="727"/>
-        </pc:sldMkLst>
-      </pc:sldChg>
-      <pc:sldChg chg="modSp mod">
-        <pc:chgData name="Gerth Stølting Brodal" userId="04ef4784-6591-4f86-a140-f5c3b108582a" providerId="ADAL" clId="{D404FE24-4761-49EE-88D6-CDB48199D24C}" dt="2023-03-12T21:29:22.136" v="1639" actId="2711"/>
-        <pc:sldMkLst>
-          <pc:docMk/>
-          <pc:sldMk cId="2802748937" sldId="728"/>
-        </pc:sldMkLst>
-      </pc:sldChg>
-      <pc:sldChg chg="modSp mod">
-        <pc:chgData name="Gerth Stølting Brodal" userId="04ef4784-6591-4f86-a140-f5c3b108582a" providerId="ADAL" clId="{D404FE24-4761-49EE-88D6-CDB48199D24C}" dt="2023-03-13T10:12:02.216" v="1670" actId="20577"/>
-        <pc:sldMkLst>
-          <pc:docMk/>
-          <pc:sldMk cId="1881171177" sldId="729"/>
-        </pc:sldMkLst>
-      </pc:sldChg>
-      <pc:sldChg chg="modSp mod modNotesTx">
-        <pc:chgData name="Gerth Stølting Brodal" userId="04ef4784-6591-4f86-a140-f5c3b108582a" providerId="ADAL" clId="{D404FE24-4761-49EE-88D6-CDB48199D24C}" dt="2023-03-13T10:11:51.777" v="1666" actId="20577"/>
-        <pc:sldMkLst>
-          <pc:docMk/>
-          <pc:sldMk cId="4113973945" sldId="730"/>
-        </pc:sldMkLst>
-      </pc:sldChg>
-      <pc:sldChg chg="new del">
-        <pc:chgData name="Gerth Stølting Brodal" userId="04ef4784-6591-4f86-a140-f5c3b108582a" providerId="ADAL" clId="{D404FE24-4761-49EE-88D6-CDB48199D24C}" dt="2023-03-12T21:00:11.882" v="1346" actId="680"/>
-        <pc:sldMkLst>
-          <pc:docMk/>
-          <pc:sldMk cId="3009592961" sldId="731"/>
-        </pc:sldMkLst>
-      </pc:sldChg>
-    </pc:docChg>
-  </pc:docChgLst>
-  <pc:docChgLst>
-    <pc:chgData name="Gerth Stølting Brodal" userId="04ef4784-6591-4f86-a140-f5c3b108582a" providerId="ADAL" clId="{64F0C171-2853-4A0E-8891-02A0F99F3D95}"/>
-    <pc:docChg chg="undo custSel modSld">
-      <pc:chgData name="Gerth Stølting Brodal" userId="04ef4784-6591-4f86-a140-f5c3b108582a" providerId="ADAL" clId="{64F0C171-2853-4A0E-8891-02A0F99F3D95}" dt="2021-03-09T11:50:49.674" v="190" actId="478"/>
-      <pc:docMkLst>
-        <pc:docMk/>
-      </pc:docMkLst>
-      <pc:sldChg chg="modSp mod">
-        <pc:chgData name="Gerth Stølting Brodal" userId="04ef4784-6591-4f86-a140-f5c3b108582a" providerId="ADAL" clId="{64F0C171-2853-4A0E-8891-02A0F99F3D95}" dt="2021-03-09T11:27:14.088" v="3" actId="20577"/>
-        <pc:sldMkLst>
-          <pc:docMk/>
-          <pc:sldMk cId="366870384" sldId="712"/>
-        </pc:sldMkLst>
-      </pc:sldChg>
-      <pc:sldChg chg="modSp mod">
-        <pc:chgData name="Gerth Stølting Brodal" userId="04ef4784-6591-4f86-a140-f5c3b108582a" providerId="ADAL" clId="{64F0C171-2853-4A0E-8891-02A0F99F3D95}" dt="2021-03-09T11:36:46.481" v="57" actId="20577"/>
-        <pc:sldMkLst>
-          <pc:docMk/>
-          <pc:sldMk cId="2205391547" sldId="717"/>
-        </pc:sldMkLst>
-      </pc:sldChg>
-      <pc:sldChg chg="modNotesTx">
-        <pc:chgData name="Gerth Stølting Brodal" userId="04ef4784-6591-4f86-a140-f5c3b108582a" providerId="ADAL" clId="{64F0C171-2853-4A0E-8891-02A0F99F3D95}" dt="2021-03-09T11:31:55.752" v="44" actId="313"/>
-        <pc:sldMkLst>
-          <pc:docMk/>
-          <pc:sldMk cId="3379938229" sldId="720"/>
-        </pc:sldMkLst>
-      </pc:sldChg>
-      <pc:sldChg chg="delSp mod modNotesTx">
-        <pc:chgData name="Gerth Stølting Brodal" userId="04ef4784-6591-4f86-a140-f5c3b108582a" providerId="ADAL" clId="{64F0C171-2853-4A0E-8891-02A0F99F3D95}" dt="2021-03-09T11:50:49.674" v="190" actId="478"/>
-        <pc:sldMkLst>
-          <pc:docMk/>
-          <pc:sldMk cId="4063920540" sldId="723"/>
-        </pc:sldMkLst>
-      </pc:sldChg>
-    </pc:docChg>
-  </pc:docChgLst>
-  <pc:docChgLst>
-    <pc:chgData name="Gerth Stølting Brodal" userId="04ef4784-6591-4f86-a140-f5c3b108582a" providerId="ADAL" clId="{4C2C2F4D-D6A3-49A4-83F7-63FF82F121FE}"/>
-    <pc:docChg chg="undo redo custSel addSld delSld modSld">
-      <pc:chgData name="Gerth Stølting Brodal" userId="04ef4784-6591-4f86-a140-f5c3b108582a" providerId="ADAL" clId="{4C2C2F4D-D6A3-49A4-83F7-63FF82F121FE}" dt="2022-03-14T07:56:44.945" v="1227" actId="20577"/>
-      <pc:docMkLst>
-        <pc:docMk/>
-      </pc:docMkLst>
-      <pc:sldChg chg="modSp mod">
-        <pc:chgData name="Gerth Stølting Brodal" userId="04ef4784-6591-4f86-a140-f5c3b108582a" providerId="ADAL" clId="{4C2C2F4D-D6A3-49A4-83F7-63FF82F121FE}" dt="2022-03-13T16:02:54.566" v="1226" actId="20577"/>
-        <pc:sldMkLst>
-          <pc:docMk/>
-          <pc:sldMk cId="1038163257" sldId="475"/>
-        </pc:sldMkLst>
-      </pc:sldChg>
-      <pc:sldChg chg="modSp mod">
-        <pc:chgData name="Gerth Stølting Brodal" userId="04ef4784-6591-4f86-a140-f5c3b108582a" providerId="ADAL" clId="{4C2C2F4D-D6A3-49A4-83F7-63FF82F121FE}" dt="2022-03-10T16:14:57.165" v="0" actId="6549"/>
-        <pc:sldMkLst>
-          <pc:docMk/>
-          <pc:sldMk cId="1202853326" sldId="709"/>
-        </pc:sldMkLst>
-      </pc:sldChg>
-      <pc:sldChg chg="del">
-        <pc:chgData name="Gerth Stølting Brodal" userId="04ef4784-6591-4f86-a140-f5c3b108582a" providerId="ADAL" clId="{4C2C2F4D-D6A3-49A4-83F7-63FF82F121FE}" dt="2022-03-10T18:54:51.728" v="1" actId="47"/>
-        <pc:sldMkLst>
-          <pc:docMk/>
-          <pc:sldMk cId="3434329423" sldId="725"/>
-        </pc:sldMkLst>
-      </pc:sldChg>
-      <pc:sldChg chg="addSp delSp modSp add mod">
-        <pc:chgData name="Gerth Stølting Brodal" userId="04ef4784-6591-4f86-a140-f5c3b108582a" providerId="ADAL" clId="{4C2C2F4D-D6A3-49A4-83F7-63FF82F121FE}" dt="2022-03-14T07:56:44.945" v="1227" actId="20577"/>
-        <pc:sldMkLst>
-          <pc:docMk/>
-          <pc:sldMk cId="2802748937" sldId="728"/>
-        </pc:sldMkLst>
-      </pc:sldChg>
-      <pc:sldChg chg="addSp delSp modSp add mod">
-        <pc:chgData name="Gerth Stølting Brodal" userId="04ef4784-6591-4f86-a140-f5c3b108582a" providerId="ADAL" clId="{4C2C2F4D-D6A3-49A4-83F7-63FF82F121FE}" dt="2022-03-10T19:59:49.061" v="1203" actId="14100"/>
-        <pc:sldMkLst>
-          <pc:docMk/>
-          <pc:sldMk cId="1881171177" sldId="729"/>
-        </pc:sldMkLst>
-      </pc:sldChg>
-      <pc:sldChg chg="addSp delSp modSp new mod">
-        <pc:chgData name="Gerth Stølting Brodal" userId="04ef4784-6591-4f86-a140-f5c3b108582a" providerId="ADAL" clId="{4C2C2F4D-D6A3-49A4-83F7-63FF82F121FE}" dt="2022-03-10T19:58:44.375" v="1199" actId="20577"/>
-        <pc:sldMkLst>
-          <pc:docMk/>
-          <pc:sldMk cId="4113973945" sldId="730"/>
-        </pc:sldMkLst>
-      </pc:sldChg>
-    </pc:docChg>
-  </pc:docChgLst>
-  <pc:docChgLst>
-    <pc:chgData name="Gerth Stølting Brodal" userId="04ef4784-6591-4f86-a140-f5c3b108582a" providerId="ADAL" clId="{A6A9A378-5A9C-494E-9AFF-D5467651EA49}"/>
-    <pc:docChg chg="undo redo custSel addSld modSld sldOrd">
-      <pc:chgData name="Gerth Stølting Brodal" userId="04ef4784-6591-4f86-a140-f5c3b108582a" providerId="ADAL" clId="{A6A9A378-5A9C-494E-9AFF-D5467651EA49}" dt="2024-11-20T09:38:35.006" v="1025" actId="20577"/>
-      <pc:docMkLst>
-        <pc:docMk/>
-      </pc:docMkLst>
-      <pc:sldChg chg="modSp mod">
-        <pc:chgData name="Gerth Stølting Brodal" userId="04ef4784-6591-4f86-a140-f5c3b108582a" providerId="ADAL" clId="{A6A9A378-5A9C-494E-9AFF-D5467651EA49}" dt="2024-11-20T08:09:51.304" v="45" actId="20577"/>
-        <pc:sldMkLst>
-          <pc:docMk/>
-          <pc:sldMk cId="2905942797" sldId="711"/>
-        </pc:sldMkLst>
-      </pc:sldChg>
-      <pc:sldChg chg="ord">
-        <pc:chgData name="Gerth Stølting Brodal" userId="04ef4784-6591-4f86-a140-f5c3b108582a" providerId="ADAL" clId="{A6A9A378-5A9C-494E-9AFF-D5467651EA49}" dt="2024-11-20T08:09:32.368" v="41"/>
-        <pc:sldMkLst>
-          <pc:docMk/>
-          <pc:sldMk cId="2205391547" sldId="717"/>
-        </pc:sldMkLst>
-      </pc:sldChg>
-      <pc:sldChg chg="addSp delSp modSp add mod ord modNotesTx">
-        <pc:chgData name="Gerth Stølting Brodal" userId="04ef4784-6591-4f86-a140-f5c3b108582a" providerId="ADAL" clId="{A6A9A378-5A9C-494E-9AFF-D5467651EA49}" dt="2024-11-20T09:38:35.006" v="1025" actId="20577"/>
+        <pc:chgData name="Gerth Stølting Brodal" userId="04ef4784-6591-4f86-a140-f5c3b108582a" providerId="ADAL" clId="{73BAC7D6-516A-44B5-B4B0-C7B08CA8B392}" dt="2026-03-09T06:25:56.526" v="307" actId="20577"/>
         <pc:sldMkLst>
           <pc:docMk/>
           <pc:sldMk cId="1833727466" sldId="731"/>
@@ -680,7 +307,7 @@
           <a:p>
             <a:fld id="{FB1A172F-81D4-4DC4-9113-1DBD56EC3646}" type="datetimeFigureOut">
               <a:rPr lang="en-US" smtClean="0"/>
-              <a:t>3/12/2025</a:t>
+              <a:t>3/9/2026</a:t>
             </a:fld>
             <a:endParaRPr lang="en-US"/>
           </a:p>
@@ -1077,35 +704,16 @@
           <a:p>
             <a:r>
               <a:rPr lang="en-US" dirty="0"/>
-              <a:t>A is an abstract class (seen earlier), where g has not been implemented (but it is, it just raises an </a:t>
-            </a:r>
-            <a:r>
-              <a:rPr lang="en-US" dirty="0" err="1"/>
-              <a:t>NotImplementedError</a:t>
+              <a:t>In the 3</a:t>
+            </a:r>
+            <a:r>
+              <a:rPr lang="en-US" baseline="30000" dirty="0"/>
+              <a:t>rd</a:t>
             </a:r>
             <a:r>
               <a:rPr lang="en-US" dirty="0"/>
-              <a:t> exception when called).</a:t>
-            </a:r>
-          </a:p>
-          <a:p>
-            <a:endParaRPr lang="en-US" dirty="0"/>
-          </a:p>
-          <a:p>
-            <a:r>
-              <a:rPr lang="en-US" dirty="0"/>
-              <a:t>Without the default g we would get </a:t>
-            </a:r>
-            <a:r>
-              <a:rPr lang="en-US" b="1" dirty="0" err="1"/>
-              <a:t>AttributeError</a:t>
-            </a:r>
-            <a:r>
-              <a:rPr lang="en-US" b="1" dirty="0"/>
-              <a:t>: 'A' object has no attribute 'g'</a:t>
-            </a:r>
-          </a:p>
-          <a:p>
+              <a:t> case the parenthesis cannot be omitted!</a:t>
+            </a:r>
             <a:endParaRPr lang="da-DK" dirty="0"/>
           </a:p>
         </p:txBody>
@@ -1127,7 +735,7 @@
           <a:p>
             <a:fld id="{CD563DD8-32AB-41BE-B1C6-8EAC45222ACE}" type="slidenum">
               <a:rPr lang="en-US" smtClean="0"/>
-              <a:t>15</a:t>
+              <a:t>14</a:t>
             </a:fld>
             <a:endParaRPr lang="en-US"/>
           </a:p>
@@ -1136,7 +744,7 @@
     </p:spTree>
     <p:extLst>
       <p:ext uri="{BB962C8B-B14F-4D97-AF65-F5344CB8AC3E}">
-        <p14:creationId xmlns:p14="http://schemas.microsoft.com/office/powerpoint/2010/main" val="4138969287"/>
+        <p14:creationId xmlns:p14="http://schemas.microsoft.com/office/powerpoint/2010/main" val="1957294039"/>
       </p:ext>
     </p:extLst>
   </p:cSld>
@@ -1191,69 +799,37 @@
           <a:lstStyle/>
           <a:p>
             <a:r>
-              <a:rPr lang="da-DK" dirty="0" err="1"/>
-              <a:t>Example</a:t>
-            </a:r>
-            <a:r>
-              <a:rPr lang="da-DK" dirty="0"/>
-              <a:t> of </a:t>
-            </a:r>
-            <a:r>
-              <a:rPr lang="da-DK" dirty="0" err="1"/>
-              <a:t>how</a:t>
-            </a:r>
-            <a:r>
-              <a:rPr lang="da-DK" dirty="0"/>
-              <a:t> to </a:t>
-            </a:r>
-            <a:r>
-              <a:rPr lang="da-DK" dirty="0" err="1"/>
-              <a:t>use</a:t>
-            </a:r>
-            <a:r>
-              <a:rPr lang="da-DK" dirty="0"/>
-              <a:t> a user </a:t>
-            </a:r>
-            <a:r>
-              <a:rPr lang="da-DK" dirty="0" err="1"/>
-              <a:t>defined</a:t>
-            </a:r>
-            <a:r>
-              <a:rPr lang="da-DK" dirty="0"/>
-              <a:t> </a:t>
-            </a:r>
-            <a:r>
-              <a:rPr lang="da-DK" dirty="0" err="1"/>
-              <a:t>exception</a:t>
-            </a:r>
-            <a:r>
-              <a:rPr lang="da-DK" dirty="0"/>
-              <a:t> to break out of a </a:t>
-            </a:r>
-            <a:r>
-              <a:rPr lang="da-DK" dirty="0" err="1"/>
-              <a:t>recursive</a:t>
-            </a:r>
-            <a:r>
-              <a:rPr lang="da-DK" dirty="0"/>
-              <a:t> </a:t>
-            </a:r>
-            <a:r>
-              <a:rPr lang="da-DK" dirty="0" err="1"/>
-              <a:t>function</a:t>
-            </a:r>
-            <a:r>
-              <a:rPr lang="da-DK" dirty="0"/>
-              <a:t> – </a:t>
-            </a:r>
-            <a:r>
-              <a:rPr lang="da-DK" b="1" dirty="0" err="1"/>
-              <a:t>control</a:t>
-            </a:r>
-            <a:r>
-              <a:rPr lang="da-DK" b="1" dirty="0"/>
-              <a:t> flow</a:t>
-            </a:r>
+              <a:rPr lang="en-US" dirty="0"/>
+              <a:t>A is an abstract class (seen earlier), where g has not been implemented (but it is, it just raises an </a:t>
+            </a:r>
+            <a:r>
+              <a:rPr lang="en-US" dirty="0" err="1"/>
+              <a:t>NotImplementedError</a:t>
+            </a:r>
+            <a:r>
+              <a:rPr lang="en-US" dirty="0"/>
+              <a:t> exception when called).</a:t>
+            </a:r>
+          </a:p>
+          <a:p>
+            <a:endParaRPr lang="en-US" dirty="0"/>
+          </a:p>
+          <a:p>
+            <a:r>
+              <a:rPr lang="en-US" dirty="0"/>
+              <a:t>Without the default g we would get </a:t>
+            </a:r>
+            <a:r>
+              <a:rPr lang="en-US" b="1" dirty="0" err="1"/>
+              <a:t>AttributeError</a:t>
+            </a:r>
+            <a:r>
+              <a:rPr lang="en-US" b="1" dirty="0"/>
+              <a:t>: 'A' object has no attribute 'g'</a:t>
+            </a:r>
+          </a:p>
+          <a:p>
+            <a:endParaRPr lang="da-DK" dirty="0"/>
           </a:p>
         </p:txBody>
       </p:sp>
@@ -1274,7 +850,7 @@
           <a:p>
             <a:fld id="{CD563DD8-32AB-41BE-B1C6-8EAC45222ACE}" type="slidenum">
               <a:rPr lang="en-US" smtClean="0"/>
-              <a:t>16</a:t>
+              <a:t>15</a:t>
             </a:fld>
             <a:endParaRPr lang="en-US"/>
           </a:p>
@@ -1283,7 +859,7 @@
     </p:spTree>
     <p:extLst>
       <p:ext uri="{BB962C8B-B14F-4D97-AF65-F5344CB8AC3E}">
-        <p14:creationId xmlns:p14="http://schemas.microsoft.com/office/powerpoint/2010/main" val="736236924"/>
+        <p14:creationId xmlns:p14="http://schemas.microsoft.com/office/powerpoint/2010/main" val="4138969287"/>
       </p:ext>
     </p:extLst>
   </p:cSld>
@@ -1338,12 +914,68 @@
           <a:lstStyle/>
           <a:p>
             <a:r>
-              <a:rPr lang="en-US" dirty="0"/>
-              <a:t>The lines read contains a ‘\n’ at the end, so we avoid printing two newlines by setting </a:t>
-            </a:r>
-            <a:r>
-              <a:rPr lang="en-US" b="1" dirty="0"/>
-              <a:t>end=‘’</a:t>
+              <a:rPr lang="da-DK" dirty="0" err="1"/>
+              <a:t>Example</a:t>
+            </a:r>
+            <a:r>
+              <a:rPr lang="da-DK" dirty="0"/>
+              <a:t> of </a:t>
+            </a:r>
+            <a:r>
+              <a:rPr lang="da-DK" dirty="0" err="1"/>
+              <a:t>how</a:t>
+            </a:r>
+            <a:r>
+              <a:rPr lang="da-DK" dirty="0"/>
+              <a:t> to </a:t>
+            </a:r>
+            <a:r>
+              <a:rPr lang="da-DK" dirty="0" err="1"/>
+              <a:t>use</a:t>
+            </a:r>
+            <a:r>
+              <a:rPr lang="da-DK" dirty="0"/>
+              <a:t> a user </a:t>
+            </a:r>
+            <a:r>
+              <a:rPr lang="da-DK" dirty="0" err="1"/>
+              <a:t>defined</a:t>
+            </a:r>
+            <a:r>
+              <a:rPr lang="da-DK" dirty="0"/>
+              <a:t> </a:t>
+            </a:r>
+            <a:r>
+              <a:rPr lang="da-DK" dirty="0" err="1"/>
+              <a:t>exception</a:t>
+            </a:r>
+            <a:r>
+              <a:rPr lang="da-DK" dirty="0"/>
+              <a:t> to break out of a </a:t>
+            </a:r>
+            <a:r>
+              <a:rPr lang="da-DK" dirty="0" err="1"/>
+              <a:t>recursive</a:t>
+            </a:r>
+            <a:r>
+              <a:rPr lang="da-DK" dirty="0"/>
+              <a:t> </a:t>
+            </a:r>
+            <a:r>
+              <a:rPr lang="da-DK" dirty="0" err="1"/>
+              <a:t>function</a:t>
+            </a:r>
+            <a:r>
+              <a:rPr lang="da-DK" dirty="0"/>
+              <a:t> – </a:t>
+            </a:r>
+            <a:r>
+              <a:rPr lang="da-DK" b="1" dirty="0" err="1"/>
+              <a:t>control</a:t>
+            </a:r>
+            <a:r>
+              <a:rPr lang="da-DK" b="1" dirty="0"/>
+              <a:t> flow</a:t>
             </a:r>
           </a:p>
         </p:txBody>
@@ -1365,7 +997,7 @@
           <a:p>
             <a:fld id="{CD563DD8-32AB-41BE-B1C6-8EAC45222ACE}" type="slidenum">
               <a:rPr lang="en-US" smtClean="0"/>
-              <a:t>18</a:t>
+              <a:t>16</a:t>
             </a:fld>
             <a:endParaRPr lang="en-US"/>
           </a:p>
@@ -1374,7 +1006,7 @@
     </p:spTree>
     <p:extLst>
       <p:ext uri="{BB962C8B-B14F-4D97-AF65-F5344CB8AC3E}">
-        <p14:creationId xmlns:p14="http://schemas.microsoft.com/office/powerpoint/2010/main" val="2093793768"/>
+        <p14:creationId xmlns:p14="http://schemas.microsoft.com/office/powerpoint/2010/main" val="736236924"/>
       </p:ext>
     </p:extLst>
   </p:cSld>
@@ -1429,22 +1061,13 @@
           <a:lstStyle/>
           <a:p>
             <a:r>
+              <a:rPr lang="en-US" dirty="0"/>
+              <a:t>The lines read contains a ‘\n’ at the end, so we avoid printing two newlines by setting </a:t>
+            </a:r>
+            <a:r>
               <a:rPr lang="en-US" b="1" dirty="0"/>
-              <a:t>with</a:t>
-            </a:r>
-            <a:r>
-              <a:rPr lang="en-US" dirty="0"/>
-              <a:t> wraps code in </a:t>
-            </a:r>
-            <a:r>
-              <a:rPr lang="en-US" b="1" dirty="0"/>
-              <a:t>try-except-else</a:t>
-            </a:r>
-            <a:r>
-              <a:rPr lang="en-US" dirty="0"/>
-              <a:t> both calling __exit__. If an exception happens __exit__ is given this exception and can react on it or just ignore it and let it propagate.</a:t>
-            </a:r>
-            <a:endParaRPr lang="da-DK" dirty="0"/>
+              <a:t>end=‘’</a:t>
+            </a:r>
           </a:p>
         </p:txBody>
       </p:sp>
@@ -1465,7 +1088,7 @@
           <a:p>
             <a:fld id="{CD563DD8-32AB-41BE-B1C6-8EAC45222ACE}" type="slidenum">
               <a:rPr lang="en-US" smtClean="0"/>
-              <a:t>21</a:t>
+              <a:t>18</a:t>
             </a:fld>
             <a:endParaRPr lang="en-US"/>
           </a:p>
@@ -1474,7 +1097,7 @@
     </p:spTree>
     <p:extLst>
       <p:ext uri="{BB962C8B-B14F-4D97-AF65-F5344CB8AC3E}">
-        <p14:creationId xmlns:p14="http://schemas.microsoft.com/office/powerpoint/2010/main" val="2379714696"/>
+        <p14:creationId xmlns:p14="http://schemas.microsoft.com/office/powerpoint/2010/main" val="2093793768"/>
       </p:ext>
     </p:extLst>
   </p:cSld>
@@ -1529,6 +1152,193 @@
           <a:lstStyle/>
           <a:p>
             <a:r>
+              <a:rPr lang="en-US" dirty="0"/>
+              <a:t>print allows multiple arguments and converts to string (whereas write requires the argument to be a string)</a:t>
+            </a:r>
+          </a:p>
+        </p:txBody>
+      </p:sp>
+      <p:sp>
+        <p:nvSpPr>
+          <p:cNvPr id="4" name="Slide Number Placeholder 3"/>
+          <p:cNvSpPr>
+            <a:spLocks noGrp="1"/>
+          </p:cNvSpPr>
+          <p:nvPr>
+            <p:ph type="sldNum" sz="quarter" idx="5"/>
+          </p:nvPr>
+        </p:nvSpPr>
+        <p:spPr/>
+        <p:txBody>
+          <a:bodyPr/>
+          <a:lstStyle/>
+          <a:p>
+            <a:fld id="{CD563DD8-32AB-41BE-B1C6-8EAC45222ACE}" type="slidenum">
+              <a:rPr lang="en-US" smtClean="0"/>
+              <a:t>19</a:t>
+            </a:fld>
+            <a:endParaRPr lang="en-US"/>
+          </a:p>
+        </p:txBody>
+      </p:sp>
+    </p:spTree>
+    <p:extLst>
+      <p:ext uri="{BB962C8B-B14F-4D97-AF65-F5344CB8AC3E}">
+        <p14:creationId xmlns:p14="http://schemas.microsoft.com/office/powerpoint/2010/main" val="1446544177"/>
+      </p:ext>
+    </p:extLst>
+  </p:cSld>
+  <p:clrMapOvr>
+    <a:masterClrMapping/>
+  </p:clrMapOvr>
+</p:notes>
+</file>
+
+<file path=ppt/notesSlides/notesSlide15.xml><?xml version="1.0" encoding="utf-8"?>
+<p:notes xmlns:a="http://schemas.openxmlformats.org/drawingml/2006/main" xmlns:r="http://schemas.openxmlformats.org/officeDocument/2006/relationships" xmlns:p="http://schemas.openxmlformats.org/presentationml/2006/main">
+  <p:cSld>
+    <p:spTree>
+      <p:nvGrpSpPr>
+        <p:cNvPr id="1" name=""/>
+        <p:cNvGrpSpPr/>
+        <p:nvPr/>
+      </p:nvGrpSpPr>
+      <p:grpSpPr>
+        <a:xfrm>
+          <a:off x="0" y="0"/>
+          <a:ext cx="0" cy="0"/>
+          <a:chOff x="0" y="0"/>
+          <a:chExt cx="0" cy="0"/>
+        </a:xfrm>
+      </p:grpSpPr>
+      <p:sp>
+        <p:nvSpPr>
+          <p:cNvPr id="2" name="Slide Image Placeholder 1"/>
+          <p:cNvSpPr>
+            <a:spLocks noGrp="1" noRot="1" noChangeAspect="1"/>
+          </p:cNvSpPr>
+          <p:nvPr>
+            <p:ph type="sldImg"/>
+          </p:nvPr>
+        </p:nvSpPr>
+        <p:spPr/>
+      </p:sp>
+      <p:sp>
+        <p:nvSpPr>
+          <p:cNvPr id="3" name="Notes Placeholder 2"/>
+          <p:cNvSpPr>
+            <a:spLocks noGrp="1"/>
+          </p:cNvSpPr>
+          <p:nvPr>
+            <p:ph type="body" idx="1"/>
+          </p:nvPr>
+        </p:nvSpPr>
+        <p:spPr/>
+        <p:txBody>
+          <a:bodyPr/>
+          <a:lstStyle/>
+          <a:p>
+            <a:r>
+              <a:rPr lang="en-US" b="1" dirty="0"/>
+              <a:t>with</a:t>
+            </a:r>
+            <a:r>
+              <a:rPr lang="en-US" dirty="0"/>
+              <a:t> wraps code in </a:t>
+            </a:r>
+            <a:r>
+              <a:rPr lang="en-US" b="1" dirty="0"/>
+              <a:t>try-except-else</a:t>
+            </a:r>
+            <a:r>
+              <a:rPr lang="en-US" dirty="0"/>
+              <a:t> both calling __exit__. If an exception happens __exit__ is given this exception and can react on it or just ignore it and let it propagate.</a:t>
+            </a:r>
+            <a:endParaRPr lang="da-DK" dirty="0"/>
+          </a:p>
+        </p:txBody>
+      </p:sp>
+      <p:sp>
+        <p:nvSpPr>
+          <p:cNvPr id="4" name="Slide Number Placeholder 3"/>
+          <p:cNvSpPr>
+            <a:spLocks noGrp="1"/>
+          </p:cNvSpPr>
+          <p:nvPr>
+            <p:ph type="sldNum" sz="quarter" idx="5"/>
+          </p:nvPr>
+        </p:nvSpPr>
+        <p:spPr/>
+        <p:txBody>
+          <a:bodyPr/>
+          <a:lstStyle/>
+          <a:p>
+            <a:fld id="{CD563DD8-32AB-41BE-B1C6-8EAC45222ACE}" type="slidenum">
+              <a:rPr lang="en-US" smtClean="0"/>
+              <a:t>21</a:t>
+            </a:fld>
+            <a:endParaRPr lang="en-US"/>
+          </a:p>
+        </p:txBody>
+      </p:sp>
+    </p:spTree>
+    <p:extLst>
+      <p:ext uri="{BB962C8B-B14F-4D97-AF65-F5344CB8AC3E}">
+        <p14:creationId xmlns:p14="http://schemas.microsoft.com/office/powerpoint/2010/main" val="2379714696"/>
+      </p:ext>
+    </p:extLst>
+  </p:cSld>
+  <p:clrMapOvr>
+    <a:masterClrMapping/>
+  </p:clrMapOvr>
+</p:notes>
+</file>
+
+<file path=ppt/notesSlides/notesSlide16.xml><?xml version="1.0" encoding="utf-8"?>
+<p:notes xmlns:a="http://schemas.openxmlformats.org/drawingml/2006/main" xmlns:r="http://schemas.openxmlformats.org/officeDocument/2006/relationships" xmlns:p="http://schemas.openxmlformats.org/presentationml/2006/main">
+  <p:cSld>
+    <p:spTree>
+      <p:nvGrpSpPr>
+        <p:cNvPr id="1" name=""/>
+        <p:cNvGrpSpPr/>
+        <p:nvPr/>
+      </p:nvGrpSpPr>
+      <p:grpSpPr>
+        <a:xfrm>
+          <a:off x="0" y="0"/>
+          <a:ext cx="0" cy="0"/>
+          <a:chOff x="0" y="0"/>
+          <a:chExt cx="0" cy="0"/>
+        </a:xfrm>
+      </p:grpSpPr>
+      <p:sp>
+        <p:nvSpPr>
+          <p:cNvPr id="2" name="Slide Image Placeholder 1"/>
+          <p:cNvSpPr>
+            <a:spLocks noGrp="1" noRot="1" noChangeAspect="1"/>
+          </p:cNvSpPr>
+          <p:nvPr>
+            <p:ph type="sldImg"/>
+          </p:nvPr>
+        </p:nvSpPr>
+        <p:spPr/>
+      </p:sp>
+      <p:sp>
+        <p:nvSpPr>
+          <p:cNvPr id="3" name="Notes Placeholder 2"/>
+          <p:cNvSpPr>
+            <a:spLocks noGrp="1"/>
+          </p:cNvSpPr>
+          <p:nvPr>
+            <p:ph type="body" idx="1"/>
+          </p:nvPr>
+        </p:nvSpPr>
+        <p:spPr/>
+        <p:txBody>
+          <a:bodyPr/>
+          <a:lstStyle/>
+          <a:p>
+            <a:r>
               <a:rPr lang="da-DK" b="1" dirty="0" err="1"/>
               <a:t>help</a:t>
             </a:r>
@@ -1600,7 +1410,7 @@
 </p:notes>
 </file>
 
-<file path=ppt/notesSlides/notesSlide15.xml><?xml version="1.0" encoding="utf-8"?>
+<file path=ppt/notesSlides/notesSlide17.xml><?xml version="1.0" encoding="utf-8"?>
 <p:notes xmlns:a="http://schemas.openxmlformats.org/drawingml/2006/main" xmlns:r="http://schemas.openxmlformats.org/officeDocument/2006/relationships" xmlns:p="http://schemas.openxmlformats.org/presentationml/2006/main">
   <p:cSld>
     <p:spTree>
@@ -1686,13 +1496,8 @@
             </a:r>
             <a:r>
               <a:rPr lang="en-US" dirty="0"/>
-              <a:t> avoids dictionary lookup in module and </a:t>
-            </a:r>
-            <a:r>
-              <a:rPr lang="en-US"/>
-              <a:t>file object</a:t>
-            </a:r>
-            <a:endParaRPr lang="en-US" dirty="0"/>
+              <a:t> avoids dictionary lookup in module and file object</a:t>
+            </a:r>
           </a:p>
           <a:p>
             <a:r>
@@ -1707,6 +1512,17 @@
               <a:rPr lang="en-US" dirty="0"/>
               <a:t> does not split input to multiple lines</a:t>
             </a:r>
+          </a:p>
+          <a:p>
+            <a:r>
+              <a:rPr lang="en-US" dirty="0"/>
+              <a:t>.read reads the full string into memory (can be </a:t>
+            </a:r>
+            <a:r>
+              <a:rPr lang="en-US"/>
+              <a:t>a problem for huge files)</a:t>
+            </a:r>
+            <a:endParaRPr lang="en-US" dirty="0"/>
           </a:p>
         </p:txBody>
       </p:sp>
@@ -1743,295 +1559,6 @@
     <p:extLst>
       <p:ext uri="{BB962C8B-B14F-4D97-AF65-F5344CB8AC3E}">
         <p14:creationId xmlns:p14="http://schemas.microsoft.com/office/powerpoint/2010/main" val="2989633617"/>
-      </p:ext>
-    </p:extLst>
-  </p:cSld>
-  <p:clrMapOvr>
-    <a:masterClrMapping/>
-  </p:clrMapOvr>
-</p:notes>
-</file>
-
-<file path=ppt/notesSlides/notesSlide16.xml><?xml version="1.0" encoding="utf-8"?>
-<p:notes xmlns:a="http://schemas.openxmlformats.org/drawingml/2006/main" xmlns:r="http://schemas.openxmlformats.org/officeDocument/2006/relationships" xmlns:p="http://schemas.openxmlformats.org/presentationml/2006/main">
-  <p:cSld>
-    <p:spTree>
-      <p:nvGrpSpPr>
-        <p:cNvPr id="1" name=""/>
-        <p:cNvGrpSpPr/>
-        <p:nvPr/>
-      </p:nvGrpSpPr>
-      <p:grpSpPr>
-        <a:xfrm>
-          <a:off x="0" y="0"/>
-          <a:ext cx="0" cy="0"/>
-          <a:chOff x="0" y="0"/>
-          <a:chExt cx="0" cy="0"/>
-        </a:xfrm>
-      </p:grpSpPr>
-      <p:sp>
-        <p:nvSpPr>
-          <p:cNvPr id="2" name="Slide Image Placeholder 1"/>
-          <p:cNvSpPr>
-            <a:spLocks noGrp="1" noRot="1" noChangeAspect="1"/>
-          </p:cNvSpPr>
-          <p:nvPr>
-            <p:ph type="sldImg"/>
-          </p:nvPr>
-        </p:nvSpPr>
-        <p:spPr/>
-      </p:sp>
-      <p:sp>
-        <p:nvSpPr>
-          <p:cNvPr id="3" name="Notes Placeholder 2"/>
-          <p:cNvSpPr>
-            <a:spLocks noGrp="1"/>
-          </p:cNvSpPr>
-          <p:nvPr>
-            <p:ph type="body" idx="1"/>
-          </p:nvPr>
-        </p:nvSpPr>
-        <p:spPr/>
-        <p:txBody>
-          <a:bodyPr/>
-          <a:lstStyle/>
-          <a:p>
-            <a:r>
-              <a:rPr lang="en-US" dirty="0"/>
-              <a:t>Don’t be afraid to scan a file of 1 GB – just </a:t>
-            </a:r>
-            <a:r>
-              <a:rPr lang="en-US" baseline="0" dirty="0"/>
-              <a:t>process each line efficiently</a:t>
-            </a:r>
-          </a:p>
-          <a:p>
-            <a:endParaRPr lang="en-US" baseline="0" dirty="0"/>
-          </a:p>
-          <a:p>
-            <a:r>
-              <a:rPr lang="en-US" baseline="0" dirty="0"/>
-              <a:t>Experiments on Lenovo T460s laptop 512 Gb SSD disk</a:t>
-            </a:r>
-            <a:endParaRPr lang="en-US" dirty="0"/>
-          </a:p>
-        </p:txBody>
-      </p:sp>
-      <p:sp>
-        <p:nvSpPr>
-          <p:cNvPr id="4" name="Slide Number Placeholder 3"/>
-          <p:cNvSpPr>
-            <a:spLocks noGrp="1"/>
-          </p:cNvSpPr>
-          <p:nvPr>
-            <p:ph type="sldNum" sz="quarter" idx="10"/>
-          </p:nvPr>
-        </p:nvSpPr>
-        <p:spPr/>
-        <p:txBody>
-          <a:bodyPr/>
-          <a:lstStyle/>
-          <a:p>
-            <a:fld id="{CD563DD8-32AB-41BE-B1C6-8EAC45222ACE}" type="slidenum">
-              <a:rPr lang="en-US" smtClean="0"/>
-              <a:t>26</a:t>
-            </a:fld>
-            <a:endParaRPr lang="en-US"/>
-          </a:p>
-        </p:txBody>
-      </p:sp>
-    </p:spTree>
-    <p:extLst>
-      <p:ext uri="{BB962C8B-B14F-4D97-AF65-F5344CB8AC3E}">
-        <p14:creationId xmlns:p14="http://schemas.microsoft.com/office/powerpoint/2010/main" val="1035472152"/>
-      </p:ext>
-    </p:extLst>
-  </p:cSld>
-  <p:clrMapOvr>
-    <a:masterClrMapping/>
-  </p:clrMapOvr>
-</p:notes>
-</file>
-
-<file path=ppt/notesSlides/notesSlide17.xml><?xml version="1.0" encoding="utf-8"?>
-<p:notes xmlns:a="http://schemas.openxmlformats.org/drawingml/2006/main" xmlns:r="http://schemas.openxmlformats.org/officeDocument/2006/relationships" xmlns:p="http://schemas.openxmlformats.org/presentationml/2006/main">
-  <p:cSld>
-    <p:spTree>
-      <p:nvGrpSpPr>
-        <p:cNvPr id="1" name=""/>
-        <p:cNvGrpSpPr/>
-        <p:nvPr/>
-      </p:nvGrpSpPr>
-      <p:grpSpPr>
-        <a:xfrm>
-          <a:off x="0" y="0"/>
-          <a:ext cx="0" cy="0"/>
-          <a:chOff x="0" y="0"/>
-          <a:chExt cx="0" cy="0"/>
-        </a:xfrm>
-      </p:grpSpPr>
-      <p:sp>
-        <p:nvSpPr>
-          <p:cNvPr id="2" name="Slide Image Placeholder 1"/>
-          <p:cNvSpPr>
-            <a:spLocks noGrp="1" noRot="1" noChangeAspect="1"/>
-          </p:cNvSpPr>
-          <p:nvPr>
-            <p:ph type="sldImg"/>
-          </p:nvPr>
-        </p:nvSpPr>
-        <p:spPr/>
-      </p:sp>
-      <p:sp>
-        <p:nvSpPr>
-          <p:cNvPr id="3" name="Notes Placeholder 2"/>
-          <p:cNvSpPr>
-            <a:spLocks noGrp="1"/>
-          </p:cNvSpPr>
-          <p:nvPr>
-            <p:ph type="body" idx="1"/>
-          </p:nvPr>
-        </p:nvSpPr>
-        <p:spPr/>
-        <p:txBody>
-          <a:bodyPr/>
-          <a:lstStyle/>
-          <a:p>
-            <a:r>
-              <a:rPr lang="en-US" dirty="0"/>
-              <a:t>Example using </a:t>
-            </a:r>
-            <a:r>
-              <a:rPr lang="en-US" b="1" dirty="0"/>
-              <a:t>reading</a:t>
-            </a:r>
-            <a:r>
-              <a:rPr lang="en-US" b="1" baseline="0" dirty="0"/>
-              <a:t> a file</a:t>
-            </a:r>
-            <a:r>
-              <a:rPr lang="en-US" baseline="0" dirty="0"/>
-              <a:t>, </a:t>
-            </a:r>
-            <a:r>
-              <a:rPr lang="en-US" b="1" baseline="0" dirty="0"/>
-              <a:t>and user defined exception</a:t>
-            </a:r>
-            <a:r>
-              <a:rPr lang="en-US" baseline="0" dirty="0"/>
-              <a:t> for returning recursive found solution</a:t>
-            </a:r>
-          </a:p>
-          <a:p>
-            <a:endParaRPr lang="en-US" baseline="0" dirty="0"/>
-          </a:p>
-          <a:p>
-            <a:r>
-              <a:rPr lang="en-US" baseline="0" dirty="0" err="1"/>
-              <a:t>find_free</a:t>
-            </a:r>
-            <a:r>
-              <a:rPr lang="en-US" baseline="0" dirty="0"/>
-              <a:t>(): return an empty cell</a:t>
-            </a:r>
-          </a:p>
-          <a:p>
-            <a:r>
-              <a:rPr lang="en-US" baseline="0" dirty="0"/>
-              <a:t>unused(</a:t>
-            </a:r>
-            <a:r>
-              <a:rPr lang="en-US" baseline="0" dirty="0" err="1"/>
-              <a:t>i,j</a:t>
-            </a:r>
-            <a:r>
-              <a:rPr lang="en-US" baseline="0" dirty="0"/>
-              <a:t>): return set of values possible for cell(</a:t>
-            </a:r>
-            <a:r>
-              <a:rPr lang="en-US" baseline="0" dirty="0" err="1"/>
-              <a:t>i,j</a:t>
-            </a:r>
-            <a:r>
-              <a:rPr lang="en-US" baseline="0" dirty="0"/>
-              <a:t>)</a:t>
-            </a:r>
-          </a:p>
-          <a:p>
-            <a:endParaRPr lang="en-US" baseline="0" dirty="0"/>
-          </a:p>
-          <a:p>
-            <a:r>
-              <a:rPr lang="en-US" baseline="0" dirty="0"/>
-              <a:t>sudoku_histogram.py : report number of recursive calls, and distribution over the recursion depth</a:t>
-            </a:r>
-          </a:p>
-          <a:p>
-            <a:endParaRPr lang="en-US" baseline="0" dirty="0"/>
-          </a:p>
-          <a:p>
-            <a:r>
-              <a:rPr lang="en-US" dirty="0"/>
-              <a:t>sudoku_histogram_smallest_unused.py : Recurse on cell with the minimum number of</a:t>
-            </a:r>
-            <a:r>
-              <a:rPr lang="en-US" baseline="0" dirty="0"/>
-              <a:t> candidate numbers left </a:t>
-            </a:r>
-            <a:br>
-              <a:rPr lang="en-US" baseline="0" dirty="0"/>
-            </a:br>
-            <a:r>
-              <a:rPr lang="en-US" baseline="0" dirty="0"/>
-              <a:t>(heuristic to reduce search space; but fails miserably when “for value in unused(</a:t>
-            </a:r>
-            <a:r>
-              <a:rPr lang="en-US" baseline="0" dirty="0" err="1"/>
-              <a:t>i,j</a:t>
-            </a:r>
-            <a:r>
-              <a:rPr lang="en-US" baseline="0" dirty="0"/>
-              <a:t>)” is replaced by “sorted(unused(</a:t>
-            </a:r>
-            <a:r>
-              <a:rPr lang="en-US" baseline="0" dirty="0" err="1"/>
-              <a:t>i,j</a:t>
-            </a:r>
-            <a:r>
-              <a:rPr lang="en-US" baseline="0" dirty="0"/>
-              <a:t>))” where the search space visited increased by factor &gt;= 1000)</a:t>
-            </a:r>
-            <a:endParaRPr lang="en-US" dirty="0"/>
-          </a:p>
-        </p:txBody>
-      </p:sp>
-      <p:sp>
-        <p:nvSpPr>
-          <p:cNvPr id="4" name="Slide Number Placeholder 3"/>
-          <p:cNvSpPr>
-            <a:spLocks noGrp="1"/>
-          </p:cNvSpPr>
-          <p:nvPr>
-            <p:ph type="sldNum" sz="quarter" idx="10"/>
-          </p:nvPr>
-        </p:nvSpPr>
-        <p:spPr/>
-        <p:txBody>
-          <a:bodyPr/>
-          <a:lstStyle/>
-          <a:p>
-            <a:fld id="{CD563DD8-32AB-41BE-B1C6-8EAC45222ACE}" type="slidenum">
-              <a:rPr lang="en-US" smtClean="0"/>
-              <a:t>27</a:t>
-            </a:fld>
-            <a:endParaRPr lang="en-US"/>
-          </a:p>
-        </p:txBody>
-      </p:sp>
-    </p:spTree>
-    <p:extLst>
-      <p:ext uri="{BB962C8B-B14F-4D97-AF65-F5344CB8AC3E}">
-        <p14:creationId xmlns:p14="http://schemas.microsoft.com/office/powerpoint/2010/main" val="980103824"/>
       </p:ext>
     </p:extLst>
   </p:cSld>
@@ -2086,14 +1613,23 @@
           <a:lstStyle/>
           <a:p>
             <a:r>
-              <a:rPr lang="en-US" b="1" dirty="0" err="1"/>
-              <a:t>repr</a:t>
-            </a:r>
-            <a:r>
               <a:rPr lang="en-US" dirty="0"/>
-              <a:t> ensures quotes will be printed around strings</a:t>
-            </a:r>
-            <a:endParaRPr lang="da-DK" dirty="0"/>
+              <a:t>Don’t be afraid to scan a file of 1 GB – just </a:t>
+            </a:r>
+            <a:r>
+              <a:rPr lang="en-US" baseline="0" dirty="0"/>
+              <a:t>process each line efficiently</a:t>
+            </a:r>
+          </a:p>
+          <a:p>
+            <a:endParaRPr lang="en-US" baseline="0" dirty="0"/>
+          </a:p>
+          <a:p>
+            <a:r>
+              <a:rPr lang="en-US" baseline="0" dirty="0"/>
+              <a:t>Experiments on Lenovo T460s laptop 512 Gb SSD disk</a:t>
+            </a:r>
+            <a:endParaRPr lang="en-US" dirty="0"/>
           </a:p>
         </p:txBody>
       </p:sp>
@@ -2104,7 +1640,7 @@
             <a:spLocks noGrp="1"/>
           </p:cNvSpPr>
           <p:nvPr>
-            <p:ph type="sldNum" sz="quarter" idx="5"/>
+            <p:ph type="sldNum" sz="quarter" idx="10"/>
           </p:nvPr>
         </p:nvSpPr>
         <p:spPr/>
@@ -2114,7 +1650,7 @@
           <a:p>
             <a:fld id="{CD563DD8-32AB-41BE-B1C6-8EAC45222ACE}" type="slidenum">
               <a:rPr lang="en-US" smtClean="0"/>
-              <a:t>30</a:t>
+              <a:t>26</a:t>
             </a:fld>
             <a:endParaRPr lang="en-US"/>
           </a:p>
@@ -2123,7 +1659,195 @@
     </p:spTree>
     <p:extLst>
       <p:ext uri="{BB962C8B-B14F-4D97-AF65-F5344CB8AC3E}">
-        <p14:creationId xmlns:p14="http://schemas.microsoft.com/office/powerpoint/2010/main" val="3338232339"/>
+        <p14:creationId xmlns:p14="http://schemas.microsoft.com/office/powerpoint/2010/main" val="1035472152"/>
+      </p:ext>
+    </p:extLst>
+  </p:cSld>
+  <p:clrMapOvr>
+    <a:masterClrMapping/>
+  </p:clrMapOvr>
+</p:notes>
+</file>
+
+<file path=ppt/notesSlides/notesSlide19.xml><?xml version="1.0" encoding="utf-8"?>
+<p:notes xmlns:a="http://schemas.openxmlformats.org/drawingml/2006/main" xmlns:r="http://schemas.openxmlformats.org/officeDocument/2006/relationships" xmlns:p="http://schemas.openxmlformats.org/presentationml/2006/main">
+  <p:cSld>
+    <p:spTree>
+      <p:nvGrpSpPr>
+        <p:cNvPr id="1" name=""/>
+        <p:cNvGrpSpPr/>
+        <p:nvPr/>
+      </p:nvGrpSpPr>
+      <p:grpSpPr>
+        <a:xfrm>
+          <a:off x="0" y="0"/>
+          <a:ext cx="0" cy="0"/>
+          <a:chOff x="0" y="0"/>
+          <a:chExt cx="0" cy="0"/>
+        </a:xfrm>
+      </p:grpSpPr>
+      <p:sp>
+        <p:nvSpPr>
+          <p:cNvPr id="2" name="Slide Image Placeholder 1"/>
+          <p:cNvSpPr>
+            <a:spLocks noGrp="1" noRot="1" noChangeAspect="1"/>
+          </p:cNvSpPr>
+          <p:nvPr>
+            <p:ph type="sldImg"/>
+          </p:nvPr>
+        </p:nvSpPr>
+        <p:spPr/>
+      </p:sp>
+      <p:sp>
+        <p:nvSpPr>
+          <p:cNvPr id="3" name="Notes Placeholder 2"/>
+          <p:cNvSpPr>
+            <a:spLocks noGrp="1"/>
+          </p:cNvSpPr>
+          <p:nvPr>
+            <p:ph type="body" idx="1"/>
+          </p:nvPr>
+        </p:nvSpPr>
+        <p:spPr/>
+        <p:txBody>
+          <a:bodyPr/>
+          <a:lstStyle/>
+          <a:p>
+            <a:r>
+              <a:rPr lang="en-US" dirty="0"/>
+              <a:t>Example using </a:t>
+            </a:r>
+            <a:r>
+              <a:rPr lang="en-US" b="1" dirty="0"/>
+              <a:t>reading</a:t>
+            </a:r>
+            <a:r>
+              <a:rPr lang="en-US" b="1" baseline="0" dirty="0"/>
+              <a:t> a file</a:t>
+            </a:r>
+            <a:r>
+              <a:rPr lang="en-US" baseline="0" dirty="0"/>
+              <a:t>, </a:t>
+            </a:r>
+            <a:r>
+              <a:rPr lang="en-US" b="1" baseline="0" dirty="0"/>
+              <a:t>and user defined exception</a:t>
+            </a:r>
+            <a:r>
+              <a:rPr lang="en-US" baseline="0" dirty="0"/>
+              <a:t> for returning recursive found solution</a:t>
+            </a:r>
+          </a:p>
+          <a:p>
+            <a:endParaRPr lang="en-US" baseline="0" dirty="0"/>
+          </a:p>
+          <a:p>
+            <a:r>
+              <a:rPr lang="en-US" baseline="0" dirty="0" err="1"/>
+              <a:t>find_free</a:t>
+            </a:r>
+            <a:r>
+              <a:rPr lang="en-US" baseline="0" dirty="0"/>
+              <a:t>(): return an empty cell</a:t>
+            </a:r>
+          </a:p>
+          <a:p>
+            <a:r>
+              <a:rPr lang="en-US" baseline="0" dirty="0"/>
+              <a:t>unused(</a:t>
+            </a:r>
+            <a:r>
+              <a:rPr lang="en-US" baseline="0" dirty="0" err="1"/>
+              <a:t>i,j</a:t>
+            </a:r>
+            <a:r>
+              <a:rPr lang="en-US" baseline="0" dirty="0"/>
+              <a:t>): return set of values possible for cell(</a:t>
+            </a:r>
+            <a:r>
+              <a:rPr lang="en-US" baseline="0" dirty="0" err="1"/>
+              <a:t>i,j</a:t>
+            </a:r>
+            <a:r>
+              <a:rPr lang="en-US" baseline="0" dirty="0"/>
+              <a:t>)</a:t>
+            </a:r>
+          </a:p>
+          <a:p>
+            <a:endParaRPr lang="en-US" baseline="0" dirty="0"/>
+          </a:p>
+          <a:p>
+            <a:r>
+              <a:rPr lang="en-US" baseline="0" dirty="0"/>
+              <a:t>sudoku_histogram.py : report number of recursive calls, and distribution over the recursion depth</a:t>
+            </a:r>
+          </a:p>
+          <a:p>
+            <a:endParaRPr lang="en-US" baseline="0" dirty="0"/>
+          </a:p>
+          <a:p>
+            <a:r>
+              <a:rPr lang="en-US" dirty="0"/>
+              <a:t>sudoku_histogram_smallest_unused.py : Recurse on cell with the minimum number of</a:t>
+            </a:r>
+            <a:r>
+              <a:rPr lang="en-US" baseline="0" dirty="0"/>
+              <a:t> candidate numbers left </a:t>
+            </a:r>
+            <a:br>
+              <a:rPr lang="en-US" baseline="0" dirty="0"/>
+            </a:br>
+            <a:r>
+              <a:rPr lang="en-US" baseline="0" dirty="0"/>
+              <a:t>(heuristic to reduce search space; but fails miserably when “for value in unused(</a:t>
+            </a:r>
+            <a:r>
+              <a:rPr lang="en-US" baseline="0" dirty="0" err="1"/>
+              <a:t>i,j</a:t>
+            </a:r>
+            <a:r>
+              <a:rPr lang="en-US" baseline="0" dirty="0"/>
+              <a:t>)” is replaced by “sorted(unused(</a:t>
+            </a:r>
+            <a:r>
+              <a:rPr lang="en-US" baseline="0" dirty="0" err="1"/>
+              <a:t>i,j</a:t>
+            </a:r>
+            <a:r>
+              <a:rPr lang="en-US" baseline="0" dirty="0"/>
+              <a:t>))” where the search space visited increased by factor &gt;= 1000)</a:t>
+            </a:r>
+            <a:endParaRPr lang="en-US" dirty="0"/>
+          </a:p>
+        </p:txBody>
+      </p:sp>
+      <p:sp>
+        <p:nvSpPr>
+          <p:cNvPr id="4" name="Slide Number Placeholder 3"/>
+          <p:cNvSpPr>
+            <a:spLocks noGrp="1"/>
+          </p:cNvSpPr>
+          <p:nvPr>
+            <p:ph type="sldNum" sz="quarter" idx="10"/>
+          </p:nvPr>
+        </p:nvSpPr>
+        <p:spPr/>
+        <p:txBody>
+          <a:bodyPr/>
+          <a:lstStyle/>
+          <a:p>
+            <a:fld id="{CD563DD8-32AB-41BE-B1C6-8EAC45222ACE}" type="slidenum">
+              <a:rPr lang="en-US" smtClean="0"/>
+              <a:t>27</a:t>
+            </a:fld>
+            <a:endParaRPr lang="en-US"/>
+          </a:p>
+        </p:txBody>
+      </p:sp>
+    </p:spTree>
+    <p:extLst>
+      <p:ext uri="{BB962C8B-B14F-4D97-AF65-F5344CB8AC3E}">
+        <p14:creationId xmlns:p14="http://schemas.microsoft.com/office/powerpoint/2010/main" val="980103824"/>
       </p:ext>
     </p:extLst>
   </p:cSld>
@@ -2307,6 +2031,98 @@
     <p:extLst>
       <p:ext uri="{BB962C8B-B14F-4D97-AF65-F5344CB8AC3E}">
         <p14:creationId xmlns:p14="http://schemas.microsoft.com/office/powerpoint/2010/main" val="2388560751"/>
+      </p:ext>
+    </p:extLst>
+  </p:cSld>
+  <p:clrMapOvr>
+    <a:masterClrMapping/>
+  </p:clrMapOvr>
+</p:notes>
+</file>
+
+<file path=ppt/notesSlides/notesSlide20.xml><?xml version="1.0" encoding="utf-8"?>
+<p:notes xmlns:a="http://schemas.openxmlformats.org/drawingml/2006/main" xmlns:r="http://schemas.openxmlformats.org/officeDocument/2006/relationships" xmlns:p="http://schemas.openxmlformats.org/presentationml/2006/main">
+  <p:cSld>
+    <p:spTree>
+      <p:nvGrpSpPr>
+        <p:cNvPr id="1" name=""/>
+        <p:cNvGrpSpPr/>
+        <p:nvPr/>
+      </p:nvGrpSpPr>
+      <p:grpSpPr>
+        <a:xfrm>
+          <a:off x="0" y="0"/>
+          <a:ext cx="0" cy="0"/>
+          <a:chOff x="0" y="0"/>
+          <a:chExt cx="0" cy="0"/>
+        </a:xfrm>
+      </p:grpSpPr>
+      <p:sp>
+        <p:nvSpPr>
+          <p:cNvPr id="2" name="Slide Image Placeholder 1"/>
+          <p:cNvSpPr>
+            <a:spLocks noGrp="1" noRot="1" noChangeAspect="1"/>
+          </p:cNvSpPr>
+          <p:nvPr>
+            <p:ph type="sldImg"/>
+          </p:nvPr>
+        </p:nvSpPr>
+        <p:spPr/>
+      </p:sp>
+      <p:sp>
+        <p:nvSpPr>
+          <p:cNvPr id="3" name="Notes Placeholder 2"/>
+          <p:cNvSpPr>
+            <a:spLocks noGrp="1"/>
+          </p:cNvSpPr>
+          <p:nvPr>
+            <p:ph type="body" idx="1"/>
+          </p:nvPr>
+        </p:nvSpPr>
+        <p:spPr/>
+        <p:txBody>
+          <a:bodyPr/>
+          <a:lstStyle/>
+          <a:p>
+            <a:r>
+              <a:rPr lang="en-US" b="1" dirty="0" err="1"/>
+              <a:t>repr</a:t>
+            </a:r>
+            <a:r>
+              <a:rPr lang="en-US" dirty="0"/>
+              <a:t> ensures quotes will be printed around strings</a:t>
+            </a:r>
+            <a:endParaRPr lang="da-DK" dirty="0"/>
+          </a:p>
+        </p:txBody>
+      </p:sp>
+      <p:sp>
+        <p:nvSpPr>
+          <p:cNvPr id="4" name="Slide Number Placeholder 3"/>
+          <p:cNvSpPr>
+            <a:spLocks noGrp="1"/>
+          </p:cNvSpPr>
+          <p:nvPr>
+            <p:ph type="sldNum" sz="quarter" idx="5"/>
+          </p:nvPr>
+        </p:nvSpPr>
+        <p:spPr/>
+        <p:txBody>
+          <a:bodyPr/>
+          <a:lstStyle/>
+          <a:p>
+            <a:fld id="{CD563DD8-32AB-41BE-B1C6-8EAC45222ACE}" type="slidenum">
+              <a:rPr lang="en-US" smtClean="0"/>
+              <a:t>30</a:t>
+            </a:fld>
+            <a:endParaRPr lang="en-US"/>
+          </a:p>
+        </p:txBody>
+      </p:sp>
+    </p:spTree>
+    <p:extLst>
+      <p:ext uri="{BB962C8B-B14F-4D97-AF65-F5344CB8AC3E}">
+        <p14:creationId xmlns:p14="http://schemas.microsoft.com/office/powerpoint/2010/main" val="3338232339"/>
       </p:ext>
     </p:extLst>
   </p:cSld>
@@ -2542,7 +2358,7 @@
             </a:r>
             <a:r>
               <a:rPr lang="en-US" dirty="0" err="1"/>
-              <a:t>misbehavioring</a:t>
+              <a:t>misbehavoring</a:t>
             </a:r>
             <a:r>
               <a:rPr lang="en-US" dirty="0"/>
@@ -2818,181 +2634,8 @@
           <a:lstStyle/>
           <a:p>
             <a:r>
-              <a:rPr lang="da-DK" b="1" dirty="0" err="1"/>
-              <a:t>help</a:t>
-            </a:r>
-            <a:r>
-              <a:rPr lang="da-DK" b="1" dirty="0"/>
-              <a:t>(</a:t>
-            </a:r>
-            <a:r>
-              <a:rPr lang="da-DK" b="1" dirty="0" err="1"/>
-              <a:t>LookupError</a:t>
-            </a:r>
-            <a:r>
-              <a:rPr lang="da-DK" b="1" dirty="0"/>
-              <a:t>)</a:t>
-            </a:r>
-            <a:r>
-              <a:rPr lang="da-DK" dirty="0"/>
-              <a:t> -&gt; class </a:t>
-            </a:r>
-            <a:r>
-              <a:rPr lang="da-DK" dirty="0" err="1"/>
-              <a:t>LookupError</a:t>
-            </a:r>
-            <a:r>
-              <a:rPr lang="da-DK" dirty="0"/>
-              <a:t>(</a:t>
-            </a:r>
-            <a:r>
-              <a:rPr lang="da-DK" dirty="0" err="1"/>
-              <a:t>Exception</a:t>
-            </a:r>
-            <a:r>
-              <a:rPr lang="da-DK" dirty="0"/>
-              <a:t>)  # lists </a:t>
-            </a:r>
-            <a:r>
-              <a:rPr lang="da-DK" dirty="0" err="1"/>
-              <a:t>parent</a:t>
-            </a:r>
-            <a:r>
-              <a:rPr lang="da-DK" dirty="0"/>
-              <a:t> </a:t>
-            </a:r>
-            <a:r>
-              <a:rPr lang="da-DK" dirty="0" err="1"/>
-              <a:t>classes</a:t>
-            </a:r>
-            <a:r>
-              <a:rPr lang="da-DK" dirty="0"/>
-              <a:t> (as part of method-resolution </a:t>
-            </a:r>
-            <a:r>
-              <a:rPr lang="da-DK" dirty="0" err="1"/>
-              <a:t>order</a:t>
-            </a:r>
-            <a:r>
-              <a:rPr lang="da-DK" dirty="0"/>
-              <a:t>) but </a:t>
-            </a:r>
-            <a:r>
-              <a:rPr lang="da-DK" dirty="0" err="1"/>
-              <a:t>also</a:t>
-            </a:r>
-            <a:r>
-              <a:rPr lang="da-DK" dirty="0"/>
-              <a:t> </a:t>
-            </a:r>
-            <a:r>
-              <a:rPr lang="da-DK" dirty="0" err="1"/>
-              <a:t>builtin</a:t>
-            </a:r>
-            <a:r>
-              <a:rPr lang="da-DK" dirty="0"/>
-              <a:t> </a:t>
-            </a:r>
-            <a:r>
-              <a:rPr lang="da-DK" dirty="0" err="1"/>
-              <a:t>subclasses</a:t>
-            </a:r>
-            <a:r>
-              <a:rPr lang="da-DK" dirty="0"/>
-              <a:t> (but not </a:t>
-            </a:r>
-            <a:r>
-              <a:rPr lang="da-DK" dirty="0" err="1"/>
-              <a:t>used</a:t>
-            </a:r>
-            <a:r>
-              <a:rPr lang="da-DK" dirty="0"/>
-              <a:t> </a:t>
-            </a:r>
-            <a:r>
-              <a:rPr lang="da-DK" dirty="0" err="1"/>
-              <a:t>defined</a:t>
-            </a:r>
-            <a:r>
-              <a:rPr lang="da-DK" dirty="0"/>
-              <a:t> </a:t>
-            </a:r>
-            <a:r>
-              <a:rPr lang="da-DK" dirty="0" err="1"/>
-              <a:t>subclasses</a:t>
-            </a:r>
-            <a:r>
-              <a:rPr lang="da-DK" dirty="0"/>
-              <a:t>)</a:t>
-            </a:r>
-          </a:p>
-          <a:p>
-            <a:endParaRPr lang="da-DK" dirty="0"/>
-          </a:p>
-          <a:p>
-            <a:r>
-              <a:rPr lang="da-DK" dirty="0" err="1"/>
-              <a:t>Other</a:t>
-            </a:r>
-            <a:r>
-              <a:rPr lang="da-DK" dirty="0"/>
-              <a:t> </a:t>
-            </a:r>
-            <a:r>
-              <a:rPr lang="da-DK" dirty="0" err="1"/>
-              <a:t>exceptions</a:t>
-            </a:r>
-            <a:r>
-              <a:rPr lang="da-DK" dirty="0"/>
-              <a:t> </a:t>
-            </a:r>
-            <a:r>
-              <a:rPr lang="da-DK" dirty="0" err="1"/>
-              <a:t>could</a:t>
-            </a:r>
-            <a:r>
-              <a:rPr lang="da-DK" dirty="0"/>
-              <a:t> </a:t>
-            </a:r>
-            <a:r>
-              <a:rPr lang="da-DK" dirty="0" err="1"/>
-              <a:t>be</a:t>
-            </a:r>
-            <a:r>
-              <a:rPr lang="da-DK" dirty="0"/>
-              <a:t> </a:t>
-            </a:r>
-            <a:r>
-              <a:rPr lang="da-DK" dirty="0" err="1"/>
-              <a:t>NameError</a:t>
-            </a:r>
-            <a:r>
-              <a:rPr lang="da-DK" dirty="0"/>
-              <a:t> (L not </a:t>
-            </a:r>
-            <a:r>
-              <a:rPr lang="da-DK" dirty="0" err="1"/>
-              <a:t>defined</a:t>
-            </a:r>
-            <a:r>
-              <a:rPr lang="da-DK" dirty="0"/>
-              <a:t>) or </a:t>
-            </a:r>
-            <a:r>
-              <a:rPr lang="da-DK" dirty="0" err="1"/>
-              <a:t>TypeError</a:t>
-            </a:r>
-            <a:r>
-              <a:rPr lang="da-DK" dirty="0"/>
-              <a:t> (L is not </a:t>
-            </a:r>
-            <a:r>
-              <a:rPr lang="da-DK" dirty="0" err="1"/>
-              <a:t>subscriptable</a:t>
-            </a:r>
-            <a:r>
-              <a:rPr lang="da-DK" dirty="0"/>
-              <a:t>)</a:t>
+              <a:rPr lang="en-US" dirty="0"/>
+              <a:t>Could also use “pass” instead of “continue”</a:t>
             </a:r>
           </a:p>
         </p:txBody>
@@ -3014,7 +2657,7 @@
           <a:p>
             <a:fld id="{CD563DD8-32AB-41BE-B1C6-8EAC45222ACE}" type="slidenum">
               <a:rPr lang="en-US" smtClean="0"/>
-              <a:t>12</a:t>
+              <a:t>11</a:t>
             </a:fld>
             <a:endParaRPr lang="en-US"/>
           </a:p>
@@ -3023,7 +2666,7 @@
     </p:spTree>
     <p:extLst>
       <p:ext uri="{BB962C8B-B14F-4D97-AF65-F5344CB8AC3E}">
-        <p14:creationId xmlns:p14="http://schemas.microsoft.com/office/powerpoint/2010/main" val="245169996"/>
+        <p14:creationId xmlns:p14="http://schemas.microsoft.com/office/powerpoint/2010/main" val="954955817"/>
       </p:ext>
     </p:extLst>
   </p:cSld>
@@ -3078,14 +2721,182 @@
           <a:lstStyle/>
           <a:p>
             <a:r>
-              <a:rPr lang="en-US" b="1" dirty="0"/>
-              <a:t>finally </a:t>
-            </a:r>
-            <a:r>
-              <a:rPr lang="en-US" dirty="0"/>
-              <a:t>is also executed if an “except” is executed that raises a new exception</a:t>
-            </a:r>
+              <a:rPr lang="da-DK" b="1" dirty="0" err="1"/>
+              <a:t>help</a:t>
+            </a:r>
+            <a:r>
+              <a:rPr lang="da-DK" b="1" dirty="0"/>
+              <a:t>(</a:t>
+            </a:r>
+            <a:r>
+              <a:rPr lang="da-DK" b="1" dirty="0" err="1"/>
+              <a:t>LookupError</a:t>
+            </a:r>
+            <a:r>
+              <a:rPr lang="da-DK" b="1" dirty="0"/>
+              <a:t>)</a:t>
+            </a:r>
+            <a:r>
+              <a:rPr lang="da-DK" dirty="0"/>
+              <a:t> -&gt; class </a:t>
+            </a:r>
+            <a:r>
+              <a:rPr lang="da-DK" dirty="0" err="1"/>
+              <a:t>LookupError</a:t>
+            </a:r>
+            <a:r>
+              <a:rPr lang="da-DK" dirty="0"/>
+              <a:t>(</a:t>
+            </a:r>
+            <a:r>
+              <a:rPr lang="da-DK" dirty="0" err="1"/>
+              <a:t>Exception</a:t>
+            </a:r>
+            <a:r>
+              <a:rPr lang="da-DK" dirty="0"/>
+              <a:t>)  # lists </a:t>
+            </a:r>
+            <a:r>
+              <a:rPr lang="da-DK" dirty="0" err="1"/>
+              <a:t>parent</a:t>
+            </a:r>
+            <a:r>
+              <a:rPr lang="da-DK" dirty="0"/>
+              <a:t> </a:t>
+            </a:r>
+            <a:r>
+              <a:rPr lang="da-DK" dirty="0" err="1"/>
+              <a:t>classes</a:t>
+            </a:r>
+            <a:r>
+              <a:rPr lang="da-DK" dirty="0"/>
+              <a:t> (as part of method-resolution </a:t>
+            </a:r>
+            <a:r>
+              <a:rPr lang="da-DK" dirty="0" err="1"/>
+              <a:t>order</a:t>
+            </a:r>
+            <a:r>
+              <a:rPr lang="da-DK" dirty="0"/>
+              <a:t>) but </a:t>
+            </a:r>
+            <a:r>
+              <a:rPr lang="da-DK" dirty="0" err="1"/>
+              <a:t>also</a:t>
+            </a:r>
+            <a:r>
+              <a:rPr lang="da-DK" dirty="0"/>
+              <a:t> </a:t>
+            </a:r>
+            <a:r>
+              <a:rPr lang="da-DK" dirty="0" err="1"/>
+              <a:t>builtin</a:t>
+            </a:r>
+            <a:r>
+              <a:rPr lang="da-DK" dirty="0"/>
+              <a:t> </a:t>
+            </a:r>
+            <a:r>
+              <a:rPr lang="da-DK" dirty="0" err="1"/>
+              <a:t>subclasses</a:t>
+            </a:r>
+            <a:r>
+              <a:rPr lang="da-DK" dirty="0"/>
+              <a:t> (but not </a:t>
+            </a:r>
+            <a:r>
+              <a:rPr lang="da-DK" dirty="0" err="1"/>
+              <a:t>used</a:t>
+            </a:r>
+            <a:r>
+              <a:rPr lang="da-DK" dirty="0"/>
+              <a:t> </a:t>
+            </a:r>
+            <a:r>
+              <a:rPr lang="da-DK" dirty="0" err="1"/>
+              <a:t>defined</a:t>
+            </a:r>
+            <a:r>
+              <a:rPr lang="da-DK" dirty="0"/>
+              <a:t> </a:t>
+            </a:r>
+            <a:r>
+              <a:rPr lang="da-DK" dirty="0" err="1"/>
+              <a:t>subclasses</a:t>
+            </a:r>
+            <a:r>
+              <a:rPr lang="da-DK" dirty="0"/>
+              <a:t>)</a:t>
+            </a:r>
+          </a:p>
+          <a:p>
             <a:endParaRPr lang="da-DK" dirty="0"/>
+          </a:p>
+          <a:p>
+            <a:r>
+              <a:rPr lang="da-DK" dirty="0" err="1"/>
+              <a:t>Other</a:t>
+            </a:r>
+            <a:r>
+              <a:rPr lang="da-DK" dirty="0"/>
+              <a:t> </a:t>
+            </a:r>
+            <a:r>
+              <a:rPr lang="da-DK" dirty="0" err="1"/>
+              <a:t>exceptions</a:t>
+            </a:r>
+            <a:r>
+              <a:rPr lang="da-DK" dirty="0"/>
+              <a:t> </a:t>
+            </a:r>
+            <a:r>
+              <a:rPr lang="da-DK" dirty="0" err="1"/>
+              <a:t>could</a:t>
+            </a:r>
+            <a:r>
+              <a:rPr lang="da-DK" dirty="0"/>
+              <a:t> </a:t>
+            </a:r>
+            <a:r>
+              <a:rPr lang="da-DK" dirty="0" err="1"/>
+              <a:t>be</a:t>
+            </a:r>
+            <a:r>
+              <a:rPr lang="da-DK" dirty="0"/>
+              <a:t> </a:t>
+            </a:r>
+            <a:r>
+              <a:rPr lang="da-DK" dirty="0" err="1"/>
+              <a:t>NameError</a:t>
+            </a:r>
+            <a:r>
+              <a:rPr lang="da-DK" dirty="0"/>
+              <a:t> (L not </a:t>
+            </a:r>
+            <a:r>
+              <a:rPr lang="da-DK" dirty="0" err="1"/>
+              <a:t>defined</a:t>
+            </a:r>
+            <a:r>
+              <a:rPr lang="da-DK" dirty="0"/>
+              <a:t>) or </a:t>
+            </a:r>
+            <a:r>
+              <a:rPr lang="da-DK" dirty="0" err="1"/>
+              <a:t>TypeError</a:t>
+            </a:r>
+            <a:r>
+              <a:rPr lang="da-DK" dirty="0"/>
+              <a:t> (L is not </a:t>
+            </a:r>
+            <a:r>
+              <a:rPr lang="da-DK" dirty="0" err="1"/>
+              <a:t>subscriptable</a:t>
+            </a:r>
+            <a:r>
+              <a:rPr lang="da-DK" dirty="0"/>
+              <a:t>)</a:t>
+            </a:r>
           </a:p>
         </p:txBody>
       </p:sp>
@@ -3106,7 +2917,7 @@
           <a:p>
             <a:fld id="{CD563DD8-32AB-41BE-B1C6-8EAC45222ACE}" type="slidenum">
               <a:rPr lang="en-US" smtClean="0"/>
-              <a:t>13</a:t>
+              <a:t>12</a:t>
             </a:fld>
             <a:endParaRPr lang="en-US"/>
           </a:p>
@@ -3115,7 +2926,7 @@
     </p:spTree>
     <p:extLst>
       <p:ext uri="{BB962C8B-B14F-4D97-AF65-F5344CB8AC3E}">
-        <p14:creationId xmlns:p14="http://schemas.microsoft.com/office/powerpoint/2010/main" val="4072957580"/>
+        <p14:creationId xmlns:p14="http://schemas.microsoft.com/office/powerpoint/2010/main" val="245169996"/>
       </p:ext>
     </p:extLst>
   </p:cSld>
@@ -3170,16 +2981,12 @@
           <a:lstStyle/>
           <a:p>
             <a:r>
+              <a:rPr lang="en-US" b="1" dirty="0"/>
+              <a:t>finally </a:t>
+            </a:r>
+            <a:r>
               <a:rPr lang="en-US" dirty="0"/>
-              <a:t>In the 3</a:t>
-            </a:r>
-            <a:r>
-              <a:rPr lang="en-US" baseline="30000" dirty="0"/>
-              <a:t>rd</a:t>
-            </a:r>
-            <a:r>
-              <a:rPr lang="en-US" dirty="0"/>
-              <a:t> case the parenthesis cannot be omitted!</a:t>
+              <a:t>is also executed if an “except” is executed that raises a new exception</a:t>
             </a:r>
             <a:endParaRPr lang="da-DK" dirty="0"/>
           </a:p>
@@ -3202,7 +3009,7 @@
           <a:p>
             <a:fld id="{CD563DD8-32AB-41BE-B1C6-8EAC45222ACE}" type="slidenum">
               <a:rPr lang="en-US" smtClean="0"/>
-              <a:t>14</a:t>
+              <a:t>13</a:t>
             </a:fld>
             <a:endParaRPr lang="en-US"/>
           </a:p>
@@ -3211,7 +3018,7 @@
     </p:spTree>
     <p:extLst>
       <p:ext uri="{BB962C8B-B14F-4D97-AF65-F5344CB8AC3E}">
-        <p14:creationId xmlns:p14="http://schemas.microsoft.com/office/powerpoint/2010/main" val="1957294039"/>
+        <p14:creationId xmlns:p14="http://schemas.microsoft.com/office/powerpoint/2010/main" val="4072957580"/>
       </p:ext>
     </p:extLst>
   </p:cSld>
@@ -3358,7 +3165,7 @@
           <a:p>
             <a:fld id="{0560A9CD-0304-4E0B-9E82-E7E0115DE05B}" type="datetimeFigureOut">
               <a:rPr lang="en-US" smtClean="0"/>
-              <a:t>3/12/2025</a:t>
+              <a:t>3/9/2026</a:t>
             </a:fld>
             <a:endParaRPr lang="en-US"/>
           </a:p>
@@ -3526,7 +3333,7 @@
           <a:p>
             <a:fld id="{0560A9CD-0304-4E0B-9E82-E7E0115DE05B}" type="datetimeFigureOut">
               <a:rPr lang="en-US" smtClean="0"/>
-              <a:t>3/12/2025</a:t>
+              <a:t>3/9/2026</a:t>
             </a:fld>
             <a:endParaRPr lang="en-US"/>
           </a:p>
@@ -3704,7 +3511,7 @@
           <a:p>
             <a:fld id="{0560A9CD-0304-4E0B-9E82-E7E0115DE05B}" type="datetimeFigureOut">
               <a:rPr lang="en-US" smtClean="0"/>
-              <a:t>3/12/2025</a:t>
+              <a:t>3/9/2026</a:t>
             </a:fld>
             <a:endParaRPr lang="en-US"/>
           </a:p>
@@ -3887,7 +3694,7 @@
           <a:p>
             <a:fld id="{0560A9CD-0304-4E0B-9E82-E7E0115DE05B}" type="datetimeFigureOut">
               <a:rPr lang="en-US" smtClean="0"/>
-              <a:t>3/12/2025</a:t>
+              <a:t>3/9/2026</a:t>
             </a:fld>
             <a:endParaRPr lang="en-US"/>
           </a:p>
@@ -4132,7 +3939,7 @@
           <a:p>
             <a:fld id="{0560A9CD-0304-4E0B-9E82-E7E0115DE05B}" type="datetimeFigureOut">
               <a:rPr lang="en-US" smtClean="0"/>
-              <a:t>3/12/2025</a:t>
+              <a:t>3/9/2026</a:t>
             </a:fld>
             <a:endParaRPr lang="en-US"/>
           </a:p>
@@ -4361,7 +4168,7 @@
           <a:p>
             <a:fld id="{0560A9CD-0304-4E0B-9E82-E7E0115DE05B}" type="datetimeFigureOut">
               <a:rPr lang="en-US" smtClean="0"/>
-              <a:t>3/12/2025</a:t>
+              <a:t>3/9/2026</a:t>
             </a:fld>
             <a:endParaRPr lang="en-US"/>
           </a:p>
@@ -4725,7 +4532,7 @@
           <a:p>
             <a:fld id="{0560A9CD-0304-4E0B-9E82-E7E0115DE05B}" type="datetimeFigureOut">
               <a:rPr lang="en-US" smtClean="0"/>
-              <a:t>3/12/2025</a:t>
+              <a:t>3/9/2026</a:t>
             </a:fld>
             <a:endParaRPr lang="en-US"/>
           </a:p>
@@ -4842,7 +4649,7 @@
           <a:p>
             <a:fld id="{0560A9CD-0304-4E0B-9E82-E7E0115DE05B}" type="datetimeFigureOut">
               <a:rPr lang="en-US" smtClean="0"/>
-              <a:t>3/12/2025</a:t>
+              <a:t>3/9/2026</a:t>
             </a:fld>
             <a:endParaRPr lang="en-US"/>
           </a:p>
@@ -4937,7 +4744,7 @@
           <a:p>
             <a:fld id="{0560A9CD-0304-4E0B-9E82-E7E0115DE05B}" type="datetimeFigureOut">
               <a:rPr lang="en-US" smtClean="0"/>
-              <a:t>3/12/2025</a:t>
+              <a:t>3/9/2026</a:t>
             </a:fld>
             <a:endParaRPr lang="en-US"/>
           </a:p>
@@ -5212,7 +5019,7 @@
           <a:p>
             <a:fld id="{0560A9CD-0304-4E0B-9E82-E7E0115DE05B}" type="datetimeFigureOut">
               <a:rPr lang="en-US" smtClean="0"/>
-              <a:t>3/12/2025</a:t>
+              <a:t>3/9/2026</a:t>
             </a:fld>
             <a:endParaRPr lang="en-US"/>
           </a:p>
@@ -5464,7 +5271,7 @@
           <a:p>
             <a:fld id="{0560A9CD-0304-4E0B-9E82-E7E0115DE05B}" type="datetimeFigureOut">
               <a:rPr lang="en-US" smtClean="0"/>
-              <a:t>3/12/2025</a:t>
+              <a:t>3/9/2026</a:t>
             </a:fld>
             <a:endParaRPr lang="en-US"/>
           </a:p>
@@ -5675,7 +5482,7 @@
           <a:p>
             <a:fld id="{0560A9CD-0304-4E0B-9E82-E7E0115DE05B}" type="datetimeFigureOut">
               <a:rPr lang="en-US" smtClean="0"/>
-              <a:t>3/12/2025</a:t>
+              <a:t>3/9/2026</a:t>
             </a:fld>
             <a:endParaRPr lang="en-US"/>
           </a:p>
@@ -6155,12 +5962,6 @@
           <a:p>
             <a:r>
               <a:rPr lang="en-US" dirty="0"/>
-              <a:t>match - case</a:t>
-            </a:r>
-          </a:p>
-          <a:p>
-            <a:r>
-              <a:rPr lang="en-US" dirty="0"/>
               <a:t>file open/read/write</a:t>
             </a:r>
           </a:p>
@@ -6192,6 +5993,15 @@
               <a:rPr lang="en-US" dirty="0"/>
               <a:t>context manager</a:t>
             </a:r>
+          </a:p>
+          <a:p>
+            <a:r>
+              <a:rPr lang="en-US" dirty="0"/>
+              <a:t>match - case</a:t>
+            </a:r>
+          </a:p>
+          <a:p>
+            <a:endParaRPr lang="en-US" dirty="0"/>
           </a:p>
         </p:txBody>
       </p:sp>
@@ -7610,1097 +7420,6 @@
       </p:grpSpPr>
       <p:sp>
         <p:nvSpPr>
-          <p:cNvPr id="2" name="Title 1"/>
-          <p:cNvSpPr>
-            <a:spLocks noGrp="1"/>
-          </p:cNvSpPr>
-          <p:nvPr>
-            <p:ph type="title"/>
-          </p:nvPr>
-        </p:nvSpPr>
-        <p:spPr/>
-        <p:txBody>
-          <a:bodyPr/>
-          <a:lstStyle/>
-          <a:p>
-            <a:r>
-              <a:rPr lang="da-DK" dirty="0"/>
-              <a:t>Keyboard </a:t>
-            </a:r>
-            <a:r>
-              <a:rPr lang="da-DK" dirty="0" err="1"/>
-              <a:t>interrupt</a:t>
-            </a:r>
-            <a:r>
-              <a:rPr lang="da-DK" dirty="0"/>
-              <a:t> (</a:t>
-            </a:r>
-            <a:r>
-              <a:rPr lang="da-DK" i="1" dirty="0" err="1"/>
-              <a:t>Ctrl</a:t>
-            </a:r>
-            <a:r>
-              <a:rPr lang="da-DK" i="1" dirty="0"/>
-              <a:t>-c</a:t>
-            </a:r>
-            <a:r>
-              <a:rPr lang="da-DK" dirty="0"/>
-              <a:t>)</a:t>
-            </a:r>
-            <a:endParaRPr lang="en-US" dirty="0"/>
-          </a:p>
-        </p:txBody>
-      </p:sp>
-      <p:graphicFrame>
-        <p:nvGraphicFramePr>
-          <p:cNvPr id="4" name="Table 3"/>
-          <p:cNvGraphicFramePr>
-            <a:graphicFrameLocks noGrp="1"/>
-          </p:cNvGraphicFramePr>
-          <p:nvPr>
-            <p:extLst>
-              <p:ext uri="{D42A27DB-BD31-4B8C-83A1-F6EECF244321}">
-                <p14:modId xmlns:p14="http://schemas.microsoft.com/office/powerpoint/2010/main" val="62231603"/>
-              </p:ext>
-            </p:extLst>
-          </p:nvPr>
-        </p:nvGraphicFramePr>
-        <p:xfrm>
-          <a:off x="6448129" y="2506287"/>
-          <a:ext cx="4950143" cy="3535680"/>
-        </p:xfrm>
-        <a:graphic>
-          <a:graphicData uri="http://schemas.openxmlformats.org/drawingml/2006/table">
-            <a:tbl>
-              <a:tblPr firstRow="1" bandRow="1">
-                <a:tableStyleId>{5C22544A-7EE6-4342-B048-85BDC9FD1C3A}</a:tableStyleId>
-              </a:tblPr>
-              <a:tblGrid>
-                <a:gridCol w="4950143">
-                  <a:extLst>
-                    <a:ext uri="{9D8B030D-6E8A-4147-A177-3AD203B41FA5}">
-                      <a16:colId xmlns:a16="http://schemas.microsoft.com/office/drawing/2014/main" val="1873682825"/>
-                    </a:ext>
-                  </a:extLst>
-                </a:gridCol>
-              </a:tblGrid>
-              <a:tr h="303242">
-                <a:tc>
-                  <a:txBody>
-                    <a:bodyPr/>
-                    <a:lstStyle/>
-                    <a:p>
-                      <a:r>
-                        <a:rPr lang="da-DK" sz="1600" b="1" dirty="0">
-                          <a:latin typeface="Courier New" panose="02070309020205020404" pitchFamily="49" charset="0"/>
-                          <a:cs typeface="Courier New" panose="02070309020205020404" pitchFamily="49" charset="0"/>
-                        </a:rPr>
-                        <a:t>read-int2.py</a:t>
-                      </a:r>
-                    </a:p>
-                  </a:txBody>
-                  <a:tcPr anchor="ctr">
-                    <a:lnL w="6350" cap="flat" cmpd="sng" algn="ctr">
-                      <a:solidFill>
-                        <a:schemeClr val="tx1"/>
-                      </a:solidFill>
-                      <a:prstDash val="solid"/>
-                      <a:round/>
-                      <a:headEnd type="none" w="med" len="med"/>
-                      <a:tailEnd type="none" w="med" len="med"/>
-                    </a:lnL>
-                    <a:lnR w="6350" cap="flat" cmpd="sng" algn="ctr">
-                      <a:solidFill>
-                        <a:schemeClr val="tx1"/>
-                      </a:solidFill>
-                      <a:prstDash val="solid"/>
-                      <a:round/>
-                      <a:headEnd type="none" w="med" len="med"/>
-                      <a:tailEnd type="none" w="med" len="med"/>
-                    </a:lnR>
-                    <a:lnT w="6350" cap="flat" cmpd="sng" algn="ctr">
-                      <a:solidFill>
-                        <a:schemeClr val="tx1"/>
-                      </a:solidFill>
-                      <a:prstDash val="solid"/>
-                      <a:round/>
-                      <a:headEnd type="none" w="med" len="med"/>
-                      <a:tailEnd type="none" w="med" len="med"/>
-                    </a:lnT>
-                    <a:lnB w="6350" cap="flat" cmpd="sng" algn="ctr">
-                      <a:solidFill>
-                        <a:schemeClr val="tx1"/>
-                      </a:solidFill>
-                      <a:prstDash val="solid"/>
-                      <a:round/>
-                      <a:headEnd type="none" w="med" len="med"/>
-                      <a:tailEnd type="none" w="med" len="med"/>
-                    </a:lnB>
-                    <a:lnTlToBr w="12700" cmpd="sng">
-                      <a:noFill/>
-                      <a:prstDash val="solid"/>
-                    </a:lnTlToBr>
-                    <a:lnBlToTr w="12700" cmpd="sng">
-                      <a:noFill/>
-                      <a:prstDash val="solid"/>
-                    </a:lnBlToTr>
-                    <a:solidFill>
-                      <a:srgbClr val="C00000"/>
-                    </a:solidFill>
-                  </a:tcPr>
-                </a:tc>
-                <a:extLst>
-                  <a:ext uri="{0D108BD9-81ED-4DB2-BD59-A6C34878D82A}">
-                    <a16:rowId xmlns:a16="http://schemas.microsoft.com/office/drawing/2014/main" val="3330819881"/>
-                  </a:ext>
-                </a:extLst>
-              </a:tr>
-              <a:tr h="1970558">
-                <a:tc>
-                  <a:txBody>
-                    <a:bodyPr/>
-                    <a:lstStyle/>
-                    <a:p>
-                      <a:r>
-                        <a:rPr lang="en-US" sz="1600" b="1" dirty="0">
-                          <a:latin typeface="Courier New" panose="02070309020205020404" pitchFamily="49" charset="0"/>
-                          <a:cs typeface="Courier New" panose="02070309020205020404" pitchFamily="49" charset="0"/>
-                        </a:rPr>
-                        <a:t>while True:</a:t>
-                      </a:r>
-                    </a:p>
-                    <a:p>
-                      <a:r>
-                        <a:rPr lang="en-US" sz="1600" b="1" dirty="0">
-                          <a:latin typeface="Courier New" panose="02070309020205020404" pitchFamily="49" charset="0"/>
-                          <a:cs typeface="Courier New" panose="02070309020205020404" pitchFamily="49" charset="0"/>
-                        </a:rPr>
-                        <a:t>    try:</a:t>
-                      </a:r>
-                    </a:p>
-                    <a:p>
-                      <a:r>
-                        <a:rPr lang="en-US" sz="1600" b="1" dirty="0">
-                          <a:latin typeface="Courier New" panose="02070309020205020404" pitchFamily="49" charset="0"/>
-                          <a:cs typeface="Courier New" panose="02070309020205020404" pitchFamily="49" charset="0"/>
-                        </a:rPr>
-                        <a:t>        x = </a:t>
-                      </a:r>
-                      <a:r>
-                        <a:rPr lang="en-US" sz="1600" b="1" dirty="0" err="1">
-                          <a:latin typeface="Courier New" panose="02070309020205020404" pitchFamily="49" charset="0"/>
-                          <a:cs typeface="Courier New" panose="02070309020205020404" pitchFamily="49" charset="0"/>
-                        </a:rPr>
-                        <a:t>int</a:t>
-                      </a:r>
-                      <a:r>
-                        <a:rPr lang="en-US" sz="1600" b="1" dirty="0">
-                          <a:latin typeface="Courier New" panose="02070309020205020404" pitchFamily="49" charset="0"/>
-                          <a:cs typeface="Courier New" panose="02070309020205020404" pitchFamily="49" charset="0"/>
-                        </a:rPr>
-                        <a:t>(input('An integer: '))</a:t>
-                      </a:r>
-                    </a:p>
-                    <a:p>
-                      <a:r>
-                        <a:rPr lang="en-US" sz="1600" b="1" dirty="0">
-                          <a:latin typeface="Courier New" panose="02070309020205020404" pitchFamily="49" charset="0"/>
-                          <a:cs typeface="Courier New" panose="02070309020205020404" pitchFamily="49" charset="0"/>
-                        </a:rPr>
-                        <a:t>        break</a:t>
-                      </a:r>
-                    </a:p>
-                    <a:p>
-                      <a:r>
-                        <a:rPr lang="en-US" sz="1600" b="1" dirty="0">
-                          <a:solidFill>
-                            <a:srgbClr val="C00000"/>
-                          </a:solidFill>
-                          <a:latin typeface="Courier New" panose="02070309020205020404" pitchFamily="49" charset="0"/>
-                          <a:cs typeface="Courier New" panose="02070309020205020404" pitchFamily="49" charset="0"/>
-                        </a:rPr>
-                        <a:t>    except:  # all exceptions</a:t>
-                      </a:r>
-                    </a:p>
-                    <a:p>
-                      <a:r>
-                        <a:rPr lang="en-US" sz="1600" b="1" dirty="0">
-                          <a:latin typeface="Courier New" panose="02070309020205020404" pitchFamily="49" charset="0"/>
-                          <a:cs typeface="Courier New" panose="02070309020205020404" pitchFamily="49" charset="0"/>
-                        </a:rPr>
-                        <a:t>        continue</a:t>
-                      </a:r>
-                    </a:p>
-                    <a:p>
-                      <a:endParaRPr lang="en-US" sz="1600" b="1" dirty="0">
-                        <a:latin typeface="Courier New" panose="02070309020205020404" pitchFamily="49" charset="0"/>
-                        <a:cs typeface="Courier New" panose="02070309020205020404" pitchFamily="49" charset="0"/>
-                      </a:endParaRPr>
-                    </a:p>
-                    <a:p>
-                      <a:r>
-                        <a:rPr lang="en-US" sz="1600" b="1" dirty="0">
-                          <a:latin typeface="Courier New" panose="02070309020205020404" pitchFamily="49" charset="0"/>
-                          <a:cs typeface="Courier New" panose="02070309020205020404" pitchFamily="49" charset="0"/>
-                        </a:rPr>
-                        <a:t>print('The value is:', x)</a:t>
-                      </a:r>
-                    </a:p>
-                  </a:txBody>
-                  <a:tcPr>
-                    <a:lnL w="6350" cap="flat" cmpd="sng" algn="ctr">
-                      <a:solidFill>
-                        <a:schemeClr val="tx1"/>
-                      </a:solidFill>
-                      <a:prstDash val="solid"/>
-                      <a:round/>
-                      <a:headEnd type="none" w="med" len="med"/>
-                      <a:tailEnd type="none" w="med" len="med"/>
-                    </a:lnL>
-                    <a:lnR w="6350" cap="flat" cmpd="sng" algn="ctr">
-                      <a:solidFill>
-                        <a:schemeClr val="tx1"/>
-                      </a:solidFill>
-                      <a:prstDash val="solid"/>
-                      <a:round/>
-                      <a:headEnd type="none" w="med" len="med"/>
-                      <a:tailEnd type="none" w="med" len="med"/>
-                    </a:lnR>
-                    <a:lnT w="6350" cap="flat" cmpd="sng" algn="ctr">
-                      <a:solidFill>
-                        <a:schemeClr val="tx1"/>
-                      </a:solidFill>
-                      <a:prstDash val="solid"/>
-                      <a:round/>
-                      <a:headEnd type="none" w="med" len="med"/>
-                      <a:tailEnd type="none" w="med" len="med"/>
-                    </a:lnT>
-                    <a:lnB w="6350" cap="flat" cmpd="sng" algn="ctr">
-                      <a:solidFill>
-                        <a:schemeClr val="tx1"/>
-                      </a:solidFill>
-                      <a:prstDash val="solid"/>
-                      <a:round/>
-                      <a:headEnd type="none" w="med" len="med"/>
-                      <a:tailEnd type="none" w="med" len="med"/>
-                    </a:lnB>
-                    <a:lnTlToBr w="12700" cmpd="sng">
-                      <a:noFill/>
-                      <a:prstDash val="solid"/>
-                    </a:lnTlToBr>
-                    <a:lnBlToTr w="12700" cmpd="sng">
-                      <a:noFill/>
-                      <a:prstDash val="solid"/>
-                    </a:lnBlToTr>
-                    <a:solidFill>
-                      <a:schemeClr val="accent5">
-                        <a:lumMod val="20000"/>
-                        <a:lumOff val="80000"/>
-                      </a:schemeClr>
-                    </a:solidFill>
-                  </a:tcPr>
-                </a:tc>
-                <a:extLst>
-                  <a:ext uri="{0D108BD9-81ED-4DB2-BD59-A6C34878D82A}">
-                    <a16:rowId xmlns:a16="http://schemas.microsoft.com/office/drawing/2014/main" val="4112970457"/>
-                  </a:ext>
-                </a:extLst>
-              </a:tr>
-              <a:tr h="303242">
-                <a:tc>
-                  <a:txBody>
-                    <a:bodyPr/>
-                    <a:lstStyle/>
-                    <a:p>
-                      <a:r>
-                        <a:rPr lang="da-DK" sz="1600" b="1" dirty="0" err="1">
-                          <a:solidFill>
-                            <a:schemeClr val="bg1"/>
-                          </a:solidFill>
-                          <a:latin typeface="Courier New" panose="02070309020205020404" pitchFamily="49" charset="0"/>
-                          <a:cs typeface="Courier New" panose="02070309020205020404" pitchFamily="49" charset="0"/>
-                        </a:rPr>
-                        <a:t>Python</a:t>
-                      </a:r>
-                      <a:r>
-                        <a:rPr lang="da-DK" sz="1600" b="1" dirty="0">
-                          <a:solidFill>
-                            <a:schemeClr val="bg1"/>
-                          </a:solidFill>
-                          <a:latin typeface="Courier New" panose="02070309020205020404" pitchFamily="49" charset="0"/>
-                          <a:cs typeface="Courier New" panose="02070309020205020404" pitchFamily="49" charset="0"/>
-                        </a:rPr>
-                        <a:t> </a:t>
-                      </a:r>
-                      <a:r>
-                        <a:rPr lang="da-DK" sz="1600" b="1" dirty="0" err="1">
-                          <a:solidFill>
-                            <a:schemeClr val="bg1"/>
-                          </a:solidFill>
-                          <a:latin typeface="Courier New" panose="02070309020205020404" pitchFamily="49" charset="0"/>
-                          <a:cs typeface="Courier New" panose="02070309020205020404" pitchFamily="49" charset="0"/>
-                        </a:rPr>
-                        <a:t>shell</a:t>
-                      </a:r>
-                      <a:endParaRPr lang="da-DK" sz="1600" b="1" dirty="0">
-                        <a:solidFill>
-                          <a:schemeClr val="bg1"/>
-                        </a:solidFill>
-                        <a:latin typeface="Courier New" panose="02070309020205020404" pitchFamily="49" charset="0"/>
-                        <a:cs typeface="Courier New" panose="02070309020205020404" pitchFamily="49" charset="0"/>
-                      </a:endParaRPr>
-                    </a:p>
-                  </a:txBody>
-                  <a:tcPr>
-                    <a:lnL w="6350" cap="flat" cmpd="sng" algn="ctr">
-                      <a:solidFill>
-                        <a:schemeClr val="tx1"/>
-                      </a:solidFill>
-                      <a:prstDash val="solid"/>
-                      <a:round/>
-                      <a:headEnd type="none" w="med" len="med"/>
-                      <a:tailEnd type="none" w="med" len="med"/>
-                    </a:lnL>
-                    <a:lnR w="6350" cap="flat" cmpd="sng" algn="ctr">
-                      <a:solidFill>
-                        <a:schemeClr val="tx1"/>
-                      </a:solidFill>
-                      <a:prstDash val="solid"/>
-                      <a:round/>
-                      <a:headEnd type="none" w="med" len="med"/>
-                      <a:tailEnd type="none" w="med" len="med"/>
-                    </a:lnR>
-                    <a:lnT w="6350" cap="flat" cmpd="sng" algn="ctr">
-                      <a:solidFill>
-                        <a:schemeClr val="tx1"/>
-                      </a:solidFill>
-                      <a:prstDash val="solid"/>
-                      <a:round/>
-                      <a:headEnd type="none" w="med" len="med"/>
-                      <a:tailEnd type="none" w="med" len="med"/>
-                    </a:lnT>
-                    <a:lnB w="6350" cap="flat" cmpd="sng" algn="ctr">
-                      <a:solidFill>
-                        <a:schemeClr val="tx1"/>
-                      </a:solidFill>
-                      <a:prstDash val="solid"/>
-                      <a:round/>
-                      <a:headEnd type="none" w="med" len="med"/>
-                      <a:tailEnd type="none" w="med" len="med"/>
-                    </a:lnB>
-                    <a:lnTlToBr w="12700" cmpd="sng">
-                      <a:noFill/>
-                      <a:prstDash val="solid"/>
-                    </a:lnTlToBr>
-                    <a:lnBlToTr w="12700" cmpd="sng">
-                      <a:noFill/>
-                      <a:prstDash val="solid"/>
-                    </a:lnBlToTr>
-                    <a:solidFill>
-                      <a:srgbClr val="C00000"/>
-                    </a:solidFill>
-                  </a:tcPr>
-                </a:tc>
-                <a:extLst>
-                  <a:ext uri="{0D108BD9-81ED-4DB2-BD59-A6C34878D82A}">
-                    <a16:rowId xmlns:a16="http://schemas.microsoft.com/office/drawing/2014/main" val="2202042958"/>
-                  </a:ext>
-                </a:extLst>
-              </a:tr>
-              <a:tr h="806691">
-                <a:tc>
-                  <a:txBody>
-                    <a:bodyPr/>
-                    <a:lstStyle/>
-                    <a:p>
-                      <a:pPr marL="266700" indent="-266700">
-                        <a:buClr>
-                          <a:schemeClr val="accent1">
-                            <a:lumMod val="50000"/>
-                          </a:schemeClr>
-                        </a:buClr>
-                        <a:buSzPct val="120000"/>
-                        <a:buFont typeface="Courier New" panose="02070309020205020404" pitchFamily="49" charset="0"/>
-                        <a:buChar char="|"/>
-                      </a:pPr>
-                      <a:r>
-                        <a:rPr lang="de-DE" sz="1600" b="1" baseline="0" dirty="0">
-                          <a:latin typeface="Courier New" panose="02070309020205020404" pitchFamily="49" charset="0"/>
-                          <a:cs typeface="Courier New" panose="02070309020205020404" pitchFamily="49" charset="0"/>
-                        </a:rPr>
-                        <a:t>An integer</a:t>
-                      </a:r>
-                      <a:r>
-                        <a:rPr lang="en-US" sz="1600" b="1" baseline="0" dirty="0">
-                          <a:latin typeface="Courier New" panose="02070309020205020404" pitchFamily="49" charset="0"/>
-                          <a:cs typeface="Courier New" panose="02070309020205020404" pitchFamily="49" charset="0"/>
-                        </a:rPr>
-                        <a:t>:         </a:t>
-                      </a:r>
-                      <a:r>
-                        <a:rPr lang="en-US" sz="1600" b="1" i="1" baseline="0" dirty="0">
-                          <a:solidFill>
-                            <a:srgbClr val="C00000"/>
-                          </a:solidFill>
-                          <a:latin typeface="Courier New" panose="02070309020205020404" pitchFamily="49" charset="0"/>
-                          <a:cs typeface="Courier New" panose="02070309020205020404" pitchFamily="49" charset="0"/>
-                        </a:rPr>
-                        <a:t>Ctrl-c</a:t>
-                      </a:r>
-                      <a:endParaRPr lang="de-DE" sz="1600" b="1" baseline="0" dirty="0">
-                        <a:latin typeface="Courier New" panose="02070309020205020404" pitchFamily="49" charset="0"/>
-                        <a:cs typeface="Courier New" panose="02070309020205020404" pitchFamily="49" charset="0"/>
-                      </a:endParaRPr>
-                    </a:p>
-                    <a:p>
-                      <a:pPr marL="266700" indent="-266700">
-                        <a:buClr>
-                          <a:schemeClr val="accent1">
-                            <a:lumMod val="50000"/>
-                          </a:schemeClr>
-                        </a:buClr>
-                        <a:buSzPct val="120000"/>
-                        <a:buFont typeface="Courier New" panose="02070309020205020404" pitchFamily="49" charset="0"/>
-                        <a:buChar char="|"/>
-                      </a:pPr>
-                      <a:r>
-                        <a:rPr lang="de-DE" sz="1600" b="1" baseline="0" dirty="0">
-                          <a:latin typeface="Courier New" panose="02070309020205020404" pitchFamily="49" charset="0"/>
-                          <a:cs typeface="Courier New" panose="02070309020205020404" pitchFamily="49" charset="0"/>
-                        </a:rPr>
-                        <a:t>An integer</a:t>
-                      </a:r>
-                      <a:r>
-                        <a:rPr lang="en-US" sz="1600" b="1" baseline="0" dirty="0">
-                          <a:latin typeface="Courier New" panose="02070309020205020404" pitchFamily="49" charset="0"/>
-                          <a:cs typeface="Courier New" panose="02070309020205020404" pitchFamily="49" charset="0"/>
-                        </a:rPr>
-                        <a:t>:         </a:t>
-                      </a:r>
-                      <a:r>
-                        <a:rPr lang="en-US" sz="1600" b="1" i="1" baseline="0" dirty="0">
-                          <a:solidFill>
-                            <a:srgbClr val="C00000"/>
-                          </a:solidFill>
-                          <a:latin typeface="Courier New" panose="02070309020205020404" pitchFamily="49" charset="0"/>
-                          <a:cs typeface="Courier New" panose="02070309020205020404" pitchFamily="49" charset="0"/>
-                        </a:rPr>
-                        <a:t>Ctrl-c</a:t>
-                      </a:r>
-                      <a:endParaRPr lang="de-DE" sz="1600" b="1" baseline="0" dirty="0">
-                        <a:latin typeface="Courier New" panose="02070309020205020404" pitchFamily="49" charset="0"/>
-                        <a:cs typeface="Courier New" panose="02070309020205020404" pitchFamily="49" charset="0"/>
-                      </a:endParaRPr>
-                    </a:p>
-                    <a:p>
-                      <a:pPr marL="266700" indent="-266700">
-                        <a:buClr>
-                          <a:schemeClr val="accent1">
-                            <a:lumMod val="50000"/>
-                          </a:schemeClr>
-                        </a:buClr>
-                        <a:buSzPct val="120000"/>
-                        <a:buFont typeface="Courier New" panose="02070309020205020404" pitchFamily="49" charset="0"/>
-                        <a:buChar char="|"/>
-                      </a:pPr>
-                      <a:r>
-                        <a:rPr lang="de-DE" sz="1600" b="1" baseline="0" dirty="0">
-                          <a:latin typeface="Courier New" panose="02070309020205020404" pitchFamily="49" charset="0"/>
-                          <a:cs typeface="Courier New" panose="02070309020205020404" pitchFamily="49" charset="0"/>
-                        </a:rPr>
-                        <a:t>An integer:</a:t>
-                      </a:r>
-                      <a:endParaRPr lang="en-US" sz="1600" b="1" baseline="0" dirty="0">
-                        <a:latin typeface="Courier New" panose="02070309020205020404" pitchFamily="49" charset="0"/>
-                        <a:cs typeface="Courier New" panose="02070309020205020404" pitchFamily="49" charset="0"/>
-                      </a:endParaRPr>
-                    </a:p>
-                  </a:txBody>
-                  <a:tcPr>
-                    <a:lnL w="6350" cap="flat" cmpd="sng" algn="ctr">
-                      <a:solidFill>
-                        <a:schemeClr val="tx1"/>
-                      </a:solidFill>
-                      <a:prstDash val="solid"/>
-                      <a:round/>
-                      <a:headEnd type="none" w="med" len="med"/>
-                      <a:tailEnd type="none" w="med" len="med"/>
-                    </a:lnL>
-                    <a:lnR w="6350" cap="flat" cmpd="sng" algn="ctr">
-                      <a:solidFill>
-                        <a:schemeClr val="tx1"/>
-                      </a:solidFill>
-                      <a:prstDash val="solid"/>
-                      <a:round/>
-                      <a:headEnd type="none" w="med" len="med"/>
-                      <a:tailEnd type="none" w="med" len="med"/>
-                    </a:lnR>
-                    <a:lnT w="6350" cap="flat" cmpd="sng" algn="ctr">
-                      <a:solidFill>
-                        <a:schemeClr val="tx1"/>
-                      </a:solidFill>
-                      <a:prstDash val="solid"/>
-                      <a:round/>
-                      <a:headEnd type="none" w="med" len="med"/>
-                      <a:tailEnd type="none" w="med" len="med"/>
-                    </a:lnT>
-                    <a:lnB w="6350" cap="flat" cmpd="sng" algn="ctr">
-                      <a:solidFill>
-                        <a:schemeClr val="tx1"/>
-                      </a:solidFill>
-                      <a:prstDash val="solid"/>
-                      <a:round/>
-                      <a:headEnd type="none" w="med" len="med"/>
-                      <a:tailEnd type="none" w="med" len="med"/>
-                    </a:lnB>
-                    <a:lnTlToBr w="12700" cmpd="sng">
-                      <a:noFill/>
-                      <a:prstDash val="solid"/>
-                    </a:lnTlToBr>
-                    <a:lnBlToTr w="12700" cmpd="sng">
-                      <a:noFill/>
-                      <a:prstDash val="solid"/>
-                    </a:lnBlToTr>
-                    <a:solidFill>
-                      <a:schemeClr val="accent5">
-                        <a:lumMod val="20000"/>
-                        <a:lumOff val="80000"/>
-                      </a:schemeClr>
-                    </a:solidFill>
-                  </a:tcPr>
-                </a:tc>
-                <a:extLst>
-                  <a:ext uri="{0D108BD9-81ED-4DB2-BD59-A6C34878D82A}">
-                    <a16:rowId xmlns:a16="http://schemas.microsoft.com/office/drawing/2014/main" val="25355368"/>
-                  </a:ext>
-                </a:extLst>
-              </a:tr>
-            </a:tbl>
-          </a:graphicData>
-        </a:graphic>
-      </p:graphicFrame>
-      <p:graphicFrame>
-        <p:nvGraphicFramePr>
-          <p:cNvPr id="5" name="Table 4"/>
-          <p:cNvGraphicFramePr>
-            <a:graphicFrameLocks noGrp="1"/>
-          </p:cNvGraphicFramePr>
-          <p:nvPr>
-            <p:extLst>
-              <p:ext uri="{D42A27DB-BD31-4B8C-83A1-F6EECF244321}">
-                <p14:modId xmlns:p14="http://schemas.microsoft.com/office/powerpoint/2010/main" val="727537512"/>
-              </p:ext>
-            </p:extLst>
-          </p:nvPr>
-        </p:nvGraphicFramePr>
-        <p:xfrm>
-          <a:off x="790937" y="2505855"/>
-          <a:ext cx="5316855" cy="3536112"/>
-        </p:xfrm>
-        <a:graphic>
-          <a:graphicData uri="http://schemas.openxmlformats.org/drawingml/2006/table">
-            <a:tbl>
-              <a:tblPr firstRow="1" bandRow="1">
-                <a:tableStyleId>{5C22544A-7EE6-4342-B048-85BDC9FD1C3A}</a:tableStyleId>
-              </a:tblPr>
-              <a:tblGrid>
-                <a:gridCol w="5316855">
-                  <a:extLst>
-                    <a:ext uri="{9D8B030D-6E8A-4147-A177-3AD203B41FA5}">
-                      <a16:colId xmlns:a16="http://schemas.microsoft.com/office/drawing/2014/main" val="1873682825"/>
-                    </a:ext>
-                  </a:extLst>
-                </a:gridCol>
-              </a:tblGrid>
-              <a:tr h="289086">
-                <a:tc>
-                  <a:txBody>
-                    <a:bodyPr/>
-                    <a:lstStyle/>
-                    <a:p>
-                      <a:r>
-                        <a:rPr lang="da-DK" sz="1600" b="1" dirty="0">
-                          <a:latin typeface="Courier New" panose="02070309020205020404" pitchFamily="49" charset="0"/>
-                          <a:cs typeface="Courier New" panose="02070309020205020404" pitchFamily="49" charset="0"/>
-                        </a:rPr>
-                        <a:t>read-int1.py</a:t>
-                      </a:r>
-                    </a:p>
-                  </a:txBody>
-                  <a:tcPr anchor="ctr">
-                    <a:lnL w="6350" cap="flat" cmpd="sng" algn="ctr">
-                      <a:solidFill>
-                        <a:schemeClr val="tx1"/>
-                      </a:solidFill>
-                      <a:prstDash val="solid"/>
-                      <a:round/>
-                      <a:headEnd type="none" w="med" len="med"/>
-                      <a:tailEnd type="none" w="med" len="med"/>
-                    </a:lnL>
-                    <a:lnR w="6350" cap="flat" cmpd="sng" algn="ctr">
-                      <a:solidFill>
-                        <a:schemeClr val="tx1"/>
-                      </a:solidFill>
-                      <a:prstDash val="solid"/>
-                      <a:round/>
-                      <a:headEnd type="none" w="med" len="med"/>
-                      <a:tailEnd type="none" w="med" len="med"/>
-                    </a:lnR>
-                    <a:lnT w="6350" cap="flat" cmpd="sng" algn="ctr">
-                      <a:solidFill>
-                        <a:schemeClr val="tx1"/>
-                      </a:solidFill>
-                      <a:prstDash val="solid"/>
-                      <a:round/>
-                      <a:headEnd type="none" w="med" len="med"/>
-                      <a:tailEnd type="none" w="med" len="med"/>
-                    </a:lnT>
-                    <a:lnB w="6350" cap="flat" cmpd="sng" algn="ctr">
-                      <a:solidFill>
-                        <a:schemeClr val="tx1"/>
-                      </a:solidFill>
-                      <a:prstDash val="solid"/>
-                      <a:round/>
-                      <a:headEnd type="none" w="med" len="med"/>
-                      <a:tailEnd type="none" w="med" len="med"/>
-                    </a:lnB>
-                    <a:lnTlToBr w="12700" cmpd="sng">
-                      <a:noFill/>
-                      <a:prstDash val="solid"/>
-                    </a:lnTlToBr>
-                    <a:lnBlToTr w="12700" cmpd="sng">
-                      <a:noFill/>
-                      <a:prstDash val="solid"/>
-                    </a:lnBlToTr>
-                    <a:solidFill>
-                      <a:srgbClr val="C00000"/>
-                    </a:solidFill>
-                  </a:tcPr>
-                </a:tc>
-                <a:extLst>
-                  <a:ext uri="{0D108BD9-81ED-4DB2-BD59-A6C34878D82A}">
-                    <a16:rowId xmlns:a16="http://schemas.microsoft.com/office/drawing/2014/main" val="3330819881"/>
-                  </a:ext>
-                </a:extLst>
-              </a:tr>
-              <a:tr h="1760798">
-                <a:tc>
-                  <a:txBody>
-                    <a:bodyPr/>
-                    <a:lstStyle/>
-                    <a:p>
-                      <a:r>
-                        <a:rPr lang="en-US" sz="1600" b="1" dirty="0">
-                          <a:latin typeface="Courier New" panose="02070309020205020404" pitchFamily="49" charset="0"/>
-                          <a:cs typeface="Courier New" panose="02070309020205020404" pitchFamily="49" charset="0"/>
-                        </a:rPr>
-                        <a:t>while True:</a:t>
-                      </a:r>
-                    </a:p>
-                    <a:p>
-                      <a:r>
-                        <a:rPr lang="en-US" sz="1600" b="1" dirty="0">
-                          <a:latin typeface="Courier New" panose="02070309020205020404" pitchFamily="49" charset="0"/>
-                          <a:cs typeface="Courier New" panose="02070309020205020404" pitchFamily="49" charset="0"/>
-                        </a:rPr>
-                        <a:t>    try:</a:t>
-                      </a:r>
-                    </a:p>
-                    <a:p>
-                      <a:r>
-                        <a:rPr lang="en-US" sz="1600" b="1" dirty="0">
-                          <a:latin typeface="Courier New" panose="02070309020205020404" pitchFamily="49" charset="0"/>
-                          <a:cs typeface="Courier New" panose="02070309020205020404" pitchFamily="49" charset="0"/>
-                        </a:rPr>
-                        <a:t>        x = </a:t>
-                      </a:r>
-                      <a:r>
-                        <a:rPr lang="en-US" sz="1600" b="1" dirty="0" err="1">
-                          <a:latin typeface="Courier New" panose="02070309020205020404" pitchFamily="49" charset="0"/>
-                          <a:cs typeface="Courier New" panose="02070309020205020404" pitchFamily="49" charset="0"/>
-                        </a:rPr>
-                        <a:t>int</a:t>
-                      </a:r>
-                      <a:r>
-                        <a:rPr lang="en-US" sz="1600" b="1" dirty="0">
-                          <a:latin typeface="Courier New" panose="02070309020205020404" pitchFamily="49" charset="0"/>
-                          <a:cs typeface="Courier New" panose="02070309020205020404" pitchFamily="49" charset="0"/>
-                        </a:rPr>
-                        <a:t>(input('An integer: '))</a:t>
-                      </a:r>
-                    </a:p>
-                    <a:p>
-                      <a:r>
-                        <a:rPr lang="en-US" sz="1600" b="1" dirty="0">
-                          <a:latin typeface="Courier New" panose="02070309020205020404" pitchFamily="49" charset="0"/>
-                          <a:cs typeface="Courier New" panose="02070309020205020404" pitchFamily="49" charset="0"/>
-                        </a:rPr>
-                        <a:t>        break</a:t>
-                      </a:r>
-                    </a:p>
-                    <a:p>
-                      <a:r>
-                        <a:rPr lang="en-US" sz="1600" b="1" dirty="0">
-                          <a:solidFill>
-                            <a:srgbClr val="C00000"/>
-                          </a:solidFill>
-                          <a:latin typeface="Courier New" panose="02070309020205020404" pitchFamily="49" charset="0"/>
-                          <a:cs typeface="Courier New" panose="02070309020205020404" pitchFamily="49" charset="0"/>
-                        </a:rPr>
-                        <a:t>    except </a:t>
-                      </a:r>
-                      <a:r>
-                        <a:rPr lang="en-US" sz="1600" b="1" dirty="0" err="1">
-                          <a:solidFill>
-                            <a:srgbClr val="C00000"/>
-                          </a:solidFill>
-                          <a:latin typeface="Courier New" panose="02070309020205020404" pitchFamily="49" charset="0"/>
-                          <a:cs typeface="Courier New" panose="02070309020205020404" pitchFamily="49" charset="0"/>
-                        </a:rPr>
-                        <a:t>ValueError</a:t>
-                      </a:r>
-                      <a:r>
-                        <a:rPr lang="en-US" sz="1600" b="1" dirty="0">
-                          <a:solidFill>
-                            <a:srgbClr val="C00000"/>
-                          </a:solidFill>
-                          <a:latin typeface="Courier New" panose="02070309020205020404" pitchFamily="49" charset="0"/>
-                          <a:cs typeface="Courier New" panose="02070309020205020404" pitchFamily="49" charset="0"/>
-                        </a:rPr>
-                        <a:t>:  # only </a:t>
-                      </a:r>
-                      <a:r>
-                        <a:rPr lang="en-US" sz="1600" b="1" dirty="0" err="1">
-                          <a:solidFill>
-                            <a:srgbClr val="C00000"/>
-                          </a:solidFill>
-                          <a:latin typeface="Courier New" panose="02070309020205020404" pitchFamily="49" charset="0"/>
-                          <a:cs typeface="Courier New" panose="02070309020205020404" pitchFamily="49" charset="0"/>
-                        </a:rPr>
-                        <a:t>ValueError</a:t>
-                      </a:r>
-                      <a:endParaRPr lang="en-US" sz="1600" b="1" dirty="0">
-                        <a:solidFill>
-                          <a:srgbClr val="C00000"/>
-                        </a:solidFill>
-                        <a:latin typeface="Courier New" panose="02070309020205020404" pitchFamily="49" charset="0"/>
-                        <a:cs typeface="Courier New" panose="02070309020205020404" pitchFamily="49" charset="0"/>
-                      </a:endParaRPr>
-                    </a:p>
-                    <a:p>
-                      <a:r>
-                        <a:rPr lang="en-US" sz="1600" b="1" dirty="0">
-                          <a:latin typeface="Courier New" panose="02070309020205020404" pitchFamily="49" charset="0"/>
-                          <a:cs typeface="Courier New" panose="02070309020205020404" pitchFamily="49" charset="0"/>
-                        </a:rPr>
-                        <a:t>        continue</a:t>
-                      </a:r>
-                    </a:p>
-                    <a:p>
-                      <a:endParaRPr lang="en-US" sz="1600" b="1" dirty="0">
-                        <a:latin typeface="Courier New" panose="02070309020205020404" pitchFamily="49" charset="0"/>
-                        <a:cs typeface="Courier New" panose="02070309020205020404" pitchFamily="49" charset="0"/>
-                      </a:endParaRPr>
-                    </a:p>
-                    <a:p>
-                      <a:r>
-                        <a:rPr lang="en-US" sz="1600" b="1" dirty="0">
-                          <a:latin typeface="Courier New" panose="02070309020205020404" pitchFamily="49" charset="0"/>
-                          <a:cs typeface="Courier New" panose="02070309020205020404" pitchFamily="49" charset="0"/>
-                        </a:rPr>
-                        <a:t>print('The value is:', x)</a:t>
-                      </a:r>
-                    </a:p>
-                  </a:txBody>
-                  <a:tcPr>
-                    <a:lnL w="6350" cap="flat" cmpd="sng" algn="ctr">
-                      <a:solidFill>
-                        <a:schemeClr val="tx1"/>
-                      </a:solidFill>
-                      <a:prstDash val="solid"/>
-                      <a:round/>
-                      <a:headEnd type="none" w="med" len="med"/>
-                      <a:tailEnd type="none" w="med" len="med"/>
-                    </a:lnL>
-                    <a:lnR w="6350" cap="flat" cmpd="sng" algn="ctr">
-                      <a:solidFill>
-                        <a:schemeClr val="tx1"/>
-                      </a:solidFill>
-                      <a:prstDash val="solid"/>
-                      <a:round/>
-                      <a:headEnd type="none" w="med" len="med"/>
-                      <a:tailEnd type="none" w="med" len="med"/>
-                    </a:lnR>
-                    <a:lnT w="6350" cap="flat" cmpd="sng" algn="ctr">
-                      <a:solidFill>
-                        <a:schemeClr val="tx1"/>
-                      </a:solidFill>
-                      <a:prstDash val="solid"/>
-                      <a:round/>
-                      <a:headEnd type="none" w="med" len="med"/>
-                      <a:tailEnd type="none" w="med" len="med"/>
-                    </a:lnT>
-                    <a:lnB w="6350" cap="flat" cmpd="sng" algn="ctr">
-                      <a:solidFill>
-                        <a:schemeClr val="tx1"/>
-                      </a:solidFill>
-                      <a:prstDash val="solid"/>
-                      <a:round/>
-                      <a:headEnd type="none" w="med" len="med"/>
-                      <a:tailEnd type="none" w="med" len="med"/>
-                    </a:lnB>
-                    <a:lnTlToBr w="12700" cmpd="sng">
-                      <a:noFill/>
-                      <a:prstDash val="solid"/>
-                    </a:lnTlToBr>
-                    <a:lnBlToTr w="12700" cmpd="sng">
-                      <a:noFill/>
-                      <a:prstDash val="solid"/>
-                    </a:lnBlToTr>
-                    <a:solidFill>
-                      <a:schemeClr val="accent5">
-                        <a:lumMod val="20000"/>
-                        <a:lumOff val="80000"/>
-                      </a:schemeClr>
-                    </a:solidFill>
-                  </a:tcPr>
-                </a:tc>
-                <a:extLst>
-                  <a:ext uri="{0D108BD9-81ED-4DB2-BD59-A6C34878D82A}">
-                    <a16:rowId xmlns:a16="http://schemas.microsoft.com/office/drawing/2014/main" val="4112970457"/>
-                  </a:ext>
-                </a:extLst>
-              </a:tr>
-              <a:tr h="289086">
-                <a:tc>
-                  <a:txBody>
-                    <a:bodyPr/>
-                    <a:lstStyle/>
-                    <a:p>
-                      <a:r>
-                        <a:rPr lang="da-DK" sz="1600" b="1" dirty="0" err="1">
-                          <a:solidFill>
-                            <a:schemeClr val="bg1"/>
-                          </a:solidFill>
-                          <a:latin typeface="Courier New" panose="02070309020205020404" pitchFamily="49" charset="0"/>
-                          <a:cs typeface="Courier New" panose="02070309020205020404" pitchFamily="49" charset="0"/>
-                        </a:rPr>
-                        <a:t>Python</a:t>
-                      </a:r>
-                      <a:r>
-                        <a:rPr lang="da-DK" sz="1600" b="1" dirty="0">
-                          <a:solidFill>
-                            <a:schemeClr val="bg1"/>
-                          </a:solidFill>
-                          <a:latin typeface="Courier New" panose="02070309020205020404" pitchFamily="49" charset="0"/>
-                          <a:cs typeface="Courier New" panose="02070309020205020404" pitchFamily="49" charset="0"/>
-                        </a:rPr>
-                        <a:t> </a:t>
-                      </a:r>
-                      <a:r>
-                        <a:rPr lang="da-DK" sz="1600" b="1" dirty="0" err="1">
-                          <a:solidFill>
-                            <a:schemeClr val="bg1"/>
-                          </a:solidFill>
-                          <a:latin typeface="Courier New" panose="02070309020205020404" pitchFamily="49" charset="0"/>
-                          <a:cs typeface="Courier New" panose="02070309020205020404" pitchFamily="49" charset="0"/>
-                        </a:rPr>
-                        <a:t>shell</a:t>
-                      </a:r>
-                      <a:endParaRPr lang="da-DK" sz="1600" b="1" dirty="0">
-                        <a:solidFill>
-                          <a:schemeClr val="bg1"/>
-                        </a:solidFill>
-                        <a:latin typeface="Courier New" panose="02070309020205020404" pitchFamily="49" charset="0"/>
-                        <a:cs typeface="Courier New" panose="02070309020205020404" pitchFamily="49" charset="0"/>
-                      </a:endParaRPr>
-                    </a:p>
-                  </a:txBody>
-                  <a:tcPr>
-                    <a:lnL w="6350" cap="flat" cmpd="sng" algn="ctr">
-                      <a:solidFill>
-                        <a:schemeClr val="tx1"/>
-                      </a:solidFill>
-                      <a:prstDash val="solid"/>
-                      <a:round/>
-                      <a:headEnd type="none" w="med" len="med"/>
-                      <a:tailEnd type="none" w="med" len="med"/>
-                    </a:lnL>
-                    <a:lnR w="6350" cap="flat" cmpd="sng" algn="ctr">
-                      <a:solidFill>
-                        <a:schemeClr val="tx1"/>
-                      </a:solidFill>
-                      <a:prstDash val="solid"/>
-                      <a:round/>
-                      <a:headEnd type="none" w="med" len="med"/>
-                      <a:tailEnd type="none" w="med" len="med"/>
-                    </a:lnR>
-                    <a:lnT w="6350" cap="flat" cmpd="sng" algn="ctr">
-                      <a:solidFill>
-                        <a:schemeClr val="tx1"/>
-                      </a:solidFill>
-                      <a:prstDash val="solid"/>
-                      <a:round/>
-                      <a:headEnd type="none" w="med" len="med"/>
-                      <a:tailEnd type="none" w="med" len="med"/>
-                    </a:lnT>
-                    <a:lnB w="6350" cap="flat" cmpd="sng" algn="ctr">
-                      <a:solidFill>
-                        <a:schemeClr val="tx1"/>
-                      </a:solidFill>
-                      <a:prstDash val="solid"/>
-                      <a:round/>
-                      <a:headEnd type="none" w="med" len="med"/>
-                      <a:tailEnd type="none" w="med" len="med"/>
-                    </a:lnB>
-                    <a:lnTlToBr w="12700" cmpd="sng">
-                      <a:noFill/>
-                      <a:prstDash val="solid"/>
-                    </a:lnTlToBr>
-                    <a:lnBlToTr w="12700" cmpd="sng">
-                      <a:noFill/>
-                      <a:prstDash val="solid"/>
-                    </a:lnBlToTr>
-                    <a:solidFill>
-                      <a:srgbClr val="C00000"/>
-                    </a:solidFill>
-                  </a:tcPr>
-                </a:tc>
-                <a:extLst>
-                  <a:ext uri="{0D108BD9-81ED-4DB2-BD59-A6C34878D82A}">
-                    <a16:rowId xmlns:a16="http://schemas.microsoft.com/office/drawing/2014/main" val="2202042958"/>
-                  </a:ext>
-                </a:extLst>
-              </a:tr>
-              <a:tr h="823392">
-                <a:tc>
-                  <a:txBody>
-                    <a:bodyPr/>
-                    <a:lstStyle/>
-                    <a:p>
-                      <a:pPr marL="266700" indent="-266700">
-                        <a:buClr>
-                          <a:schemeClr val="accent1">
-                            <a:lumMod val="50000"/>
-                          </a:schemeClr>
-                        </a:buClr>
-                        <a:buSzPct val="120000"/>
-                        <a:buFont typeface="Courier New" panose="02070309020205020404" pitchFamily="49" charset="0"/>
-                        <a:buChar char="|"/>
-                      </a:pPr>
-                      <a:r>
-                        <a:rPr lang="en-US" sz="1600" b="1" baseline="0" dirty="0">
-                          <a:latin typeface="Courier New" panose="02070309020205020404" pitchFamily="49" charset="0"/>
-                          <a:cs typeface="Courier New" panose="02070309020205020404" pitchFamily="49" charset="0"/>
-                        </a:rPr>
-                        <a:t>An integer:              </a:t>
-                      </a:r>
-                      <a:r>
-                        <a:rPr lang="en-US" sz="1600" b="1" i="1" baseline="0" dirty="0">
-                          <a:solidFill>
-                            <a:srgbClr val="C00000"/>
-                          </a:solidFill>
-                          <a:latin typeface="Courier New" panose="02070309020205020404" pitchFamily="49" charset="0"/>
-                          <a:cs typeface="Courier New" panose="02070309020205020404" pitchFamily="49" charset="0"/>
-                        </a:rPr>
-                        <a:t>Ctrl-c</a:t>
-                      </a:r>
-                    </a:p>
-                    <a:p>
-                      <a:pPr marL="266700" indent="-266700">
-                        <a:buClr>
-                          <a:schemeClr val="accent1">
-                            <a:lumMod val="50000"/>
-                          </a:schemeClr>
-                        </a:buClr>
-                        <a:buSzPct val="120000"/>
-                        <a:buFont typeface="Courier New" panose="02070309020205020404" pitchFamily="49" charset="0"/>
-                        <a:buChar char="|"/>
-                      </a:pPr>
-                      <a:r>
-                        <a:rPr lang="en-US" sz="1600" b="1" baseline="0" dirty="0" err="1">
-                          <a:solidFill>
-                            <a:srgbClr val="C00000"/>
-                          </a:solidFill>
-                          <a:latin typeface="Courier New" panose="02070309020205020404" pitchFamily="49" charset="0"/>
-                          <a:cs typeface="Courier New" panose="02070309020205020404" pitchFamily="49" charset="0"/>
-                        </a:rPr>
-                        <a:t>KeyboardInterrupt</a:t>
-                      </a:r>
-                      <a:endParaRPr lang="en-US" sz="1600" b="1" baseline="0" dirty="0">
-                        <a:solidFill>
-                          <a:srgbClr val="C00000"/>
-                        </a:solidFill>
-                        <a:latin typeface="Courier New" panose="02070309020205020404" pitchFamily="49" charset="0"/>
-                        <a:cs typeface="Courier New" panose="02070309020205020404" pitchFamily="49" charset="0"/>
-                      </a:endParaRPr>
-                    </a:p>
-                  </a:txBody>
-                  <a:tcPr>
-                    <a:lnL w="6350" cap="flat" cmpd="sng" algn="ctr">
-                      <a:solidFill>
-                        <a:schemeClr val="tx1"/>
-                      </a:solidFill>
-                      <a:prstDash val="solid"/>
-                      <a:round/>
-                      <a:headEnd type="none" w="med" len="med"/>
-                      <a:tailEnd type="none" w="med" len="med"/>
-                    </a:lnL>
-                    <a:lnR w="6350" cap="flat" cmpd="sng" algn="ctr">
-                      <a:solidFill>
-                        <a:schemeClr val="tx1"/>
-                      </a:solidFill>
-                      <a:prstDash val="solid"/>
-                      <a:round/>
-                      <a:headEnd type="none" w="med" len="med"/>
-                      <a:tailEnd type="none" w="med" len="med"/>
-                    </a:lnR>
-                    <a:lnT w="6350" cap="flat" cmpd="sng" algn="ctr">
-                      <a:solidFill>
-                        <a:schemeClr val="tx1"/>
-                      </a:solidFill>
-                      <a:prstDash val="solid"/>
-                      <a:round/>
-                      <a:headEnd type="none" w="med" len="med"/>
-                      <a:tailEnd type="none" w="med" len="med"/>
-                    </a:lnT>
-                    <a:lnB w="6350" cap="flat" cmpd="sng" algn="ctr">
-                      <a:solidFill>
-                        <a:schemeClr val="tx1"/>
-                      </a:solidFill>
-                      <a:prstDash val="solid"/>
-                      <a:round/>
-                      <a:headEnd type="none" w="med" len="med"/>
-                      <a:tailEnd type="none" w="med" len="med"/>
-                    </a:lnB>
-                    <a:lnTlToBr w="12700" cmpd="sng">
-                      <a:noFill/>
-                      <a:prstDash val="solid"/>
-                    </a:lnTlToBr>
-                    <a:lnBlToTr w="12700" cmpd="sng">
-                      <a:noFill/>
-                      <a:prstDash val="solid"/>
-                    </a:lnBlToTr>
-                    <a:solidFill>
-                      <a:schemeClr val="accent5">
-                        <a:lumMod val="20000"/>
-                        <a:lumOff val="80000"/>
-                      </a:schemeClr>
-                    </a:solidFill>
-                  </a:tcPr>
-                </a:tc>
-                <a:extLst>
-                  <a:ext uri="{0D108BD9-81ED-4DB2-BD59-A6C34878D82A}">
-                    <a16:rowId xmlns:a16="http://schemas.microsoft.com/office/drawing/2014/main" val="25355368"/>
-                  </a:ext>
-                </a:extLst>
-              </a:tr>
-            </a:tbl>
-          </a:graphicData>
-        </a:graphic>
-      </p:graphicFrame>
-      <p:sp>
-        <p:nvSpPr>
           <p:cNvPr id="7" name="Content Placeholder 2"/>
           <p:cNvSpPr txBox="1">
             <a:spLocks/>
@@ -9116,6 +7835,1097 @@
           </a:p>
         </p:txBody>
       </p:sp>
+      <p:sp>
+        <p:nvSpPr>
+          <p:cNvPr id="2" name="Title 1"/>
+          <p:cNvSpPr>
+            <a:spLocks noGrp="1"/>
+          </p:cNvSpPr>
+          <p:nvPr>
+            <p:ph type="title"/>
+          </p:nvPr>
+        </p:nvSpPr>
+        <p:spPr/>
+        <p:txBody>
+          <a:bodyPr/>
+          <a:lstStyle/>
+          <a:p>
+            <a:r>
+              <a:rPr lang="da-DK" dirty="0"/>
+              <a:t>Keyboard </a:t>
+            </a:r>
+            <a:r>
+              <a:rPr lang="da-DK" dirty="0" err="1"/>
+              <a:t>interrupt</a:t>
+            </a:r>
+            <a:r>
+              <a:rPr lang="da-DK" dirty="0"/>
+              <a:t> (</a:t>
+            </a:r>
+            <a:r>
+              <a:rPr lang="da-DK" i="1" dirty="0" err="1"/>
+              <a:t>Ctrl</a:t>
+            </a:r>
+            <a:r>
+              <a:rPr lang="da-DK" i="1" dirty="0"/>
+              <a:t>-c</a:t>
+            </a:r>
+            <a:r>
+              <a:rPr lang="da-DK" dirty="0"/>
+              <a:t>)</a:t>
+            </a:r>
+            <a:endParaRPr lang="en-US" dirty="0"/>
+          </a:p>
+        </p:txBody>
+      </p:sp>
+      <p:graphicFrame>
+        <p:nvGraphicFramePr>
+          <p:cNvPr id="4" name="Table 3"/>
+          <p:cNvGraphicFramePr>
+            <a:graphicFrameLocks noGrp="1"/>
+          </p:cNvGraphicFramePr>
+          <p:nvPr>
+            <p:extLst>
+              <p:ext uri="{D42A27DB-BD31-4B8C-83A1-F6EECF244321}">
+                <p14:modId xmlns:p14="http://schemas.microsoft.com/office/powerpoint/2010/main" val="62231603"/>
+              </p:ext>
+            </p:extLst>
+          </p:nvPr>
+        </p:nvGraphicFramePr>
+        <p:xfrm>
+          <a:off x="6448129" y="2506287"/>
+          <a:ext cx="4950143" cy="3535680"/>
+        </p:xfrm>
+        <a:graphic>
+          <a:graphicData uri="http://schemas.openxmlformats.org/drawingml/2006/table">
+            <a:tbl>
+              <a:tblPr firstRow="1" bandRow="1">
+                <a:tableStyleId>{5C22544A-7EE6-4342-B048-85BDC9FD1C3A}</a:tableStyleId>
+              </a:tblPr>
+              <a:tblGrid>
+                <a:gridCol w="4950143">
+                  <a:extLst>
+                    <a:ext uri="{9D8B030D-6E8A-4147-A177-3AD203B41FA5}">
+                      <a16:colId xmlns:a16="http://schemas.microsoft.com/office/drawing/2014/main" val="1873682825"/>
+                    </a:ext>
+                  </a:extLst>
+                </a:gridCol>
+              </a:tblGrid>
+              <a:tr h="303242">
+                <a:tc>
+                  <a:txBody>
+                    <a:bodyPr/>
+                    <a:lstStyle/>
+                    <a:p>
+                      <a:r>
+                        <a:rPr lang="da-DK" sz="1600" b="1" dirty="0">
+                          <a:latin typeface="Courier New" panose="02070309020205020404" pitchFamily="49" charset="0"/>
+                          <a:cs typeface="Courier New" panose="02070309020205020404" pitchFamily="49" charset="0"/>
+                        </a:rPr>
+                        <a:t>read-int2.py</a:t>
+                      </a:r>
+                    </a:p>
+                  </a:txBody>
+                  <a:tcPr anchor="ctr">
+                    <a:lnL w="6350" cap="flat" cmpd="sng" algn="ctr">
+                      <a:solidFill>
+                        <a:schemeClr val="tx1"/>
+                      </a:solidFill>
+                      <a:prstDash val="solid"/>
+                      <a:round/>
+                      <a:headEnd type="none" w="med" len="med"/>
+                      <a:tailEnd type="none" w="med" len="med"/>
+                    </a:lnL>
+                    <a:lnR w="6350" cap="flat" cmpd="sng" algn="ctr">
+                      <a:solidFill>
+                        <a:schemeClr val="tx1"/>
+                      </a:solidFill>
+                      <a:prstDash val="solid"/>
+                      <a:round/>
+                      <a:headEnd type="none" w="med" len="med"/>
+                      <a:tailEnd type="none" w="med" len="med"/>
+                    </a:lnR>
+                    <a:lnT w="6350" cap="flat" cmpd="sng" algn="ctr">
+                      <a:solidFill>
+                        <a:schemeClr val="tx1"/>
+                      </a:solidFill>
+                      <a:prstDash val="solid"/>
+                      <a:round/>
+                      <a:headEnd type="none" w="med" len="med"/>
+                      <a:tailEnd type="none" w="med" len="med"/>
+                    </a:lnT>
+                    <a:lnB w="6350" cap="flat" cmpd="sng" algn="ctr">
+                      <a:solidFill>
+                        <a:schemeClr val="tx1"/>
+                      </a:solidFill>
+                      <a:prstDash val="solid"/>
+                      <a:round/>
+                      <a:headEnd type="none" w="med" len="med"/>
+                      <a:tailEnd type="none" w="med" len="med"/>
+                    </a:lnB>
+                    <a:lnTlToBr w="12700" cmpd="sng">
+                      <a:noFill/>
+                      <a:prstDash val="solid"/>
+                    </a:lnTlToBr>
+                    <a:lnBlToTr w="12700" cmpd="sng">
+                      <a:noFill/>
+                      <a:prstDash val="solid"/>
+                    </a:lnBlToTr>
+                    <a:solidFill>
+                      <a:srgbClr val="C00000"/>
+                    </a:solidFill>
+                  </a:tcPr>
+                </a:tc>
+                <a:extLst>
+                  <a:ext uri="{0D108BD9-81ED-4DB2-BD59-A6C34878D82A}">
+                    <a16:rowId xmlns:a16="http://schemas.microsoft.com/office/drawing/2014/main" val="3330819881"/>
+                  </a:ext>
+                </a:extLst>
+              </a:tr>
+              <a:tr h="1970558">
+                <a:tc>
+                  <a:txBody>
+                    <a:bodyPr/>
+                    <a:lstStyle/>
+                    <a:p>
+                      <a:r>
+                        <a:rPr lang="en-US" sz="1600" b="1" dirty="0">
+                          <a:latin typeface="Courier New" panose="02070309020205020404" pitchFamily="49" charset="0"/>
+                          <a:cs typeface="Courier New" panose="02070309020205020404" pitchFamily="49" charset="0"/>
+                        </a:rPr>
+                        <a:t>while True:</a:t>
+                      </a:r>
+                    </a:p>
+                    <a:p>
+                      <a:r>
+                        <a:rPr lang="en-US" sz="1600" b="1" dirty="0">
+                          <a:latin typeface="Courier New" panose="02070309020205020404" pitchFamily="49" charset="0"/>
+                          <a:cs typeface="Courier New" panose="02070309020205020404" pitchFamily="49" charset="0"/>
+                        </a:rPr>
+                        <a:t>    try:</a:t>
+                      </a:r>
+                    </a:p>
+                    <a:p>
+                      <a:r>
+                        <a:rPr lang="en-US" sz="1600" b="1" dirty="0">
+                          <a:latin typeface="Courier New" panose="02070309020205020404" pitchFamily="49" charset="0"/>
+                          <a:cs typeface="Courier New" panose="02070309020205020404" pitchFamily="49" charset="0"/>
+                        </a:rPr>
+                        <a:t>        x = </a:t>
+                      </a:r>
+                      <a:r>
+                        <a:rPr lang="en-US" sz="1600" b="1" dirty="0" err="1">
+                          <a:latin typeface="Courier New" panose="02070309020205020404" pitchFamily="49" charset="0"/>
+                          <a:cs typeface="Courier New" panose="02070309020205020404" pitchFamily="49" charset="0"/>
+                        </a:rPr>
+                        <a:t>int</a:t>
+                      </a:r>
+                      <a:r>
+                        <a:rPr lang="en-US" sz="1600" b="1" dirty="0">
+                          <a:latin typeface="Courier New" panose="02070309020205020404" pitchFamily="49" charset="0"/>
+                          <a:cs typeface="Courier New" panose="02070309020205020404" pitchFamily="49" charset="0"/>
+                        </a:rPr>
+                        <a:t>(input('An integer: '))</a:t>
+                      </a:r>
+                    </a:p>
+                    <a:p>
+                      <a:r>
+                        <a:rPr lang="en-US" sz="1600" b="1" dirty="0">
+                          <a:latin typeface="Courier New" panose="02070309020205020404" pitchFamily="49" charset="0"/>
+                          <a:cs typeface="Courier New" panose="02070309020205020404" pitchFamily="49" charset="0"/>
+                        </a:rPr>
+                        <a:t>        break</a:t>
+                      </a:r>
+                    </a:p>
+                    <a:p>
+                      <a:r>
+                        <a:rPr lang="en-US" sz="1600" b="1" dirty="0">
+                          <a:solidFill>
+                            <a:srgbClr val="C00000"/>
+                          </a:solidFill>
+                          <a:latin typeface="Courier New" panose="02070309020205020404" pitchFamily="49" charset="0"/>
+                          <a:cs typeface="Courier New" panose="02070309020205020404" pitchFamily="49" charset="0"/>
+                        </a:rPr>
+                        <a:t>    except:  # all exceptions</a:t>
+                      </a:r>
+                    </a:p>
+                    <a:p>
+                      <a:r>
+                        <a:rPr lang="en-US" sz="1600" b="1" dirty="0">
+                          <a:latin typeface="Courier New" panose="02070309020205020404" pitchFamily="49" charset="0"/>
+                          <a:cs typeface="Courier New" panose="02070309020205020404" pitchFamily="49" charset="0"/>
+                        </a:rPr>
+                        <a:t>        continue</a:t>
+                      </a:r>
+                    </a:p>
+                    <a:p>
+                      <a:endParaRPr lang="en-US" sz="1600" b="1" dirty="0">
+                        <a:latin typeface="Courier New" panose="02070309020205020404" pitchFamily="49" charset="0"/>
+                        <a:cs typeface="Courier New" panose="02070309020205020404" pitchFamily="49" charset="0"/>
+                      </a:endParaRPr>
+                    </a:p>
+                    <a:p>
+                      <a:r>
+                        <a:rPr lang="en-US" sz="1600" b="1" dirty="0">
+                          <a:latin typeface="Courier New" panose="02070309020205020404" pitchFamily="49" charset="0"/>
+                          <a:cs typeface="Courier New" panose="02070309020205020404" pitchFamily="49" charset="0"/>
+                        </a:rPr>
+                        <a:t>print('The value is:', x)</a:t>
+                      </a:r>
+                    </a:p>
+                  </a:txBody>
+                  <a:tcPr>
+                    <a:lnL w="6350" cap="flat" cmpd="sng" algn="ctr">
+                      <a:solidFill>
+                        <a:schemeClr val="tx1"/>
+                      </a:solidFill>
+                      <a:prstDash val="solid"/>
+                      <a:round/>
+                      <a:headEnd type="none" w="med" len="med"/>
+                      <a:tailEnd type="none" w="med" len="med"/>
+                    </a:lnL>
+                    <a:lnR w="6350" cap="flat" cmpd="sng" algn="ctr">
+                      <a:solidFill>
+                        <a:schemeClr val="tx1"/>
+                      </a:solidFill>
+                      <a:prstDash val="solid"/>
+                      <a:round/>
+                      <a:headEnd type="none" w="med" len="med"/>
+                      <a:tailEnd type="none" w="med" len="med"/>
+                    </a:lnR>
+                    <a:lnT w="6350" cap="flat" cmpd="sng" algn="ctr">
+                      <a:solidFill>
+                        <a:schemeClr val="tx1"/>
+                      </a:solidFill>
+                      <a:prstDash val="solid"/>
+                      <a:round/>
+                      <a:headEnd type="none" w="med" len="med"/>
+                      <a:tailEnd type="none" w="med" len="med"/>
+                    </a:lnT>
+                    <a:lnB w="6350" cap="flat" cmpd="sng" algn="ctr">
+                      <a:solidFill>
+                        <a:schemeClr val="tx1"/>
+                      </a:solidFill>
+                      <a:prstDash val="solid"/>
+                      <a:round/>
+                      <a:headEnd type="none" w="med" len="med"/>
+                      <a:tailEnd type="none" w="med" len="med"/>
+                    </a:lnB>
+                    <a:lnTlToBr w="12700" cmpd="sng">
+                      <a:noFill/>
+                      <a:prstDash val="solid"/>
+                    </a:lnTlToBr>
+                    <a:lnBlToTr w="12700" cmpd="sng">
+                      <a:noFill/>
+                      <a:prstDash val="solid"/>
+                    </a:lnBlToTr>
+                    <a:solidFill>
+                      <a:schemeClr val="accent5">
+                        <a:lumMod val="20000"/>
+                        <a:lumOff val="80000"/>
+                      </a:schemeClr>
+                    </a:solidFill>
+                  </a:tcPr>
+                </a:tc>
+                <a:extLst>
+                  <a:ext uri="{0D108BD9-81ED-4DB2-BD59-A6C34878D82A}">
+                    <a16:rowId xmlns:a16="http://schemas.microsoft.com/office/drawing/2014/main" val="4112970457"/>
+                  </a:ext>
+                </a:extLst>
+              </a:tr>
+              <a:tr h="303242">
+                <a:tc>
+                  <a:txBody>
+                    <a:bodyPr/>
+                    <a:lstStyle/>
+                    <a:p>
+                      <a:r>
+                        <a:rPr lang="da-DK" sz="1600" b="1" dirty="0" err="1">
+                          <a:solidFill>
+                            <a:schemeClr val="bg1"/>
+                          </a:solidFill>
+                          <a:latin typeface="Courier New" panose="02070309020205020404" pitchFamily="49" charset="0"/>
+                          <a:cs typeface="Courier New" panose="02070309020205020404" pitchFamily="49" charset="0"/>
+                        </a:rPr>
+                        <a:t>Python</a:t>
+                      </a:r>
+                      <a:r>
+                        <a:rPr lang="da-DK" sz="1600" b="1" dirty="0">
+                          <a:solidFill>
+                            <a:schemeClr val="bg1"/>
+                          </a:solidFill>
+                          <a:latin typeface="Courier New" panose="02070309020205020404" pitchFamily="49" charset="0"/>
+                          <a:cs typeface="Courier New" panose="02070309020205020404" pitchFamily="49" charset="0"/>
+                        </a:rPr>
+                        <a:t> </a:t>
+                      </a:r>
+                      <a:r>
+                        <a:rPr lang="da-DK" sz="1600" b="1" dirty="0" err="1">
+                          <a:solidFill>
+                            <a:schemeClr val="bg1"/>
+                          </a:solidFill>
+                          <a:latin typeface="Courier New" panose="02070309020205020404" pitchFamily="49" charset="0"/>
+                          <a:cs typeface="Courier New" panose="02070309020205020404" pitchFamily="49" charset="0"/>
+                        </a:rPr>
+                        <a:t>shell</a:t>
+                      </a:r>
+                      <a:endParaRPr lang="da-DK" sz="1600" b="1" dirty="0">
+                        <a:solidFill>
+                          <a:schemeClr val="bg1"/>
+                        </a:solidFill>
+                        <a:latin typeface="Courier New" panose="02070309020205020404" pitchFamily="49" charset="0"/>
+                        <a:cs typeface="Courier New" panose="02070309020205020404" pitchFamily="49" charset="0"/>
+                      </a:endParaRPr>
+                    </a:p>
+                  </a:txBody>
+                  <a:tcPr>
+                    <a:lnL w="6350" cap="flat" cmpd="sng" algn="ctr">
+                      <a:solidFill>
+                        <a:schemeClr val="tx1"/>
+                      </a:solidFill>
+                      <a:prstDash val="solid"/>
+                      <a:round/>
+                      <a:headEnd type="none" w="med" len="med"/>
+                      <a:tailEnd type="none" w="med" len="med"/>
+                    </a:lnL>
+                    <a:lnR w="6350" cap="flat" cmpd="sng" algn="ctr">
+                      <a:solidFill>
+                        <a:schemeClr val="tx1"/>
+                      </a:solidFill>
+                      <a:prstDash val="solid"/>
+                      <a:round/>
+                      <a:headEnd type="none" w="med" len="med"/>
+                      <a:tailEnd type="none" w="med" len="med"/>
+                    </a:lnR>
+                    <a:lnT w="6350" cap="flat" cmpd="sng" algn="ctr">
+                      <a:solidFill>
+                        <a:schemeClr val="tx1"/>
+                      </a:solidFill>
+                      <a:prstDash val="solid"/>
+                      <a:round/>
+                      <a:headEnd type="none" w="med" len="med"/>
+                      <a:tailEnd type="none" w="med" len="med"/>
+                    </a:lnT>
+                    <a:lnB w="6350" cap="flat" cmpd="sng" algn="ctr">
+                      <a:solidFill>
+                        <a:schemeClr val="tx1"/>
+                      </a:solidFill>
+                      <a:prstDash val="solid"/>
+                      <a:round/>
+                      <a:headEnd type="none" w="med" len="med"/>
+                      <a:tailEnd type="none" w="med" len="med"/>
+                    </a:lnB>
+                    <a:lnTlToBr w="12700" cmpd="sng">
+                      <a:noFill/>
+                      <a:prstDash val="solid"/>
+                    </a:lnTlToBr>
+                    <a:lnBlToTr w="12700" cmpd="sng">
+                      <a:noFill/>
+                      <a:prstDash val="solid"/>
+                    </a:lnBlToTr>
+                    <a:solidFill>
+                      <a:srgbClr val="C00000"/>
+                    </a:solidFill>
+                  </a:tcPr>
+                </a:tc>
+                <a:extLst>
+                  <a:ext uri="{0D108BD9-81ED-4DB2-BD59-A6C34878D82A}">
+                    <a16:rowId xmlns:a16="http://schemas.microsoft.com/office/drawing/2014/main" val="2202042958"/>
+                  </a:ext>
+                </a:extLst>
+              </a:tr>
+              <a:tr h="806691">
+                <a:tc>
+                  <a:txBody>
+                    <a:bodyPr/>
+                    <a:lstStyle/>
+                    <a:p>
+                      <a:pPr marL="266700" indent="-266700">
+                        <a:buClr>
+                          <a:schemeClr val="accent1">
+                            <a:lumMod val="50000"/>
+                          </a:schemeClr>
+                        </a:buClr>
+                        <a:buSzPct val="120000"/>
+                        <a:buFont typeface="Courier New" panose="02070309020205020404" pitchFamily="49" charset="0"/>
+                        <a:buChar char="|"/>
+                      </a:pPr>
+                      <a:r>
+                        <a:rPr lang="de-DE" sz="1600" b="1" baseline="0" dirty="0">
+                          <a:latin typeface="Courier New" panose="02070309020205020404" pitchFamily="49" charset="0"/>
+                          <a:cs typeface="Courier New" panose="02070309020205020404" pitchFamily="49" charset="0"/>
+                        </a:rPr>
+                        <a:t>An integer</a:t>
+                      </a:r>
+                      <a:r>
+                        <a:rPr lang="en-US" sz="1600" b="1" baseline="0" dirty="0">
+                          <a:latin typeface="Courier New" panose="02070309020205020404" pitchFamily="49" charset="0"/>
+                          <a:cs typeface="Courier New" panose="02070309020205020404" pitchFamily="49" charset="0"/>
+                        </a:rPr>
+                        <a:t>:         </a:t>
+                      </a:r>
+                      <a:r>
+                        <a:rPr lang="en-US" sz="1600" b="1" i="1" baseline="0" dirty="0">
+                          <a:solidFill>
+                            <a:srgbClr val="C00000"/>
+                          </a:solidFill>
+                          <a:latin typeface="Courier New" panose="02070309020205020404" pitchFamily="49" charset="0"/>
+                          <a:cs typeface="Courier New" panose="02070309020205020404" pitchFamily="49" charset="0"/>
+                        </a:rPr>
+                        <a:t>Ctrl-c</a:t>
+                      </a:r>
+                      <a:endParaRPr lang="de-DE" sz="1600" b="1" baseline="0" dirty="0">
+                        <a:latin typeface="Courier New" panose="02070309020205020404" pitchFamily="49" charset="0"/>
+                        <a:cs typeface="Courier New" panose="02070309020205020404" pitchFamily="49" charset="0"/>
+                      </a:endParaRPr>
+                    </a:p>
+                    <a:p>
+                      <a:pPr marL="266700" indent="-266700">
+                        <a:buClr>
+                          <a:schemeClr val="accent1">
+                            <a:lumMod val="50000"/>
+                          </a:schemeClr>
+                        </a:buClr>
+                        <a:buSzPct val="120000"/>
+                        <a:buFont typeface="Courier New" panose="02070309020205020404" pitchFamily="49" charset="0"/>
+                        <a:buChar char="|"/>
+                      </a:pPr>
+                      <a:r>
+                        <a:rPr lang="de-DE" sz="1600" b="1" baseline="0" dirty="0">
+                          <a:latin typeface="Courier New" panose="02070309020205020404" pitchFamily="49" charset="0"/>
+                          <a:cs typeface="Courier New" panose="02070309020205020404" pitchFamily="49" charset="0"/>
+                        </a:rPr>
+                        <a:t>An integer</a:t>
+                      </a:r>
+                      <a:r>
+                        <a:rPr lang="en-US" sz="1600" b="1" baseline="0" dirty="0">
+                          <a:latin typeface="Courier New" panose="02070309020205020404" pitchFamily="49" charset="0"/>
+                          <a:cs typeface="Courier New" panose="02070309020205020404" pitchFamily="49" charset="0"/>
+                        </a:rPr>
+                        <a:t>:         </a:t>
+                      </a:r>
+                      <a:r>
+                        <a:rPr lang="en-US" sz="1600" b="1" i="1" baseline="0" dirty="0">
+                          <a:solidFill>
+                            <a:srgbClr val="C00000"/>
+                          </a:solidFill>
+                          <a:latin typeface="Courier New" panose="02070309020205020404" pitchFamily="49" charset="0"/>
+                          <a:cs typeface="Courier New" panose="02070309020205020404" pitchFamily="49" charset="0"/>
+                        </a:rPr>
+                        <a:t>Ctrl-c</a:t>
+                      </a:r>
+                      <a:endParaRPr lang="de-DE" sz="1600" b="1" baseline="0" dirty="0">
+                        <a:latin typeface="Courier New" panose="02070309020205020404" pitchFamily="49" charset="0"/>
+                        <a:cs typeface="Courier New" panose="02070309020205020404" pitchFamily="49" charset="0"/>
+                      </a:endParaRPr>
+                    </a:p>
+                    <a:p>
+                      <a:pPr marL="266700" indent="-266700">
+                        <a:buClr>
+                          <a:schemeClr val="accent1">
+                            <a:lumMod val="50000"/>
+                          </a:schemeClr>
+                        </a:buClr>
+                        <a:buSzPct val="120000"/>
+                        <a:buFont typeface="Courier New" panose="02070309020205020404" pitchFamily="49" charset="0"/>
+                        <a:buChar char="|"/>
+                      </a:pPr>
+                      <a:r>
+                        <a:rPr lang="de-DE" sz="1600" b="1" baseline="0" dirty="0">
+                          <a:latin typeface="Courier New" panose="02070309020205020404" pitchFamily="49" charset="0"/>
+                          <a:cs typeface="Courier New" panose="02070309020205020404" pitchFamily="49" charset="0"/>
+                        </a:rPr>
+                        <a:t>An integer:</a:t>
+                      </a:r>
+                      <a:endParaRPr lang="en-US" sz="1600" b="1" baseline="0" dirty="0">
+                        <a:latin typeface="Courier New" panose="02070309020205020404" pitchFamily="49" charset="0"/>
+                        <a:cs typeface="Courier New" panose="02070309020205020404" pitchFamily="49" charset="0"/>
+                      </a:endParaRPr>
+                    </a:p>
+                  </a:txBody>
+                  <a:tcPr>
+                    <a:lnL w="6350" cap="flat" cmpd="sng" algn="ctr">
+                      <a:solidFill>
+                        <a:schemeClr val="tx1"/>
+                      </a:solidFill>
+                      <a:prstDash val="solid"/>
+                      <a:round/>
+                      <a:headEnd type="none" w="med" len="med"/>
+                      <a:tailEnd type="none" w="med" len="med"/>
+                    </a:lnL>
+                    <a:lnR w="6350" cap="flat" cmpd="sng" algn="ctr">
+                      <a:solidFill>
+                        <a:schemeClr val="tx1"/>
+                      </a:solidFill>
+                      <a:prstDash val="solid"/>
+                      <a:round/>
+                      <a:headEnd type="none" w="med" len="med"/>
+                      <a:tailEnd type="none" w="med" len="med"/>
+                    </a:lnR>
+                    <a:lnT w="6350" cap="flat" cmpd="sng" algn="ctr">
+                      <a:solidFill>
+                        <a:schemeClr val="tx1"/>
+                      </a:solidFill>
+                      <a:prstDash val="solid"/>
+                      <a:round/>
+                      <a:headEnd type="none" w="med" len="med"/>
+                      <a:tailEnd type="none" w="med" len="med"/>
+                    </a:lnT>
+                    <a:lnB w="6350" cap="flat" cmpd="sng" algn="ctr">
+                      <a:solidFill>
+                        <a:schemeClr val="tx1"/>
+                      </a:solidFill>
+                      <a:prstDash val="solid"/>
+                      <a:round/>
+                      <a:headEnd type="none" w="med" len="med"/>
+                      <a:tailEnd type="none" w="med" len="med"/>
+                    </a:lnB>
+                    <a:lnTlToBr w="12700" cmpd="sng">
+                      <a:noFill/>
+                      <a:prstDash val="solid"/>
+                    </a:lnTlToBr>
+                    <a:lnBlToTr w="12700" cmpd="sng">
+                      <a:noFill/>
+                      <a:prstDash val="solid"/>
+                    </a:lnBlToTr>
+                    <a:solidFill>
+                      <a:schemeClr val="accent5">
+                        <a:lumMod val="20000"/>
+                        <a:lumOff val="80000"/>
+                      </a:schemeClr>
+                    </a:solidFill>
+                  </a:tcPr>
+                </a:tc>
+                <a:extLst>
+                  <a:ext uri="{0D108BD9-81ED-4DB2-BD59-A6C34878D82A}">
+                    <a16:rowId xmlns:a16="http://schemas.microsoft.com/office/drawing/2014/main" val="25355368"/>
+                  </a:ext>
+                </a:extLst>
+              </a:tr>
+            </a:tbl>
+          </a:graphicData>
+        </a:graphic>
+      </p:graphicFrame>
+      <p:graphicFrame>
+        <p:nvGraphicFramePr>
+          <p:cNvPr id="5" name="Table 4"/>
+          <p:cNvGraphicFramePr>
+            <a:graphicFrameLocks noGrp="1"/>
+          </p:cNvGraphicFramePr>
+          <p:nvPr>
+            <p:extLst>
+              <p:ext uri="{D42A27DB-BD31-4B8C-83A1-F6EECF244321}">
+                <p14:modId xmlns:p14="http://schemas.microsoft.com/office/powerpoint/2010/main" val="727537512"/>
+              </p:ext>
+            </p:extLst>
+          </p:nvPr>
+        </p:nvGraphicFramePr>
+        <p:xfrm>
+          <a:off x="790937" y="2505855"/>
+          <a:ext cx="5316855" cy="3536112"/>
+        </p:xfrm>
+        <a:graphic>
+          <a:graphicData uri="http://schemas.openxmlformats.org/drawingml/2006/table">
+            <a:tbl>
+              <a:tblPr firstRow="1" bandRow="1">
+                <a:tableStyleId>{5C22544A-7EE6-4342-B048-85BDC9FD1C3A}</a:tableStyleId>
+              </a:tblPr>
+              <a:tblGrid>
+                <a:gridCol w="5316855">
+                  <a:extLst>
+                    <a:ext uri="{9D8B030D-6E8A-4147-A177-3AD203B41FA5}">
+                      <a16:colId xmlns:a16="http://schemas.microsoft.com/office/drawing/2014/main" val="1873682825"/>
+                    </a:ext>
+                  </a:extLst>
+                </a:gridCol>
+              </a:tblGrid>
+              <a:tr h="289086">
+                <a:tc>
+                  <a:txBody>
+                    <a:bodyPr/>
+                    <a:lstStyle/>
+                    <a:p>
+                      <a:r>
+                        <a:rPr lang="da-DK" sz="1600" b="1" dirty="0">
+                          <a:latin typeface="Courier New" panose="02070309020205020404" pitchFamily="49" charset="0"/>
+                          <a:cs typeface="Courier New" panose="02070309020205020404" pitchFamily="49" charset="0"/>
+                        </a:rPr>
+                        <a:t>read-int1.py</a:t>
+                      </a:r>
+                    </a:p>
+                  </a:txBody>
+                  <a:tcPr anchor="ctr">
+                    <a:lnL w="6350" cap="flat" cmpd="sng" algn="ctr">
+                      <a:solidFill>
+                        <a:schemeClr val="tx1"/>
+                      </a:solidFill>
+                      <a:prstDash val="solid"/>
+                      <a:round/>
+                      <a:headEnd type="none" w="med" len="med"/>
+                      <a:tailEnd type="none" w="med" len="med"/>
+                    </a:lnL>
+                    <a:lnR w="6350" cap="flat" cmpd="sng" algn="ctr">
+                      <a:solidFill>
+                        <a:schemeClr val="tx1"/>
+                      </a:solidFill>
+                      <a:prstDash val="solid"/>
+                      <a:round/>
+                      <a:headEnd type="none" w="med" len="med"/>
+                      <a:tailEnd type="none" w="med" len="med"/>
+                    </a:lnR>
+                    <a:lnT w="6350" cap="flat" cmpd="sng" algn="ctr">
+                      <a:solidFill>
+                        <a:schemeClr val="tx1"/>
+                      </a:solidFill>
+                      <a:prstDash val="solid"/>
+                      <a:round/>
+                      <a:headEnd type="none" w="med" len="med"/>
+                      <a:tailEnd type="none" w="med" len="med"/>
+                    </a:lnT>
+                    <a:lnB w="6350" cap="flat" cmpd="sng" algn="ctr">
+                      <a:solidFill>
+                        <a:schemeClr val="tx1"/>
+                      </a:solidFill>
+                      <a:prstDash val="solid"/>
+                      <a:round/>
+                      <a:headEnd type="none" w="med" len="med"/>
+                      <a:tailEnd type="none" w="med" len="med"/>
+                    </a:lnB>
+                    <a:lnTlToBr w="12700" cmpd="sng">
+                      <a:noFill/>
+                      <a:prstDash val="solid"/>
+                    </a:lnTlToBr>
+                    <a:lnBlToTr w="12700" cmpd="sng">
+                      <a:noFill/>
+                      <a:prstDash val="solid"/>
+                    </a:lnBlToTr>
+                    <a:solidFill>
+                      <a:srgbClr val="C00000"/>
+                    </a:solidFill>
+                  </a:tcPr>
+                </a:tc>
+                <a:extLst>
+                  <a:ext uri="{0D108BD9-81ED-4DB2-BD59-A6C34878D82A}">
+                    <a16:rowId xmlns:a16="http://schemas.microsoft.com/office/drawing/2014/main" val="3330819881"/>
+                  </a:ext>
+                </a:extLst>
+              </a:tr>
+              <a:tr h="1760798">
+                <a:tc>
+                  <a:txBody>
+                    <a:bodyPr/>
+                    <a:lstStyle/>
+                    <a:p>
+                      <a:r>
+                        <a:rPr lang="en-US" sz="1600" b="1" dirty="0">
+                          <a:latin typeface="Courier New" panose="02070309020205020404" pitchFamily="49" charset="0"/>
+                          <a:cs typeface="Courier New" panose="02070309020205020404" pitchFamily="49" charset="0"/>
+                        </a:rPr>
+                        <a:t>while True:</a:t>
+                      </a:r>
+                    </a:p>
+                    <a:p>
+                      <a:r>
+                        <a:rPr lang="en-US" sz="1600" b="1" dirty="0">
+                          <a:latin typeface="Courier New" panose="02070309020205020404" pitchFamily="49" charset="0"/>
+                          <a:cs typeface="Courier New" panose="02070309020205020404" pitchFamily="49" charset="0"/>
+                        </a:rPr>
+                        <a:t>    try:</a:t>
+                      </a:r>
+                    </a:p>
+                    <a:p>
+                      <a:r>
+                        <a:rPr lang="en-US" sz="1600" b="1" dirty="0">
+                          <a:latin typeface="Courier New" panose="02070309020205020404" pitchFamily="49" charset="0"/>
+                          <a:cs typeface="Courier New" panose="02070309020205020404" pitchFamily="49" charset="0"/>
+                        </a:rPr>
+                        <a:t>        x = </a:t>
+                      </a:r>
+                      <a:r>
+                        <a:rPr lang="en-US" sz="1600" b="1" dirty="0" err="1">
+                          <a:latin typeface="Courier New" panose="02070309020205020404" pitchFamily="49" charset="0"/>
+                          <a:cs typeface="Courier New" panose="02070309020205020404" pitchFamily="49" charset="0"/>
+                        </a:rPr>
+                        <a:t>int</a:t>
+                      </a:r>
+                      <a:r>
+                        <a:rPr lang="en-US" sz="1600" b="1" dirty="0">
+                          <a:latin typeface="Courier New" panose="02070309020205020404" pitchFamily="49" charset="0"/>
+                          <a:cs typeface="Courier New" panose="02070309020205020404" pitchFamily="49" charset="0"/>
+                        </a:rPr>
+                        <a:t>(input('An integer: '))</a:t>
+                      </a:r>
+                    </a:p>
+                    <a:p>
+                      <a:r>
+                        <a:rPr lang="en-US" sz="1600" b="1" dirty="0">
+                          <a:latin typeface="Courier New" panose="02070309020205020404" pitchFamily="49" charset="0"/>
+                          <a:cs typeface="Courier New" panose="02070309020205020404" pitchFamily="49" charset="0"/>
+                        </a:rPr>
+                        <a:t>        break</a:t>
+                      </a:r>
+                    </a:p>
+                    <a:p>
+                      <a:r>
+                        <a:rPr lang="en-US" sz="1600" b="1" dirty="0">
+                          <a:solidFill>
+                            <a:srgbClr val="C00000"/>
+                          </a:solidFill>
+                          <a:latin typeface="Courier New" panose="02070309020205020404" pitchFamily="49" charset="0"/>
+                          <a:cs typeface="Courier New" panose="02070309020205020404" pitchFamily="49" charset="0"/>
+                        </a:rPr>
+                        <a:t>    except </a:t>
+                      </a:r>
+                      <a:r>
+                        <a:rPr lang="en-US" sz="1600" b="1" dirty="0" err="1">
+                          <a:solidFill>
+                            <a:srgbClr val="C00000"/>
+                          </a:solidFill>
+                          <a:latin typeface="Courier New" panose="02070309020205020404" pitchFamily="49" charset="0"/>
+                          <a:cs typeface="Courier New" panose="02070309020205020404" pitchFamily="49" charset="0"/>
+                        </a:rPr>
+                        <a:t>ValueError</a:t>
+                      </a:r>
+                      <a:r>
+                        <a:rPr lang="en-US" sz="1600" b="1" dirty="0">
+                          <a:solidFill>
+                            <a:srgbClr val="C00000"/>
+                          </a:solidFill>
+                          <a:latin typeface="Courier New" panose="02070309020205020404" pitchFamily="49" charset="0"/>
+                          <a:cs typeface="Courier New" panose="02070309020205020404" pitchFamily="49" charset="0"/>
+                        </a:rPr>
+                        <a:t>:  # only </a:t>
+                      </a:r>
+                      <a:r>
+                        <a:rPr lang="en-US" sz="1600" b="1" dirty="0" err="1">
+                          <a:solidFill>
+                            <a:srgbClr val="C00000"/>
+                          </a:solidFill>
+                          <a:latin typeface="Courier New" panose="02070309020205020404" pitchFamily="49" charset="0"/>
+                          <a:cs typeface="Courier New" panose="02070309020205020404" pitchFamily="49" charset="0"/>
+                        </a:rPr>
+                        <a:t>ValueError</a:t>
+                      </a:r>
+                      <a:endParaRPr lang="en-US" sz="1600" b="1" dirty="0">
+                        <a:solidFill>
+                          <a:srgbClr val="C00000"/>
+                        </a:solidFill>
+                        <a:latin typeface="Courier New" panose="02070309020205020404" pitchFamily="49" charset="0"/>
+                        <a:cs typeface="Courier New" panose="02070309020205020404" pitchFamily="49" charset="0"/>
+                      </a:endParaRPr>
+                    </a:p>
+                    <a:p>
+                      <a:r>
+                        <a:rPr lang="en-US" sz="1600" b="1" dirty="0">
+                          <a:latin typeface="Courier New" panose="02070309020205020404" pitchFamily="49" charset="0"/>
+                          <a:cs typeface="Courier New" panose="02070309020205020404" pitchFamily="49" charset="0"/>
+                        </a:rPr>
+                        <a:t>        continue</a:t>
+                      </a:r>
+                    </a:p>
+                    <a:p>
+                      <a:endParaRPr lang="en-US" sz="1600" b="1" dirty="0">
+                        <a:latin typeface="Courier New" panose="02070309020205020404" pitchFamily="49" charset="0"/>
+                        <a:cs typeface="Courier New" panose="02070309020205020404" pitchFamily="49" charset="0"/>
+                      </a:endParaRPr>
+                    </a:p>
+                    <a:p>
+                      <a:r>
+                        <a:rPr lang="en-US" sz="1600" b="1" dirty="0">
+                          <a:latin typeface="Courier New" panose="02070309020205020404" pitchFamily="49" charset="0"/>
+                          <a:cs typeface="Courier New" panose="02070309020205020404" pitchFamily="49" charset="0"/>
+                        </a:rPr>
+                        <a:t>print('The value is:', x)</a:t>
+                      </a:r>
+                    </a:p>
+                  </a:txBody>
+                  <a:tcPr>
+                    <a:lnL w="6350" cap="flat" cmpd="sng" algn="ctr">
+                      <a:solidFill>
+                        <a:schemeClr val="tx1"/>
+                      </a:solidFill>
+                      <a:prstDash val="solid"/>
+                      <a:round/>
+                      <a:headEnd type="none" w="med" len="med"/>
+                      <a:tailEnd type="none" w="med" len="med"/>
+                    </a:lnL>
+                    <a:lnR w="6350" cap="flat" cmpd="sng" algn="ctr">
+                      <a:solidFill>
+                        <a:schemeClr val="tx1"/>
+                      </a:solidFill>
+                      <a:prstDash val="solid"/>
+                      <a:round/>
+                      <a:headEnd type="none" w="med" len="med"/>
+                      <a:tailEnd type="none" w="med" len="med"/>
+                    </a:lnR>
+                    <a:lnT w="6350" cap="flat" cmpd="sng" algn="ctr">
+                      <a:solidFill>
+                        <a:schemeClr val="tx1"/>
+                      </a:solidFill>
+                      <a:prstDash val="solid"/>
+                      <a:round/>
+                      <a:headEnd type="none" w="med" len="med"/>
+                      <a:tailEnd type="none" w="med" len="med"/>
+                    </a:lnT>
+                    <a:lnB w="6350" cap="flat" cmpd="sng" algn="ctr">
+                      <a:solidFill>
+                        <a:schemeClr val="tx1"/>
+                      </a:solidFill>
+                      <a:prstDash val="solid"/>
+                      <a:round/>
+                      <a:headEnd type="none" w="med" len="med"/>
+                      <a:tailEnd type="none" w="med" len="med"/>
+                    </a:lnB>
+                    <a:lnTlToBr w="12700" cmpd="sng">
+                      <a:noFill/>
+                      <a:prstDash val="solid"/>
+                    </a:lnTlToBr>
+                    <a:lnBlToTr w="12700" cmpd="sng">
+                      <a:noFill/>
+                      <a:prstDash val="solid"/>
+                    </a:lnBlToTr>
+                    <a:solidFill>
+                      <a:schemeClr val="accent5">
+                        <a:lumMod val="20000"/>
+                        <a:lumOff val="80000"/>
+                      </a:schemeClr>
+                    </a:solidFill>
+                  </a:tcPr>
+                </a:tc>
+                <a:extLst>
+                  <a:ext uri="{0D108BD9-81ED-4DB2-BD59-A6C34878D82A}">
+                    <a16:rowId xmlns:a16="http://schemas.microsoft.com/office/drawing/2014/main" val="4112970457"/>
+                  </a:ext>
+                </a:extLst>
+              </a:tr>
+              <a:tr h="289086">
+                <a:tc>
+                  <a:txBody>
+                    <a:bodyPr/>
+                    <a:lstStyle/>
+                    <a:p>
+                      <a:r>
+                        <a:rPr lang="da-DK" sz="1600" b="1" dirty="0" err="1">
+                          <a:solidFill>
+                            <a:schemeClr val="bg1"/>
+                          </a:solidFill>
+                          <a:latin typeface="Courier New" panose="02070309020205020404" pitchFamily="49" charset="0"/>
+                          <a:cs typeface="Courier New" panose="02070309020205020404" pitchFamily="49" charset="0"/>
+                        </a:rPr>
+                        <a:t>Python</a:t>
+                      </a:r>
+                      <a:r>
+                        <a:rPr lang="da-DK" sz="1600" b="1" dirty="0">
+                          <a:solidFill>
+                            <a:schemeClr val="bg1"/>
+                          </a:solidFill>
+                          <a:latin typeface="Courier New" panose="02070309020205020404" pitchFamily="49" charset="0"/>
+                          <a:cs typeface="Courier New" panose="02070309020205020404" pitchFamily="49" charset="0"/>
+                        </a:rPr>
+                        <a:t> </a:t>
+                      </a:r>
+                      <a:r>
+                        <a:rPr lang="da-DK" sz="1600" b="1" dirty="0" err="1">
+                          <a:solidFill>
+                            <a:schemeClr val="bg1"/>
+                          </a:solidFill>
+                          <a:latin typeface="Courier New" panose="02070309020205020404" pitchFamily="49" charset="0"/>
+                          <a:cs typeface="Courier New" panose="02070309020205020404" pitchFamily="49" charset="0"/>
+                        </a:rPr>
+                        <a:t>shell</a:t>
+                      </a:r>
+                      <a:endParaRPr lang="da-DK" sz="1600" b="1" dirty="0">
+                        <a:solidFill>
+                          <a:schemeClr val="bg1"/>
+                        </a:solidFill>
+                        <a:latin typeface="Courier New" panose="02070309020205020404" pitchFamily="49" charset="0"/>
+                        <a:cs typeface="Courier New" panose="02070309020205020404" pitchFamily="49" charset="0"/>
+                      </a:endParaRPr>
+                    </a:p>
+                  </a:txBody>
+                  <a:tcPr>
+                    <a:lnL w="6350" cap="flat" cmpd="sng" algn="ctr">
+                      <a:solidFill>
+                        <a:schemeClr val="tx1"/>
+                      </a:solidFill>
+                      <a:prstDash val="solid"/>
+                      <a:round/>
+                      <a:headEnd type="none" w="med" len="med"/>
+                      <a:tailEnd type="none" w="med" len="med"/>
+                    </a:lnL>
+                    <a:lnR w="6350" cap="flat" cmpd="sng" algn="ctr">
+                      <a:solidFill>
+                        <a:schemeClr val="tx1"/>
+                      </a:solidFill>
+                      <a:prstDash val="solid"/>
+                      <a:round/>
+                      <a:headEnd type="none" w="med" len="med"/>
+                      <a:tailEnd type="none" w="med" len="med"/>
+                    </a:lnR>
+                    <a:lnT w="6350" cap="flat" cmpd="sng" algn="ctr">
+                      <a:solidFill>
+                        <a:schemeClr val="tx1"/>
+                      </a:solidFill>
+                      <a:prstDash val="solid"/>
+                      <a:round/>
+                      <a:headEnd type="none" w="med" len="med"/>
+                      <a:tailEnd type="none" w="med" len="med"/>
+                    </a:lnT>
+                    <a:lnB w="6350" cap="flat" cmpd="sng" algn="ctr">
+                      <a:solidFill>
+                        <a:schemeClr val="tx1"/>
+                      </a:solidFill>
+                      <a:prstDash val="solid"/>
+                      <a:round/>
+                      <a:headEnd type="none" w="med" len="med"/>
+                      <a:tailEnd type="none" w="med" len="med"/>
+                    </a:lnB>
+                    <a:lnTlToBr w="12700" cmpd="sng">
+                      <a:noFill/>
+                      <a:prstDash val="solid"/>
+                    </a:lnTlToBr>
+                    <a:lnBlToTr w="12700" cmpd="sng">
+                      <a:noFill/>
+                      <a:prstDash val="solid"/>
+                    </a:lnBlToTr>
+                    <a:solidFill>
+                      <a:srgbClr val="C00000"/>
+                    </a:solidFill>
+                  </a:tcPr>
+                </a:tc>
+                <a:extLst>
+                  <a:ext uri="{0D108BD9-81ED-4DB2-BD59-A6C34878D82A}">
+                    <a16:rowId xmlns:a16="http://schemas.microsoft.com/office/drawing/2014/main" val="2202042958"/>
+                  </a:ext>
+                </a:extLst>
+              </a:tr>
+              <a:tr h="823392">
+                <a:tc>
+                  <a:txBody>
+                    <a:bodyPr/>
+                    <a:lstStyle/>
+                    <a:p>
+                      <a:pPr marL="266700" indent="-266700">
+                        <a:buClr>
+                          <a:schemeClr val="accent1">
+                            <a:lumMod val="50000"/>
+                          </a:schemeClr>
+                        </a:buClr>
+                        <a:buSzPct val="120000"/>
+                        <a:buFont typeface="Courier New" panose="02070309020205020404" pitchFamily="49" charset="0"/>
+                        <a:buChar char="|"/>
+                      </a:pPr>
+                      <a:r>
+                        <a:rPr lang="en-US" sz="1600" b="1" baseline="0" dirty="0">
+                          <a:latin typeface="Courier New" panose="02070309020205020404" pitchFamily="49" charset="0"/>
+                          <a:cs typeface="Courier New" panose="02070309020205020404" pitchFamily="49" charset="0"/>
+                        </a:rPr>
+                        <a:t>An integer:              </a:t>
+                      </a:r>
+                      <a:r>
+                        <a:rPr lang="en-US" sz="1600" b="1" i="1" baseline="0" dirty="0">
+                          <a:solidFill>
+                            <a:srgbClr val="C00000"/>
+                          </a:solidFill>
+                          <a:latin typeface="Courier New" panose="02070309020205020404" pitchFamily="49" charset="0"/>
+                          <a:cs typeface="Courier New" panose="02070309020205020404" pitchFamily="49" charset="0"/>
+                        </a:rPr>
+                        <a:t>Ctrl-c</a:t>
+                      </a:r>
+                    </a:p>
+                    <a:p>
+                      <a:pPr marL="266700" indent="-266700">
+                        <a:buClr>
+                          <a:schemeClr val="accent1">
+                            <a:lumMod val="50000"/>
+                          </a:schemeClr>
+                        </a:buClr>
+                        <a:buSzPct val="120000"/>
+                        <a:buFont typeface="Courier New" panose="02070309020205020404" pitchFamily="49" charset="0"/>
+                        <a:buChar char="|"/>
+                      </a:pPr>
+                      <a:r>
+                        <a:rPr lang="en-US" sz="1600" b="1" baseline="0" dirty="0" err="1">
+                          <a:solidFill>
+                            <a:srgbClr val="C00000"/>
+                          </a:solidFill>
+                          <a:latin typeface="Courier New" panose="02070309020205020404" pitchFamily="49" charset="0"/>
+                          <a:cs typeface="Courier New" panose="02070309020205020404" pitchFamily="49" charset="0"/>
+                        </a:rPr>
+                        <a:t>KeyboardInterrupt</a:t>
+                      </a:r>
+                      <a:endParaRPr lang="en-US" sz="1600" b="1" baseline="0" dirty="0">
+                        <a:solidFill>
+                          <a:srgbClr val="C00000"/>
+                        </a:solidFill>
+                        <a:latin typeface="Courier New" panose="02070309020205020404" pitchFamily="49" charset="0"/>
+                        <a:cs typeface="Courier New" panose="02070309020205020404" pitchFamily="49" charset="0"/>
+                      </a:endParaRPr>
+                    </a:p>
+                  </a:txBody>
+                  <a:tcPr>
+                    <a:lnL w="6350" cap="flat" cmpd="sng" algn="ctr">
+                      <a:solidFill>
+                        <a:schemeClr val="tx1"/>
+                      </a:solidFill>
+                      <a:prstDash val="solid"/>
+                      <a:round/>
+                      <a:headEnd type="none" w="med" len="med"/>
+                      <a:tailEnd type="none" w="med" len="med"/>
+                    </a:lnL>
+                    <a:lnR w="6350" cap="flat" cmpd="sng" algn="ctr">
+                      <a:solidFill>
+                        <a:schemeClr val="tx1"/>
+                      </a:solidFill>
+                      <a:prstDash val="solid"/>
+                      <a:round/>
+                      <a:headEnd type="none" w="med" len="med"/>
+                      <a:tailEnd type="none" w="med" len="med"/>
+                    </a:lnR>
+                    <a:lnT w="6350" cap="flat" cmpd="sng" algn="ctr">
+                      <a:solidFill>
+                        <a:schemeClr val="tx1"/>
+                      </a:solidFill>
+                      <a:prstDash val="solid"/>
+                      <a:round/>
+                      <a:headEnd type="none" w="med" len="med"/>
+                      <a:tailEnd type="none" w="med" len="med"/>
+                    </a:lnT>
+                    <a:lnB w="6350" cap="flat" cmpd="sng" algn="ctr">
+                      <a:solidFill>
+                        <a:schemeClr val="tx1"/>
+                      </a:solidFill>
+                      <a:prstDash val="solid"/>
+                      <a:round/>
+                      <a:headEnd type="none" w="med" len="med"/>
+                      <a:tailEnd type="none" w="med" len="med"/>
+                    </a:lnB>
+                    <a:lnTlToBr w="12700" cmpd="sng">
+                      <a:noFill/>
+                      <a:prstDash val="solid"/>
+                    </a:lnTlToBr>
+                    <a:lnBlToTr w="12700" cmpd="sng">
+                      <a:noFill/>
+                      <a:prstDash val="solid"/>
+                    </a:lnBlToTr>
+                    <a:solidFill>
+                      <a:schemeClr val="accent5">
+                        <a:lumMod val="20000"/>
+                        <a:lumOff val="80000"/>
+                      </a:schemeClr>
+                    </a:solidFill>
+                  </a:tcPr>
+                </a:tc>
+                <a:extLst>
+                  <a:ext uri="{0D108BD9-81ED-4DB2-BD59-A6C34878D82A}">
+                    <a16:rowId xmlns:a16="http://schemas.microsoft.com/office/drawing/2014/main" val="25355368"/>
+                  </a:ext>
+                </a:extLst>
+              </a:tr>
+            </a:tbl>
+          </a:graphicData>
+        </a:graphic>
+      </p:graphicFrame>
       <p:sp>
         <p:nvSpPr>
           <p:cNvPr id="6" name="Right Arrow 5"/>
@@ -17762,15 +17572,7 @@
           <a:p>
             <a:r>
               <a:rPr lang="en-US" sz="2000" dirty="0"/>
-              <a:t>Write list of strings </a:t>
-            </a:r>
-            <a:r>
-              <a:rPr lang="en-US" sz="2000" dirty="0" err="1"/>
-              <a:t>strings</a:t>
-            </a:r>
-            <a:r>
-              <a:rPr lang="en-US" sz="2000" dirty="0"/>
-              <a:t>:</a:t>
+              <a:t>Write list of strings :</a:t>
             </a:r>
             <a:br>
               <a:rPr lang="en-US" sz="2000" dirty="0"/>
@@ -17791,7 +17593,7 @@
                 <a:latin typeface="Courier New" panose="02070309020205020404" pitchFamily="49" charset="0"/>
                 <a:cs typeface="Courier New" panose="02070309020205020404" pitchFamily="49" charset="0"/>
               </a:rPr>
-              <a:t>.writeline</a:t>
+              <a:t>.writelines</a:t>
             </a:r>
             <a:r>
               <a:rPr lang="en-US" sz="2000" dirty="0">

</xml_diff>

<commit_message>
exercises.html all-slides-with-answers.pdf all-slides.pdf code.zip exceptions.pdf exceptions.pptx
</commit_message>
<xml_diff>
--- a/ipsa/slides/exceptions.pptx
+++ b/ipsa/slides/exceptions.pptx
@@ -147,7 +147,7 @@
 <file path=ppt/revisionInfo.xml><?xml version="1.0" encoding="utf-8"?>
 <p1510:revInfo xmlns:a="http://schemas.openxmlformats.org/drawingml/2006/main" xmlns:r="http://schemas.openxmlformats.org/officeDocument/2006/relationships" xmlns:p1510="http://schemas.microsoft.com/office/powerpoint/2015/10/main">
   <p1510:revLst>
-    <p1510:client id="{E38F93A8-4FA1-49BC-B109-DD14B9BCDAB8}" v="3" dt="2026-03-09T05:33:46.945"/>
+    <p1510:client id="{E38F93A8-4FA1-49BC-B109-DD14B9BCDAB8}" v="10" dt="2026-03-09T08:00:38.716"/>
   </p1510:revLst>
 </p1510:revInfo>
 </file>
@@ -157,7 +157,7 @@
   <pc:docChgLst>
     <pc:chgData name="Gerth Stølting Brodal" userId="04ef4784-6591-4f86-a140-f5c3b108582a" providerId="ADAL" clId="{73BAC7D6-516A-44B5-B4B0-C7B08CA8B392}"/>
     <pc:docChg chg="undo custSel modSld">
-      <pc:chgData name="Gerth Stølting Brodal" userId="04ef4784-6591-4f86-a140-f5c3b108582a" providerId="ADAL" clId="{73BAC7D6-516A-44B5-B4B0-C7B08CA8B392}" dt="2026-03-09T06:25:56.526" v="307" actId="20577"/>
+      <pc:chgData name="Gerth Stølting Brodal" userId="04ef4784-6591-4f86-a140-f5c3b108582a" providerId="ADAL" clId="{73BAC7D6-516A-44B5-B4B0-C7B08CA8B392}" dt="2026-03-09T08:03:57.909" v="396" actId="313"/>
       <pc:docMkLst>
         <pc:docMk/>
       </pc:docMkLst>
@@ -182,6 +182,37 @@
           <pc:docMk/>
           <pc:sldMk cId="1654434957" sldId="704"/>
         </pc:sldMkLst>
+      </pc:sldChg>
+      <pc:sldChg chg="modSp mod">
+        <pc:chgData name="Gerth Stølting Brodal" userId="04ef4784-6591-4f86-a140-f5c3b108582a" providerId="ADAL" clId="{73BAC7D6-516A-44B5-B4B0-C7B08CA8B392}" dt="2026-03-09T08:03:57.909" v="396" actId="313"/>
+        <pc:sldMkLst>
+          <pc:docMk/>
+          <pc:sldMk cId="753419617" sldId="707"/>
+        </pc:sldMkLst>
+        <pc:spChg chg="mod">
+          <ac:chgData name="Gerth Stølting Brodal" userId="04ef4784-6591-4f86-a140-f5c3b108582a" providerId="ADAL" clId="{73BAC7D6-516A-44B5-B4B0-C7B08CA8B392}" dt="2026-03-09T08:01:08.341" v="379" actId="1036"/>
+          <ac:spMkLst>
+            <pc:docMk/>
+            <pc:sldMk cId="753419617" sldId="707"/>
+            <ac:spMk id="2" creationId="{00000000-0000-0000-0000-000000000000}"/>
+          </ac:spMkLst>
+        </pc:spChg>
+        <pc:spChg chg="mod">
+          <ac:chgData name="Gerth Stølting Brodal" userId="04ef4784-6591-4f86-a140-f5c3b108582a" providerId="ADAL" clId="{73BAC7D6-516A-44B5-B4B0-C7B08CA8B392}" dt="2026-03-09T08:03:48.396" v="392" actId="1038"/>
+          <ac:spMkLst>
+            <pc:docMk/>
+            <pc:sldMk cId="753419617" sldId="707"/>
+            <ac:spMk id="5" creationId="{00000000-0000-0000-0000-000000000000}"/>
+          </ac:spMkLst>
+        </pc:spChg>
+        <pc:graphicFrameChg chg="mod modGraphic">
+          <ac:chgData name="Gerth Stølting Brodal" userId="04ef4784-6591-4f86-a140-f5c3b108582a" providerId="ADAL" clId="{73BAC7D6-516A-44B5-B4B0-C7B08CA8B392}" dt="2026-03-09T08:03:57.909" v="396" actId="313"/>
+          <ac:graphicFrameMkLst>
+            <pc:docMk/>
+            <pc:sldMk cId="753419617" sldId="707"/>
+            <ac:graphicFrameMk id="4" creationId="{00000000-0000-0000-0000-000000000000}"/>
+          </ac:graphicFrameMkLst>
+        </pc:graphicFrameChg>
       </pc:sldChg>
       <pc:sldChg chg="modSp mod modNotesTx">
         <pc:chgData name="Gerth Stølting Brodal" userId="04ef4784-6591-4f86-a140-f5c3b108582a" providerId="ADAL" clId="{73BAC7D6-516A-44B5-B4B0-C7B08CA8B392}" dt="2026-03-09T05:52:17.894" v="71" actId="313"/>
@@ -40282,7 +40313,12 @@
             <p:ph type="title"/>
           </p:nvPr>
         </p:nvSpPr>
-        <p:spPr/>
+        <p:spPr>
+          <a:xfrm>
+            <a:off x="838200" y="-73285"/>
+            <a:ext cx="10515600" cy="1325563"/>
+          </a:xfrm>
+        </p:spPr>
         <p:txBody>
           <a:bodyPr/>
           <a:lstStyle/>
@@ -40324,14 +40360,14 @@
           <p:nvPr>
             <p:extLst>
               <p:ext uri="{D42A27DB-BD31-4B8C-83A1-F6EECF244321}">
-                <p14:modId xmlns:p14="http://schemas.microsoft.com/office/powerpoint/2010/main" val="3494574842"/>
+                <p14:modId xmlns:p14="http://schemas.microsoft.com/office/powerpoint/2010/main" val="3167713975"/>
               </p:ext>
             </p:extLst>
           </p:nvPr>
         </p:nvGraphicFramePr>
         <p:xfrm>
-          <a:off x="1805652" y="1432085"/>
-          <a:ext cx="9057005" cy="5242560"/>
+          <a:off x="1805652" y="993675"/>
+          <a:ext cx="9057005" cy="5730240"/>
         </p:xfrm>
         <a:graphic>
           <a:graphicData uri="http://schemas.openxmlformats.org/drawingml/2006/table">
@@ -40476,16 +40512,12 @@
                     </a:p>
                     <a:p>
                       <a:r>
-                        <a:rPr lang="pt-BR" sz="1600" b="1">
+                        <a:rPr lang="pt-BR" sz="1600" b="1" dirty="0">
                           <a:latin typeface="Courier New" panose="02070309020205020404" pitchFamily="49" charset="0"/>
                           <a:cs typeface="Courier New" panose="02070309020205020404" pitchFamily="49" charset="0"/>
                         </a:rPr>
                         <a:t>        print(f'{numerator} / {denominator} = {result}')</a:t>
                       </a:r>
-                      <a:endParaRPr lang="pt-BR" sz="1600" b="1" dirty="0">
-                        <a:latin typeface="Courier New" panose="02070309020205020404" pitchFamily="49" charset="0"/>
-                        <a:cs typeface="Courier New" panose="02070309020205020404" pitchFamily="49" charset="0"/>
-                      </a:endParaRPr>
                     </a:p>
                     <a:p>
                       <a:r>
@@ -40512,7 +40544,7 @@
                           <a:latin typeface="Courier New" panose="02070309020205020404" pitchFamily="49" charset="0"/>
                           <a:cs typeface="Courier New" panose="02070309020205020404" pitchFamily="49" charset="0"/>
                         </a:rPr>
-                        <a:t>        print('input not a valid integer')</a:t>
+                        <a:t>        print('input not a valid integer’)</a:t>
                       </a:r>
                     </a:p>
                     <a:p>
@@ -40540,7 +40572,59 @@
                           <a:latin typeface="Courier New" panose="02070309020205020404" pitchFamily="49" charset="0"/>
                           <a:cs typeface="Courier New" panose="02070309020205020404" pitchFamily="49" charset="0"/>
                         </a:rPr>
-                        <a:t>        print('cannot divide by zero')</a:t>
+                        <a:t>        print('cannot divide by zero’)</a:t>
+                      </a:r>
+                    </a:p>
+                    <a:p>
+                      <a:r>
+                        <a:rPr lang="pt-BR" sz="1600" b="1" dirty="0">
+                          <a:solidFill>
+                            <a:schemeClr val="accent1">
+                              <a:lumMod val="50000"/>
+                            </a:schemeClr>
+                          </a:solidFill>
+                          <a:latin typeface="Courier New" panose="02070309020205020404" pitchFamily="49" charset="0"/>
+                          <a:cs typeface="Courier New" panose="02070309020205020404" pitchFamily="49" charset="0"/>
+                        </a:rPr>
+                        <a:t>    except OverflowError:</a:t>
+                      </a:r>
+                    </a:p>
+                    <a:p>
+                      <a:r>
+                        <a:rPr lang="pt-BR" sz="1600" b="1" dirty="0">
+                          <a:solidFill>
+                            <a:schemeClr val="accent1">
+                              <a:lumMod val="50000"/>
+                            </a:schemeClr>
+                          </a:solidFill>
+                          <a:latin typeface="Courier New" panose="02070309020205020404" pitchFamily="49" charset="0"/>
+                          <a:cs typeface="Courier New" panose="02070309020205020404" pitchFamily="49" charset="0"/>
+                        </a:rPr>
+                        <a:t>        </a:t>
+                      </a:r>
+                      <a:r>
+                        <a:rPr lang="pt-BR" sz="1600" b="1">
+                          <a:solidFill>
+                            <a:schemeClr val="accent1">
+                              <a:lumMod val="50000"/>
+                            </a:schemeClr>
+                          </a:solidFill>
+                          <a:latin typeface="Courier New" panose="02070309020205020404" pitchFamily="49" charset="0"/>
+                          <a:cs typeface="Courier New" panose="02070309020205020404" pitchFamily="49" charset="0"/>
+                        </a:rPr>
+                        <a:t>print('overflow</a:t>
+                      </a:r>
+                      <a:r>
+                        <a:rPr lang="pt-BR" sz="1600" b="1" dirty="0">
+                          <a:solidFill>
+                            <a:schemeClr val="accent1">
+                              <a:lumMod val="50000"/>
+                            </a:schemeClr>
+                          </a:solidFill>
+                          <a:latin typeface="Courier New" panose="02070309020205020404" pitchFamily="49" charset="0"/>
+                          <a:cs typeface="Courier New" panose="02070309020205020404" pitchFamily="49" charset="0"/>
+                        </a:rPr>
+                        <a:t>')</a:t>
                       </a:r>
                     </a:p>
                   </a:txBody>
@@ -40933,7 +41017,7 @@
         </p:nvSpPr>
         <p:spPr>
           <a:xfrm>
-            <a:off x="370390" y="2999286"/>
+            <a:off x="114702" y="2347934"/>
             <a:ext cx="1597308" cy="1291472"/>
           </a:xfrm>
           <a:prstGeom prst="rightArrow">

</xml_diff>